<commit_message>
Office fidelity, font handling and packaging verification
Squash 6 consecutive development commits, retaining the original ending snapshot.

- Match Word's pagination and line layout, draw PPTX connectors, order LTR runs in RTL text
- Select delivered fonts through an alias, calibrate Arabic substitutes, wait for fonts before measuring
- Bench Extend, apollo and pptx-browser; record measured findings in the competitor survey
- Read PPTX autofit and bullets as PowerPoint stores them, add Aptos and lazy font delivery, then freeze aared-fonts
- Place DOCX pictures as Word wraps them, close the PPTX fidelity pass, split open gaps from accepted limits
- Type every error by whose fault it is, prove webpack and Next.js consumers, report navigation failures on every embed layer
</commit_message>
<xml_diff>
--- a/fixtures/pptx-coverage.pptx
+++ b/fixtures/pptx-coverage.pptx
@@ -5,7 +5,7 @@
     <p:sldMasterId id="2147483648" r:id="rId1"/>
   </p:sldMasterIdLst>
   <p:notesMasterIdLst>
-    <p:notesMasterId r:id="rId12"/>
+    <p:notesMasterId r:id="rId14"/>
   </p:notesMasterIdLst>
   <p:sldIdLst>
     <p:sldId id="256" r:id="rId2"/>
@@ -18,6 +18,8 @@
     <p:sldId id="263" r:id="rId9"/>
     <p:sldId id="264" r:id="rId10"/>
     <p:sldId id="265" r:id="rId11"/>
+    <p:sldId id="266" r:id="rId12"/>
+    <p:sldId id="267" r:id="rId13"/>
   </p:sldIdLst>
   <p:sldSz cx="12192000" cy="6858000"/>
   <p:notesSz cx="6858000" cy="9144000"/>
@@ -442,7 +444,7 @@
           <a:p>
             <a:fld id="{86A64A56-4393-4CB6-85C6-C90BB7A8548C}" type="datetimeFigureOut">
               <a:rPr lang="en-US" smtClean="0"/>
-              <a:t>9/23/2026</a:t>
+              <a:t>9/28/2026</a:t>
             </a:fld>
             <a:endParaRPr lang="en-US"/>
           </a:p>
@@ -856,7 +858,7 @@
           <a:p>
             <a:fld id="{60541A7F-F981-4501-AAE0-06F6CB326412}" type="datetime1">
               <a:rPr lang="en-US" smtClean="0"/>
-              <a:t>9/23/2026</a:t>
+              <a:t>9/28/2026</a:t>
             </a:fld>
             <a:endParaRPr lang="en-US"/>
           </a:p>
@@ -1054,7 +1056,7 @@
           <a:p>
             <a:fld id="{F853943D-1B76-47AC-8196-C4B25463BF47}" type="datetime1">
               <a:rPr lang="en-US" smtClean="0"/>
-              <a:t>9/23/2026</a:t>
+              <a:t>9/28/2026</a:t>
             </a:fld>
             <a:endParaRPr lang="en-US"/>
           </a:p>
@@ -1262,7 +1264,7 @@
           <a:p>
             <a:fld id="{2E188C43-274A-49F7-9E8E-741661AA3B8D}" type="datetime1">
               <a:rPr lang="en-US" smtClean="0"/>
-              <a:t>9/23/2026</a:t>
+              <a:t>9/28/2026</a:t>
             </a:fld>
             <a:endParaRPr lang="en-US"/>
           </a:p>
@@ -1460,7 +1462,7 @@
           <a:p>
             <a:fld id="{AFE56759-6820-42B3-B9BE-972720AE0218}" type="datetime1">
               <a:rPr lang="en-US" smtClean="0"/>
-              <a:t>9/23/2026</a:t>
+              <a:t>9/28/2026</a:t>
             </a:fld>
             <a:endParaRPr lang="en-US"/>
           </a:p>
@@ -1735,7 +1737,7 @@
           <a:p>
             <a:fld id="{E60A5D86-3AF6-469E-9631-8585AF639EE9}" type="datetime1">
               <a:rPr lang="en-US" smtClean="0"/>
-              <a:t>9/23/2026</a:t>
+              <a:t>9/28/2026</a:t>
             </a:fld>
             <a:endParaRPr lang="en-US"/>
           </a:p>
@@ -2000,7 +2002,7 @@
           <a:p>
             <a:fld id="{7040F516-D53A-4B36-A577-E8486E25D0EC}" type="datetime1">
               <a:rPr lang="en-US" smtClean="0"/>
-              <a:t>9/23/2026</a:t>
+              <a:t>9/28/2026</a:t>
             </a:fld>
             <a:endParaRPr lang="en-US"/>
           </a:p>
@@ -2412,7 +2414,7 @@
           <a:p>
             <a:fld id="{3E6E30B0-F99E-4FCA-83EF-31E10F2B66B1}" type="datetime1">
               <a:rPr lang="en-US" smtClean="0"/>
-              <a:t>9/23/2026</a:t>
+              <a:t>9/28/2026</a:t>
             </a:fld>
             <a:endParaRPr lang="en-US"/>
           </a:p>
@@ -2553,7 +2555,7 @@
           <a:p>
             <a:fld id="{FF185E36-5297-403D-B499-FD865F8C5A4F}" type="datetime1">
               <a:rPr lang="en-US" smtClean="0"/>
-              <a:t>9/23/2026</a:t>
+              <a:t>9/28/2026</a:t>
             </a:fld>
             <a:endParaRPr lang="en-US"/>
           </a:p>
@@ -2666,7 +2668,7 @@
           <a:p>
             <a:fld id="{2CDF4417-72BA-4D8F-8104-BFB5B423E2DD}" type="datetime1">
               <a:rPr lang="en-US" smtClean="0"/>
-              <a:t>9/23/2026</a:t>
+              <a:t>9/28/2026</a:t>
             </a:fld>
             <a:endParaRPr lang="en-US"/>
           </a:p>
@@ -2977,7 +2979,7 @@
           <a:p>
             <a:fld id="{C30CC0FA-F1D1-458D-9491-18A8D18048F7}" type="datetime1">
               <a:rPr lang="en-US" smtClean="0"/>
-              <a:t>9/23/2026</a:t>
+              <a:t>9/28/2026</a:t>
             </a:fld>
             <a:endParaRPr lang="en-US"/>
           </a:p>
@@ -3265,7 +3267,7 @@
           <a:p>
             <a:fld id="{66BF3E84-4616-4F9E-891F-D3C933FF2937}" type="datetime1">
               <a:rPr lang="en-US" smtClean="0"/>
-              <a:t>9/23/2026</a:t>
+              <a:t>9/28/2026</a:t>
             </a:fld>
             <a:endParaRPr lang="en-US"/>
           </a:p>
@@ -3506,7 +3508,7 @@
           <a:p>
             <a:fld id="{350CAA63-4269-45C0-A8A2-D62AE2EC413F}" type="datetime1">
               <a:rPr lang="en-US" smtClean="0"/>
-              <a:t>9/23/2026</a:t>
+              <a:t>9/28/2026</a:t>
             </a:fld>
             <a:endParaRPr lang="en-US"/>
           </a:p>
@@ -4549,6 +4551,640 @@
     <p:extLst>
       <p:ext uri="{BB962C8B-B14F-4D97-AF65-F5344CB8AC3E}">
         <p14:creationId xmlns:p14="http://schemas.microsoft.com/office/powerpoint/2010/main" val="3906041817"/>
+      </p:ext>
+    </p:extLst>
+  </p:cSld>
+  <p:clrMapOvr>
+    <a:masterClrMapping/>
+  </p:clrMapOvr>
+</p:sld>
+</file>
+
+<file path=ppt/slides/slide11.xml><?xml version="1.0" encoding="utf-8"?>
+<p:sld xmlns:a="http://schemas.openxmlformats.org/drawingml/2006/main" xmlns:r="http://schemas.openxmlformats.org/officeDocument/2006/relationships" xmlns:p="http://schemas.openxmlformats.org/presentationml/2006/main">
+  <p:cSld>
+    <p:spTree>
+      <p:nvGrpSpPr>
+        <p:cNvPr id="1" name=""/>
+        <p:cNvGrpSpPr/>
+        <p:nvPr/>
+      </p:nvGrpSpPr>
+      <p:grpSpPr>
+        <a:xfrm>
+          <a:off x="0" y="0"/>
+          <a:ext cx="0" cy="0"/>
+          <a:chOff x="0" y="0"/>
+          <a:chExt cx="0" cy="0"/>
+        </a:xfrm>
+      </p:grpSpPr>
+      <p:sp>
+        <p:nvSpPr>
+          <p:cNvPr id="4" name="Slide Number Placeholder 3">
+            <a:extLst>
+              <a:ext uri="{FF2B5EF4-FFF2-40B4-BE49-F238E27FC236}">
+                <a16:creationId xmlns:a16="http://schemas.microsoft.com/office/drawing/2014/main" id="{7CF73C67-6A8A-5856-CE07-81FF7A124167}"/>
+              </a:ext>
+            </a:extLst>
+          </p:cNvPr>
+          <p:cNvSpPr>
+            <a:spLocks noGrp="1"/>
+          </p:cNvSpPr>
+          <p:nvPr>
+            <p:ph type="sldNum" sz="quarter" idx="12"/>
+          </p:nvPr>
+        </p:nvSpPr>
+        <p:spPr/>
+        <p:txBody>
+          <a:bodyPr/>
+          <a:lstStyle/>
+          <a:p>
+            <a:fld id="{DCB96425-C66E-449F-8335-3FF27AC80FA3}" type="slidenum">
+              <a:rPr lang="en-US" smtClean="0"/>
+              <a:t>11</a:t>
+            </a:fld>
+            <a:endParaRPr lang="en-US"/>
+          </a:p>
+        </p:txBody>
+      </p:sp>
+      <p:sp>
+        <p:nvSpPr>
+          <p:cNvPr id="5" name="Title">
+            <a:extLst>
+              <a:ext uri="{FF2B5EF4-FFF2-40B4-BE49-F238E27FC236}">
+                <a16:creationId xmlns:a16="http://schemas.microsoft.com/office/drawing/2014/main" id="{34958500-4107-66AD-9E57-FD96394F86E1}"/>
+              </a:ext>
+            </a:extLst>
+          </p:cNvPr>
+          <p:cNvSpPr txBox="1"/>
+          <p:nvPr/>
+        </p:nvSpPr>
+        <p:spPr>
+          <a:xfrm>
+            <a:off x="0" y="304800"/>
+            <a:ext cx="12192000" cy="523220"/>
+          </a:xfrm>
+          <a:prstGeom prst="rect">
+            <a:avLst/>
+          </a:prstGeom>
+          <a:noFill/>
+        </p:spPr>
+        <p:txBody>
+          <a:bodyPr vert="horz" rtlCol="0">
+            <a:spAutoFit/>
+          </a:bodyPr>
+          <a:lstStyle/>
+          <a:p>
+            <a:pPr algn="ctr" rtl="1"/>
+            <a:r>
+              <a:rPr lang="ar-EG" sz="2800"/>
+              <a:t>خطوط وموصلات</a:t>
+            </a:r>
+            <a:endParaRPr lang="en-US" sz="2800"/>
+          </a:p>
+        </p:txBody>
+      </p:sp>
+      <p:cxnSp>
+        <p:nvCxnSpPr>
+          <p:cNvPr id="2" name="Timeline">
+            <a:extLst>
+              <a:ext uri="{FF2B5EF4-FFF2-40B4-BE49-F238E27FC236}">
+                <a16:creationId xmlns:a16="http://schemas.microsoft.com/office/drawing/2014/main" id="{80F9A06E-CA69-73C9-E91F-A3BB40E102E1}"/>
+              </a:ext>
+            </a:extLst>
+          </p:cNvPr>
+          <p:cNvCxnSpPr/>
+          <p:nvPr/>
+        </p:nvCxnSpPr>
+        <p:spPr>
+          <a:xfrm>
+            <a:off x="1016000" y="3048000"/>
+            <a:ext cx="10160000" cy="0"/>
+          </a:xfrm>
+          <a:prstGeom prst="straightConnector1">
+            <a:avLst/>
+          </a:prstGeom>
+          <a:ln w="25400">
+            <a:solidFill>
+              <a:srgbClr val="1E3A5A"/>
+            </a:solidFill>
+          </a:ln>
+        </p:spPr>
+        <p:style>
+          <a:lnRef idx="2">
+            <a:schemeClr val="accent1"/>
+          </a:lnRef>
+          <a:fillRef idx="0">
+            <a:schemeClr val="accent1"/>
+          </a:fillRef>
+          <a:effectRef idx="1">
+            <a:schemeClr val="accent1"/>
+          </a:effectRef>
+          <a:fontRef idx="minor">
+            <a:schemeClr val="tx1"/>
+          </a:fontRef>
+        </p:style>
+      </p:cxnSp>
+      <p:cxnSp>
+        <p:nvCxnSpPr>
+          <p:cNvPr id="3" name="Today">
+            <a:extLst>
+              <a:ext uri="{FF2B5EF4-FFF2-40B4-BE49-F238E27FC236}">
+                <a16:creationId xmlns:a16="http://schemas.microsoft.com/office/drawing/2014/main" id="{38BE034F-34A4-5316-2EA3-7211F6C949CB}"/>
+              </a:ext>
+            </a:extLst>
+          </p:cNvPr>
+          <p:cNvCxnSpPr/>
+          <p:nvPr/>
+        </p:nvCxnSpPr>
+        <p:spPr>
+          <a:xfrm>
+            <a:off x="6096000" y="1524000"/>
+            <a:ext cx="0" cy="3556000"/>
+          </a:xfrm>
+          <a:prstGeom prst="line">
+            <a:avLst/>
+          </a:prstGeom>
+          <a:ln w="19050">
+            <a:solidFill>
+              <a:srgbClr val="F59B1E"/>
+            </a:solidFill>
+            <a:prstDash val="dash"/>
+          </a:ln>
+        </p:spPr>
+        <p:style>
+          <a:lnRef idx="2">
+            <a:schemeClr val="accent1"/>
+          </a:lnRef>
+          <a:fillRef idx="0">
+            <a:schemeClr val="accent1"/>
+          </a:fillRef>
+          <a:effectRef idx="1">
+            <a:schemeClr val="accent1"/>
+          </a:effectRef>
+          <a:fontRef idx="minor">
+            <a:schemeClr val="tx1"/>
+          </a:fontRef>
+        </p:style>
+      </p:cxnSp>
+      <p:cxnSp>
+        <p:nvCxnSpPr>
+          <p:cNvPr id="7" name="Dotted">
+            <a:extLst>
+              <a:ext uri="{FF2B5EF4-FFF2-40B4-BE49-F238E27FC236}">
+                <a16:creationId xmlns:a16="http://schemas.microsoft.com/office/drawing/2014/main" id="{412D5034-8347-C745-3BF3-8C6C630C8B7C}"/>
+              </a:ext>
+            </a:extLst>
+          </p:cNvPr>
+          <p:cNvCxnSpPr/>
+          <p:nvPr/>
+        </p:nvCxnSpPr>
+        <p:spPr>
+          <a:xfrm>
+            <a:off x="1016000" y="4064000"/>
+            <a:ext cx="10160000" cy="0"/>
+          </a:xfrm>
+          <a:prstGeom prst="line">
+            <a:avLst/>
+          </a:prstGeom>
+          <a:ln w="12700" cap="rnd">
+            <a:solidFill>
+              <a:srgbClr val="808F9C"/>
+            </a:solidFill>
+            <a:prstDash val="dot"/>
+          </a:ln>
+        </p:spPr>
+        <p:style>
+          <a:lnRef idx="2">
+            <a:schemeClr val="accent1"/>
+          </a:lnRef>
+          <a:fillRef idx="0">
+            <a:schemeClr val="accent1"/>
+          </a:fillRef>
+          <a:effectRef idx="1">
+            <a:schemeClr val="accent1"/>
+          </a:effectRef>
+          <a:fontRef idx="minor">
+            <a:schemeClr val="tx1"/>
+          </a:fontRef>
+        </p:style>
+      </p:cxnSp>
+      <p:cxnSp>
+        <p:nvCxnSpPr>
+          <p:cNvPr id="8" name="Diagonal">
+            <a:extLst>
+              <a:ext uri="{FF2B5EF4-FFF2-40B4-BE49-F238E27FC236}">
+                <a16:creationId xmlns:a16="http://schemas.microsoft.com/office/drawing/2014/main" id="{8B7729AA-FB6D-E4A4-46F6-92C2F5137AA6}"/>
+              </a:ext>
+            </a:extLst>
+          </p:cNvPr>
+          <p:cNvCxnSpPr/>
+          <p:nvPr/>
+        </p:nvCxnSpPr>
+        <p:spPr>
+          <a:xfrm flipV="1">
+            <a:off x="1016000" y="4826000"/>
+            <a:ext cx="2540000" cy="1016000"/>
+          </a:xfrm>
+          <a:prstGeom prst="line">
+            <a:avLst/>
+          </a:prstGeom>
+          <a:ln w="38100">
+            <a:solidFill>
+              <a:srgbClr val="1E3A5A"/>
+            </a:solidFill>
+          </a:ln>
+        </p:spPr>
+        <p:style>
+          <a:lnRef idx="2">
+            <a:schemeClr val="accent1"/>
+          </a:lnRef>
+          <a:fillRef idx="0">
+            <a:schemeClr val="accent1"/>
+          </a:fillRef>
+          <a:effectRef idx="1">
+            <a:schemeClr val="accent1"/>
+          </a:effectRef>
+          <a:fontRef idx="minor">
+            <a:schemeClr val="tx1"/>
+          </a:fontRef>
+        </p:style>
+      </p:cxnSp>
+      <p:sp>
+        <p:nvSpPr>
+          <p:cNvPr id="6" name="Mixed direction">
+            <a:extLst>
+              <a:ext uri="{FF2B5EF4-FFF2-40B4-BE49-F238E27FC236}">
+                <a16:creationId xmlns:a16="http://schemas.microsoft.com/office/drawing/2014/main" id="{4F49EAE7-3274-8F51-B7EE-B613C7B2FE13}"/>
+              </a:ext>
+            </a:extLst>
+          </p:cNvPr>
+          <p:cNvSpPr txBox="1"/>
+          <p:nvPr/>
+        </p:nvSpPr>
+        <p:spPr>
+          <a:xfrm>
+            <a:off x="1016000" y="5969000"/>
+            <a:ext cx="10160000" cy="449097"/>
+          </a:xfrm>
+          <a:prstGeom prst="rect">
+            <a:avLst/>
+          </a:prstGeom>
+          <a:noFill/>
+        </p:spPr>
+        <p:txBody>
+          <a:bodyPr vert="horz" rtlCol="0">
+            <a:spAutoFit/>
+          </a:bodyPr>
+          <a:lstStyle/>
+          <a:p>
+            <a:pPr algn="r" rtl="1">
+              <a:lnSpc>
+                <a:spcPts val="3000"/>
+              </a:lnSpc>
+            </a:pPr>
+            <a:r>
+              <a:rPr lang="ar-SA" sz="2000"/>
+              <a:t>الإيرادات دون الموازنة بنسبة </a:t>
+            </a:r>
+            <a:r>
+              <a:rPr lang="en-US" sz="2000">
+                <a:latin typeface="Calibri" panose="020F0502020204030204" pitchFamily="34" charset="0"/>
+              </a:rPr>
+              <a:t>2.1%</a:t>
+            </a:r>
+            <a:endParaRPr lang="en-US" sz="2000" dirty="0">
+              <a:latin typeface="Calibri" panose="020F0502020204030204" pitchFamily="34" charset="0"/>
+            </a:endParaRPr>
+          </a:p>
+        </p:txBody>
+      </p:sp>
+    </p:spTree>
+    <p:extLst>
+      <p:ext uri="{BB962C8B-B14F-4D97-AF65-F5344CB8AC3E}">
+        <p14:creationId xmlns:p14="http://schemas.microsoft.com/office/powerpoint/2010/main" val="3578241439"/>
+      </p:ext>
+    </p:extLst>
+  </p:cSld>
+  <p:clrMapOvr>
+    <a:masterClrMapping/>
+  </p:clrMapOvr>
+</p:sld>
+</file>
+
+<file path=ppt/slides/slide12.xml><?xml version="1.0" encoding="utf-8"?>
+<p:sld xmlns:a="http://schemas.openxmlformats.org/drawingml/2006/main" xmlns:r="http://schemas.openxmlformats.org/officeDocument/2006/relationships" xmlns:p="http://schemas.openxmlformats.org/presentationml/2006/main">
+  <p:cSld>
+    <p:spTree>
+      <p:nvGrpSpPr>
+        <p:cNvPr id="1" name=""/>
+        <p:cNvGrpSpPr/>
+        <p:nvPr/>
+      </p:nvGrpSpPr>
+      <p:grpSpPr>
+        <a:xfrm>
+          <a:off x="0" y="0"/>
+          <a:ext cx="0" cy="0"/>
+          <a:chOff x="0" y="0"/>
+          <a:chExt cx="0" cy="0"/>
+        </a:xfrm>
+      </p:grpSpPr>
+      <p:sp>
+        <p:nvSpPr>
+          <p:cNvPr id="4" name="Slide Number Placeholder 3">
+            <a:extLst>
+              <a:ext uri="{FF2B5EF4-FFF2-40B4-BE49-F238E27FC236}">
+                <a16:creationId xmlns:a16="http://schemas.microsoft.com/office/drawing/2014/main" id="{7CF73C67-6A8A-5856-CE07-81FF7A124167}"/>
+              </a:ext>
+            </a:extLst>
+          </p:cNvPr>
+          <p:cNvSpPr>
+            <a:spLocks noGrp="1"/>
+          </p:cNvSpPr>
+          <p:nvPr>
+            <p:ph type="sldNum" sz="quarter" idx="12"/>
+          </p:nvPr>
+        </p:nvSpPr>
+        <p:spPr/>
+        <p:txBody>
+          <a:bodyPr/>
+          <a:lstStyle/>
+          <a:p>
+            <a:fld id="{DCB96425-C66E-449F-8335-3FF27AC80FA3}" type="slidenum">
+              <a:rPr lang="en-US" smtClean="0"/>
+              <a:t>12</a:t>
+            </a:fld>
+            <a:endParaRPr lang="en-US"/>
+          </a:p>
+        </p:txBody>
+      </p:sp>
+      <p:sp>
+        <p:nvSpPr>
+          <p:cNvPr id="5" name="Title">
+            <a:extLst>
+              <a:ext uri="{FF2B5EF4-FFF2-40B4-BE49-F238E27FC236}">
+                <a16:creationId xmlns:a16="http://schemas.microsoft.com/office/drawing/2014/main" id="{34958500-4107-66AD-9E57-FD96394F86E1}"/>
+              </a:ext>
+            </a:extLst>
+          </p:cNvPr>
+          <p:cNvSpPr txBox="1"/>
+          <p:nvPr/>
+        </p:nvSpPr>
+        <p:spPr>
+          <a:xfrm>
+            <a:off x="0" y="304800"/>
+            <a:ext cx="12192000" cy="523220"/>
+          </a:xfrm>
+          <a:prstGeom prst="rect">
+            <a:avLst/>
+          </a:prstGeom>
+          <a:noFill/>
+        </p:spPr>
+        <p:txBody>
+          <a:bodyPr vert="horz" rtlCol="0">
+            <a:spAutoFit/>
+          </a:bodyPr>
+          <a:lstStyle/>
+          <a:p>
+            <a:pPr algn="ctr" rtl="1"/>
+            <a:r>
+              <a:rPr lang="ar-EG" sz="2800"/>
+              <a:t>تباعد الفقرات</a:t>
+            </a:r>
+            <a:endParaRPr lang="en-US" sz="2800"/>
+          </a:p>
+        </p:txBody>
+      </p:sp>
+      <p:sp>
+        <p:nvSpPr>
+          <p:cNvPr id="9" name="Spacing in lines">
+            <a:extLst>
+              <a:ext uri="{FF2B5EF4-FFF2-40B4-BE49-F238E27FC236}">
+                <a16:creationId xmlns:a16="http://schemas.microsoft.com/office/drawing/2014/main" id="{32992895-2F7F-841E-A74A-8486F4DE5FDE}"/>
+              </a:ext>
+            </a:extLst>
+          </p:cNvPr>
+          <p:cNvSpPr txBox="1"/>
+          <p:nvPr/>
+        </p:nvSpPr>
+        <p:spPr>
+          <a:xfrm>
+            <a:off x="5080000" y="1524000"/>
+            <a:ext cx="6096000" cy="4826000"/>
+          </a:xfrm>
+          <a:prstGeom prst="rect">
+            <a:avLst/>
+          </a:prstGeom>
+          <a:noFill/>
+        </p:spPr>
+        <p:txBody>
+          <a:bodyPr vert="horz" rtlCol="0" anchor="t">
+            <a:noAutofit/>
+          </a:bodyPr>
+          <a:lstStyle/>
+          <a:p>
+            <a:pPr algn="r" rtl="1">
+              <a:spcBef>
+                <a:spcPct val="100000"/>
+              </a:spcBef>
+              <a:spcAft>
+                <a:spcPct val="0"/>
+              </a:spcAft>
+            </a:pPr>
+            <a:r>
+              <a:rPr lang="ar-EG"/>
+              <a:t>الفقرة الأولى: سطر قبلها لا يظهر</a:t>
+            </a:r>
+          </a:p>
+          <a:p>
+            <a:pPr algn="r" rtl="1">
+              <a:spcBef>
+                <a:spcPct val="50000"/>
+              </a:spcBef>
+              <a:spcAft>
+                <a:spcPct val="0"/>
+              </a:spcAft>
+            </a:pPr>
+            <a:r>
+              <a:rPr lang="ar-EG"/>
+              <a:t>نصف سطر قبل هذه الفقرة</a:t>
+            </a:r>
+          </a:p>
+          <a:p>
+            <a:pPr algn="r" rtl="1">
+              <a:spcBef>
+                <a:spcPct val="100000"/>
+              </a:spcBef>
+              <a:spcAft>
+                <a:spcPct val="0"/>
+              </a:spcAft>
+            </a:pPr>
+            <a:r>
+              <a:rPr lang="ar-EG"/>
+              <a:t>سطر قبلها بحجم الكلمة </a:t>
+            </a:r>
+            <a:r>
+              <a:rPr lang="ar-EG" sz="2800"/>
+              <a:t>الأكبر</a:t>
+            </a:r>
+          </a:p>
+          <a:p>
+            <a:pPr algn="r" rtl="1">
+              <a:spcBef>
+                <a:spcPct val="0"/>
+              </a:spcBef>
+              <a:spcAft>
+                <a:spcPct val="100000"/>
+              </a:spcAft>
+            </a:pPr>
+            <a:r>
+              <a:rPr lang="ar-EG"/>
+              <a:t>سطر كامل بعد هذه الفقرة</a:t>
+            </a:r>
+          </a:p>
+          <a:p>
+            <a:pPr algn="r" rtl="1">
+              <a:spcBef>
+                <a:spcPct val="100000"/>
+              </a:spcBef>
+              <a:spcAft>
+                <a:spcPct val="0"/>
+              </a:spcAft>
+            </a:pPr>
+            <a:r>
+              <a:rPr lang="ar-EG"/>
+              <a:t>وسطر قبل هذه فيجتمعان</a:t>
+            </a:r>
+          </a:p>
+          <a:p>
+            <a:pPr algn="r" rtl="1">
+              <a:spcBef>
+                <a:spcPct val="0"/>
+              </a:spcBef>
+              <a:spcAft>
+                <a:spcPct val="100000"/>
+              </a:spcAft>
+            </a:pPr>
+            <a:r>
+              <a:rPr lang="ar-EG"/>
+              <a:t>الفقرة الأخيرة: سطر بعدها لا يظهر</a:t>
+            </a:r>
+            <a:endParaRPr lang="en-US"/>
+          </a:p>
+        </p:txBody>
+      </p:sp>
+      <p:graphicFrame>
+        <p:nvGraphicFramePr>
+          <p:cNvPr id="10" name="Spacing in a cell">
+            <a:extLst>
+              <a:ext uri="{FF2B5EF4-FFF2-40B4-BE49-F238E27FC236}">
+                <a16:creationId xmlns:a16="http://schemas.microsoft.com/office/drawing/2014/main" id="{824B5542-66C9-A9FA-1B03-15EB6CD402D1}"/>
+              </a:ext>
+            </a:extLst>
+          </p:cNvPr>
+          <p:cNvGraphicFramePr>
+            <a:graphicFrameLocks noGrp="1"/>
+          </p:cNvGraphicFramePr>
+          <p:nvPr>
+            <p:extLst>
+              <p:ext uri="{D42A27DB-BD31-4B8C-83A1-F6EECF244321}">
+                <p14:modId xmlns:p14="http://schemas.microsoft.com/office/powerpoint/2010/main" val="2608124176"/>
+              </p:ext>
+            </p:extLst>
+          </p:nvPr>
+        </p:nvGraphicFramePr>
+        <p:xfrm>
+          <a:off x="762000" y="1524000"/>
+          <a:ext cx="4318000" cy="2540000"/>
+        </p:xfrm>
+        <a:graphic>
+          <a:graphicData uri="http://schemas.openxmlformats.org/drawingml/2006/table">
+            <a:tbl>
+              <a:tblPr firstRow="1" bandRow="1">
+                <a:tableStyleId>{5C22544A-7EE6-4342-B048-85BDC9FD1C3A}</a:tableStyleId>
+              </a:tblPr>
+              <a:tblGrid>
+                <a:gridCol w="4318000">
+                  <a:extLst>
+                    <a:ext uri="{9D8B030D-6E8A-4147-A177-3AD203B41FA5}">
+                      <a16:colId xmlns:a16="http://schemas.microsoft.com/office/drawing/2014/main" val="144344866"/>
+                    </a:ext>
+                  </a:extLst>
+                </a:gridCol>
+              </a:tblGrid>
+              <a:tr h="2540000">
+                <a:tc>
+                  <a:txBody>
+                    <a:bodyPr/>
+                    <a:lstStyle/>
+                    <a:p>
+                      <a:pPr algn="r" rtl="1">
+                        <a:lnSpc>
+                          <a:spcPct val="100000"/>
+                        </a:lnSpc>
+                        <a:spcBef>
+                          <a:spcPct val="100000"/>
+                        </a:spcBef>
+                        <a:spcAft>
+                          <a:spcPct val="0"/>
+                        </a:spcAft>
+                      </a:pPr>
+                      <a:r>
+                        <a:rPr lang="ar-EG" sz="1800"/>
+                        <a:t>في الخلية: سطر قبل الأولى لا يظهر</a:t>
+                      </a:r>
+                    </a:p>
+                    <a:p>
+                      <a:pPr algn="r" rtl="1">
+                        <a:lnSpc>
+                          <a:spcPct val="100000"/>
+                        </a:lnSpc>
+                        <a:spcBef>
+                          <a:spcPct val="0"/>
+                        </a:spcBef>
+                        <a:spcAft>
+                          <a:spcPct val="50000"/>
+                        </a:spcAft>
+                      </a:pPr>
+                      <a:r>
+                        <a:rPr lang="ar-EG" sz="1800"/>
+                        <a:t>نصف سطر بعد هذه</a:t>
+                      </a:r>
+                    </a:p>
+                    <a:p>
+                      <a:pPr algn="r" rtl="1">
+                        <a:lnSpc>
+                          <a:spcPct val="100000"/>
+                        </a:lnSpc>
+                        <a:spcBef>
+                          <a:spcPct val="50000"/>
+                        </a:spcBef>
+                        <a:spcAft>
+                          <a:spcPct val="0"/>
+                        </a:spcAft>
+                      </a:pPr>
+                      <a:r>
+                        <a:rPr lang="ar-EG" sz="1800"/>
+                        <a:t>ونصف سطر قبل هذه</a:t>
+                      </a:r>
+                      <a:endParaRPr lang="en-US" sz="1800"/>
+                    </a:p>
+                  </a:txBody>
+                  <a:tcPr/>
+                </a:tc>
+                <a:extLst>
+                  <a:ext uri="{0D108BD9-81ED-4DB2-BD59-A6C34878D82A}">
+                    <a16:rowId xmlns:a16="http://schemas.microsoft.com/office/drawing/2014/main" val="1208137714"/>
+                  </a:ext>
+                </a:extLst>
+              </a:tr>
+            </a:tbl>
+          </a:graphicData>
+        </a:graphic>
+      </p:graphicFrame>
+    </p:spTree>
+    <p:extLst>
+      <p:ext uri="{BB962C8B-B14F-4D97-AF65-F5344CB8AC3E}">
+        <p14:creationId xmlns:p14="http://schemas.microsoft.com/office/powerpoint/2010/main" val="596326689"/>
       </p:ext>
     </p:extLst>
   </p:cSld>

</xml_diff>

<commit_message>
Unified viewer, search and chart engine
Squash 5 consecutive development commits, retaining the original ending snapshot.

- Run every embed layer on one viewer with toolbar methods and search, make renders cancellable, add a Start page, compact the decision log
- Read charts into a real model in the Worker and lay them out on the page, draw every chart type but surface and maps, set Arabic chart text as Office does, and bound hostile counts where files are read
- Check the chart engine's assumed rules against Office and correct them; list the chart corpora as bench samples
- Fix the review findings, warn on drawings without an id, number DOCX lists as Word does, read a second master's theme, and reorganise the roadmap
- Consolidate tools: one Office export driver, one rasterizer, standard probe shape
</commit_message>
<xml_diff>
--- a/fixtures/pptx-coverage.pptx
+++ b/fixtures/pptx-coverage.pptx
@@ -3,23 +3,30 @@
 <p:presentation xmlns:a="http://schemas.openxmlformats.org/drawingml/2006/main" xmlns:r="http://schemas.openxmlformats.org/officeDocument/2006/relationships" xmlns:p="http://schemas.openxmlformats.org/presentationml/2006/main" saveSubsetFonts="1">
   <p:sldMasterIdLst>
     <p:sldMasterId id="2147483648" r:id="rId1"/>
+    <p:sldMasterId id="2147483660" r:id="rId2"/>
   </p:sldMasterIdLst>
   <p:notesMasterIdLst>
-    <p:notesMasterId r:id="rId14"/>
+    <p:notesMasterId r:id="rId21"/>
   </p:notesMasterIdLst>
   <p:sldIdLst>
-    <p:sldId id="256" r:id="rId2"/>
-    <p:sldId id="257" r:id="rId3"/>
-    <p:sldId id="258" r:id="rId4"/>
-    <p:sldId id="259" r:id="rId5"/>
-    <p:sldId id="260" r:id="rId6"/>
-    <p:sldId id="261" r:id="rId7"/>
-    <p:sldId id="262" r:id="rId8"/>
-    <p:sldId id="263" r:id="rId9"/>
-    <p:sldId id="264" r:id="rId10"/>
-    <p:sldId id="265" r:id="rId11"/>
-    <p:sldId id="266" r:id="rId12"/>
-    <p:sldId id="267" r:id="rId13"/>
+    <p:sldId id="256" r:id="rId3"/>
+    <p:sldId id="257" r:id="rId4"/>
+    <p:sldId id="258" r:id="rId5"/>
+    <p:sldId id="259" r:id="rId6"/>
+    <p:sldId id="260" r:id="rId7"/>
+    <p:sldId id="261" r:id="rId8"/>
+    <p:sldId id="262" r:id="rId9"/>
+    <p:sldId id="263" r:id="rId10"/>
+    <p:sldId id="264" r:id="rId11"/>
+    <p:sldId id="265" r:id="rId12"/>
+    <p:sldId id="266" r:id="rId13"/>
+    <p:sldId id="267" r:id="rId14"/>
+    <p:sldId id="268" r:id="rId15"/>
+    <p:sldId id="269" r:id="rId16"/>
+    <p:sldId id="270" r:id="rId17"/>
+    <p:sldId id="271" r:id="rId18"/>
+    <p:sldId id="272" r:id="rId19"/>
+    <p:sldId id="273" r:id="rId20"/>
   </p:sldIdLst>
   <p:sldSz cx="12192000" cy="6858000"/>
   <p:notesSz cx="6858000" cy="9144000"/>
@@ -124,6 +131,619 @@
     </p:ext>
   </p:extLst>
 </p:presentation>
+</file>
+
+<file path=ppt/charts/chartEx1.xml><?xml version="1.0" encoding="utf-8"?>
+<cx:chartSpace xmlns:a="http://schemas.openxmlformats.org/drawingml/2006/main" xmlns:r="http://schemas.openxmlformats.org/officeDocument/2006/relationships" xmlns:cx="http://schemas.microsoft.com/office/drawing/2014/chartex">
+  <cx:chartData>
+    <cx:externalData r:id="rId1" cx:autoUpdate="0"/>
+    <cx:data id="0">
+      <cx:strDim type="cat">
+        <cx:f>waterfall!$A$2:$A$6</cx:f>
+        <cx:lvl ptCount="5">
+          <cx:pt idx="0">البداية</cx:pt>
+          <cx:pt idx="1">المبيعات</cx:pt>
+          <cx:pt idx="2">التكاليف</cx:pt>
+          <cx:pt idx="3">الضرائب</cx:pt>
+          <cx:pt idx="4">الصافي</cx:pt>
+        </cx:lvl>
+      </cx:strDim>
+      <cx:numDim type="val">
+        <cx:f>waterfall!$B$2:$B$6</cx:f>
+        <cx:lvl ptCount="5" formatCode="General">
+          <cx:pt idx="0">100</cx:pt>
+          <cx:pt idx="1">60</cx:pt>
+          <cx:pt idx="2">-40</cx:pt>
+          <cx:pt idx="3">-15</cx:pt>
+          <cx:pt idx="4">105</cx:pt>
+        </cx:lvl>
+      </cx:numDim>
+    </cx:data>
+  </cx:chartData>
+  <cx:chart>
+    <cx:title pos="t" align="ctr" overlay="0"/>
+    <cx:plotArea>
+      <cx:plotAreaRegion>
+        <cx:series layoutId="waterfall" uniqueId="{00000000-D1D3-4E07-9A76-FCE8C7D96EFB}">
+          <cx:tx>
+            <cx:txData>
+              <cx:f>waterfall!$B$1</cx:f>
+              <cx:v>Amount</cx:v>
+            </cx:txData>
+          </cx:tx>
+          <cx:dataLabels pos="outEnd">
+            <cx:visibility seriesName="0" categoryName="0" value="1"/>
+          </cx:dataLabels>
+          <cx:dataId val="0"/>
+          <cx:layoutPr>
+            <cx:visibility connectorLines="1"/>
+            <cx:subtotals>
+              <cx:idx val="4"/>
+            </cx:subtotals>
+          </cx:layoutPr>
+        </cx:series>
+      </cx:plotAreaRegion>
+      <cx:axis id="0">
+        <cx:catScaling gapWidth="0.5"/>
+        <cx:tickLabels/>
+      </cx:axis>
+      <cx:axis id="1">
+        <cx:valScaling/>
+        <cx:majorGridlines/>
+        <cx:tickLabels/>
+      </cx:axis>
+    </cx:plotArea>
+    <cx:legend pos="t" align="ctr" overlay="0"/>
+  </cx:chart>
+</cx:chartSpace>
+</file>
+
+<file path=ppt/charts/colors1.xml><?xml version="1.0" encoding="utf-8"?>
+<cs:colorStyle xmlns:cs="http://schemas.microsoft.com/office/drawing/2012/chartStyle" xmlns:a="http://schemas.openxmlformats.org/drawingml/2006/main" meth="cycle" id="10">
+  <a:schemeClr val="accent1"/>
+  <a:schemeClr val="accent2"/>
+  <a:schemeClr val="accent3"/>
+  <a:schemeClr val="accent4"/>
+  <a:schemeClr val="accent5"/>
+  <a:schemeClr val="accent6"/>
+  <cs:variation/>
+  <cs:variation>
+    <a:lumMod val="60000"/>
+  </cs:variation>
+  <cs:variation>
+    <a:lumMod val="80000"/>
+    <a:lumOff val="20000"/>
+  </cs:variation>
+  <cs:variation>
+    <a:lumMod val="80000"/>
+  </cs:variation>
+  <cs:variation>
+    <a:lumMod val="60000"/>
+    <a:lumOff val="40000"/>
+  </cs:variation>
+  <cs:variation>
+    <a:lumMod val="50000"/>
+  </cs:variation>
+  <cs:variation>
+    <a:lumMod val="70000"/>
+    <a:lumOff val="30000"/>
+  </cs:variation>
+  <cs:variation>
+    <a:lumMod val="70000"/>
+  </cs:variation>
+  <cs:variation>
+    <a:lumMod val="50000"/>
+    <a:lumOff val="50000"/>
+  </cs:variation>
+</cs:colorStyle>
+</file>
+
+<file path=ppt/charts/style1.xml><?xml version="1.0" encoding="utf-8"?>
+<cs:chartStyle xmlns:cs="http://schemas.microsoft.com/office/drawing/2012/chartStyle" xmlns:a="http://schemas.openxmlformats.org/drawingml/2006/main" id="395">
+  <cs:axisTitle>
+    <cs:lnRef idx="0"/>
+    <cs:fillRef idx="0"/>
+    <cs:effectRef idx="0"/>
+    <cs:fontRef idx="minor">
+      <a:schemeClr val="tx1">
+        <a:lumMod val="65000"/>
+        <a:lumOff val="35000"/>
+      </a:schemeClr>
+    </cs:fontRef>
+    <cs:defRPr sz="900"/>
+  </cs:axisTitle>
+  <cs:categoryAxis>
+    <cs:lnRef idx="0"/>
+    <cs:fillRef idx="0"/>
+    <cs:effectRef idx="0"/>
+    <cs:fontRef idx="minor">
+      <a:schemeClr val="tx1">
+        <a:lumMod val="65000"/>
+        <a:lumOff val="35000"/>
+      </a:schemeClr>
+    </cs:fontRef>
+    <cs:spPr>
+      <a:ln w="9525" cap="flat" cmpd="sng" algn="ctr">
+        <a:solidFill>
+          <a:schemeClr val="tx1">
+            <a:lumMod val="15000"/>
+            <a:lumOff val="85000"/>
+          </a:schemeClr>
+        </a:solidFill>
+        <a:round/>
+      </a:ln>
+    </cs:spPr>
+    <cs:defRPr sz="900"/>
+  </cs:categoryAxis>
+  <cs:chartArea mods="allowNoFillOverride allowNoLineOverride">
+    <cs:lnRef idx="0"/>
+    <cs:fillRef idx="0"/>
+    <cs:effectRef idx="0"/>
+    <cs:fontRef idx="minor">
+      <a:schemeClr val="tx1"/>
+    </cs:fontRef>
+    <cs:spPr>
+      <a:solidFill>
+        <a:schemeClr val="bg1"/>
+      </a:solidFill>
+      <a:ln w="9525" cap="flat" cmpd="sng" algn="ctr">
+        <a:solidFill>
+          <a:schemeClr val="tx1">
+            <a:lumMod val="15000"/>
+            <a:lumOff val="85000"/>
+          </a:schemeClr>
+        </a:solidFill>
+        <a:round/>
+      </a:ln>
+    </cs:spPr>
+    <cs:defRPr sz="1000"/>
+  </cs:chartArea>
+  <cs:dataLabel>
+    <cs:lnRef idx="0"/>
+    <cs:fillRef idx="0"/>
+    <cs:effectRef idx="0"/>
+    <cs:fontRef idx="minor">
+      <a:schemeClr val="tx1">
+        <a:lumMod val="65000"/>
+        <a:lumOff val="35000"/>
+      </a:schemeClr>
+    </cs:fontRef>
+    <cs:defRPr sz="900"/>
+  </cs:dataLabel>
+  <cs:dataLabelCallout>
+    <cs:lnRef idx="0"/>
+    <cs:fillRef idx="0"/>
+    <cs:effectRef idx="0"/>
+    <cs:fontRef idx="minor">
+      <a:schemeClr val="dk1">
+        <a:lumMod val="65000"/>
+        <a:lumOff val="35000"/>
+      </a:schemeClr>
+    </cs:fontRef>
+    <cs:spPr>
+      <a:solidFill>
+        <a:schemeClr val="lt1"/>
+      </a:solidFill>
+      <a:ln>
+        <a:solidFill>
+          <a:schemeClr val="dk1">
+            <a:lumMod val="25000"/>
+            <a:lumOff val="75000"/>
+          </a:schemeClr>
+        </a:solidFill>
+      </a:ln>
+    </cs:spPr>
+    <cs:defRPr sz="900"/>
+    <cs:bodyPr rot="0" spcFirstLastPara="1" vertOverflow="clip" horzOverflow="clip" vert="horz" wrap="square" lIns="36576" tIns="18288" rIns="36576" bIns="18288" anchor="ctr" anchorCtr="1">
+      <a:spAutoFit/>
+    </cs:bodyPr>
+  </cs:dataLabelCallout>
+  <cs:dataPoint>
+    <cs:lnRef idx="0"/>
+    <cs:fillRef idx="0">
+      <cs:styleClr val="auto"/>
+    </cs:fillRef>
+    <cs:effectRef idx="0"/>
+    <cs:fontRef idx="minor">
+      <a:schemeClr val="tx1"/>
+    </cs:fontRef>
+    <cs:spPr>
+      <a:solidFill>
+        <a:schemeClr val="phClr"/>
+      </a:solidFill>
+    </cs:spPr>
+  </cs:dataPoint>
+  <cs:dataPoint3D>
+    <cs:lnRef idx="0"/>
+    <cs:fillRef idx="0">
+      <cs:styleClr val="auto"/>
+    </cs:fillRef>
+    <cs:effectRef idx="0"/>
+    <cs:fontRef idx="minor">
+      <a:schemeClr val="tx1"/>
+    </cs:fontRef>
+    <cs:spPr>
+      <a:solidFill>
+        <a:schemeClr val="phClr"/>
+      </a:solidFill>
+    </cs:spPr>
+  </cs:dataPoint3D>
+  <cs:dataPointLine>
+    <cs:lnRef idx="0">
+      <cs:styleClr val="auto"/>
+    </cs:lnRef>
+    <cs:fillRef idx="0"/>
+    <cs:effectRef idx="0"/>
+    <cs:fontRef idx="minor">
+      <a:schemeClr val="tx1"/>
+    </cs:fontRef>
+    <cs:spPr>
+      <a:ln w="28575" cap="rnd">
+        <a:solidFill>
+          <a:schemeClr val="phClr"/>
+        </a:solidFill>
+        <a:round/>
+      </a:ln>
+    </cs:spPr>
+  </cs:dataPointLine>
+  <cs:dataPointMarker>
+    <cs:lnRef idx="0"/>
+    <cs:fillRef idx="0">
+      <cs:styleClr val="auto"/>
+    </cs:fillRef>
+    <cs:effectRef idx="0"/>
+    <cs:fontRef idx="minor">
+      <a:schemeClr val="tx1"/>
+    </cs:fontRef>
+    <cs:spPr>
+      <a:solidFill>
+        <a:schemeClr val="phClr"/>
+      </a:solidFill>
+      <a:ln w="9525">
+        <a:solidFill>
+          <a:schemeClr val="lt1"/>
+        </a:solidFill>
+      </a:ln>
+    </cs:spPr>
+  </cs:dataPointMarker>
+  <cs:dataPointMarkerLayout symbol="circle" size="5"/>
+  <cs:dataPointWireframe>
+    <cs:lnRef idx="0">
+      <cs:styleClr val="auto"/>
+    </cs:lnRef>
+    <cs:fillRef idx="0"/>
+    <cs:effectRef idx="0"/>
+    <cs:fontRef idx="minor">
+      <a:schemeClr val="tx1"/>
+    </cs:fontRef>
+    <cs:spPr>
+      <a:ln w="28575" cap="rnd">
+        <a:solidFill>
+          <a:schemeClr val="phClr"/>
+        </a:solidFill>
+        <a:round/>
+      </a:ln>
+    </cs:spPr>
+  </cs:dataPointWireframe>
+  <cs:dataTable>
+    <cs:lnRef idx="0"/>
+    <cs:fillRef idx="0"/>
+    <cs:effectRef idx="0"/>
+    <cs:fontRef idx="minor">
+      <a:schemeClr val="tx1">
+        <a:lumMod val="65000"/>
+        <a:lumOff val="35000"/>
+      </a:schemeClr>
+    </cs:fontRef>
+    <cs:spPr>
+      <a:ln w="9525">
+        <a:solidFill>
+          <a:schemeClr val="tx1">
+            <a:lumMod val="15000"/>
+            <a:lumOff val="85000"/>
+          </a:schemeClr>
+        </a:solidFill>
+      </a:ln>
+    </cs:spPr>
+    <cs:defRPr sz="900"/>
+  </cs:dataTable>
+  <cs:downBar>
+    <cs:lnRef idx="0"/>
+    <cs:fillRef idx="0"/>
+    <cs:effectRef idx="0"/>
+    <cs:fontRef idx="minor">
+      <a:schemeClr val="dk1"/>
+    </cs:fontRef>
+    <cs:spPr>
+      <a:solidFill>
+        <a:schemeClr val="dk1">
+          <a:lumMod val="65000"/>
+          <a:lumOff val="35000"/>
+        </a:schemeClr>
+      </a:solidFill>
+      <a:ln w="9525">
+        <a:solidFill>
+          <a:schemeClr val="tx1">
+            <a:lumMod val="65000"/>
+            <a:lumOff val="35000"/>
+          </a:schemeClr>
+        </a:solidFill>
+      </a:ln>
+    </cs:spPr>
+  </cs:downBar>
+  <cs:dropLine>
+    <cs:lnRef idx="0"/>
+    <cs:fillRef idx="0"/>
+    <cs:effectRef idx="0"/>
+    <cs:fontRef idx="minor">
+      <a:schemeClr val="tx1"/>
+    </cs:fontRef>
+    <cs:spPr>
+      <a:ln w="9525" cap="flat" cmpd="sng" algn="ctr">
+        <a:solidFill>
+          <a:schemeClr val="tx1">
+            <a:lumMod val="35000"/>
+            <a:lumOff val="65000"/>
+          </a:schemeClr>
+        </a:solidFill>
+        <a:round/>
+      </a:ln>
+    </cs:spPr>
+  </cs:dropLine>
+  <cs:errorBar>
+    <cs:lnRef idx="0"/>
+    <cs:fillRef idx="0"/>
+    <cs:effectRef idx="0"/>
+    <cs:fontRef idx="minor">
+      <a:schemeClr val="tx1"/>
+    </cs:fontRef>
+    <cs:spPr>
+      <a:ln w="9525" cap="flat" cmpd="sng" algn="ctr">
+        <a:solidFill>
+          <a:schemeClr val="tx1">
+            <a:lumMod val="65000"/>
+            <a:lumOff val="35000"/>
+          </a:schemeClr>
+        </a:solidFill>
+        <a:round/>
+      </a:ln>
+    </cs:spPr>
+  </cs:errorBar>
+  <cs:floor>
+    <cs:lnRef idx="0"/>
+    <cs:fillRef idx="0"/>
+    <cs:effectRef idx="0"/>
+    <cs:fontRef idx="minor">
+      <a:schemeClr val="tx1"/>
+    </cs:fontRef>
+  </cs:floor>
+  <cs:gridlineMajor>
+    <cs:lnRef idx="0"/>
+    <cs:fillRef idx="0"/>
+    <cs:effectRef idx="0"/>
+    <cs:fontRef idx="minor">
+      <a:schemeClr val="tx1"/>
+    </cs:fontRef>
+    <cs:spPr>
+      <a:ln w="9525" cap="flat" cmpd="sng" algn="ctr">
+        <a:solidFill>
+          <a:schemeClr val="tx1">
+            <a:lumMod val="15000"/>
+            <a:lumOff val="85000"/>
+          </a:schemeClr>
+        </a:solidFill>
+        <a:round/>
+      </a:ln>
+    </cs:spPr>
+  </cs:gridlineMajor>
+  <cs:gridlineMinor>
+    <cs:lnRef idx="0"/>
+    <cs:fillRef idx="0"/>
+    <cs:effectRef idx="0"/>
+    <cs:fontRef idx="minor">
+      <a:schemeClr val="tx1"/>
+    </cs:fontRef>
+    <cs:spPr>
+      <a:ln w="9525" cap="flat" cmpd="sng" algn="ctr">
+        <a:solidFill>
+          <a:schemeClr val="tx1">
+            <a:lumMod val="15000"/>
+            <a:lumOff val="85000"/>
+          </a:schemeClr>
+        </a:solidFill>
+        <a:round/>
+      </a:ln>
+    </cs:spPr>
+  </cs:gridlineMinor>
+  <cs:hiLoLine>
+    <cs:lnRef idx="0"/>
+    <cs:fillRef idx="0"/>
+    <cs:effectRef idx="0"/>
+    <cs:fontRef idx="minor">
+      <a:schemeClr val="tx1"/>
+    </cs:fontRef>
+    <cs:spPr>
+      <a:ln w="9525" cap="flat" cmpd="sng" algn="ctr">
+        <a:solidFill>
+          <a:schemeClr val="tx1">
+            <a:lumMod val="75000"/>
+            <a:lumOff val="25000"/>
+          </a:schemeClr>
+        </a:solidFill>
+        <a:round/>
+      </a:ln>
+    </cs:spPr>
+  </cs:hiLoLine>
+  <cs:leaderLine>
+    <cs:lnRef idx="0"/>
+    <cs:fillRef idx="0"/>
+    <cs:effectRef idx="0"/>
+    <cs:fontRef idx="minor">
+      <a:schemeClr val="tx1"/>
+    </cs:fontRef>
+    <cs:spPr>
+      <a:ln w="9525" cap="flat" cmpd="sng" algn="ctr">
+        <a:solidFill>
+          <a:schemeClr val="tx1">
+            <a:lumMod val="35000"/>
+            <a:lumOff val="65000"/>
+          </a:schemeClr>
+        </a:solidFill>
+        <a:round/>
+      </a:ln>
+    </cs:spPr>
+  </cs:leaderLine>
+  <cs:legend>
+    <cs:lnRef idx="0"/>
+    <cs:fillRef idx="0"/>
+    <cs:effectRef idx="0"/>
+    <cs:fontRef idx="minor">
+      <a:schemeClr val="tx1">
+        <a:lumMod val="65000"/>
+        <a:lumOff val="35000"/>
+      </a:schemeClr>
+    </cs:fontRef>
+    <cs:defRPr sz="900"/>
+  </cs:legend>
+  <cs:plotArea mods="allowNoFillOverride allowNoLineOverride">
+    <cs:lnRef idx="0"/>
+    <cs:fillRef idx="0"/>
+    <cs:effectRef idx="0"/>
+    <cs:fontRef idx="minor">
+      <a:schemeClr val="tx1"/>
+    </cs:fontRef>
+  </cs:plotArea>
+  <cs:plotArea3D mods="allowNoFillOverride allowNoLineOverride">
+    <cs:lnRef idx="0"/>
+    <cs:fillRef idx="0"/>
+    <cs:effectRef idx="0"/>
+    <cs:fontRef idx="minor">
+      <a:schemeClr val="tx1"/>
+    </cs:fontRef>
+  </cs:plotArea3D>
+  <cs:seriesAxis>
+    <cs:lnRef idx="0"/>
+    <cs:fillRef idx="0"/>
+    <cs:effectRef idx="0"/>
+    <cs:fontRef idx="minor">
+      <a:schemeClr val="tx1">
+        <a:lumMod val="65000"/>
+        <a:lumOff val="35000"/>
+      </a:schemeClr>
+    </cs:fontRef>
+    <cs:spPr>
+      <a:ln w="9525" cap="flat" cmpd="sng" algn="ctr">
+        <a:solidFill>
+          <a:schemeClr val="tx1">
+            <a:lumMod val="15000"/>
+            <a:lumOff val="85000"/>
+          </a:schemeClr>
+        </a:solidFill>
+        <a:round/>
+      </a:ln>
+    </cs:spPr>
+    <cs:defRPr sz="900"/>
+  </cs:seriesAxis>
+  <cs:seriesLine>
+    <cs:lnRef idx="0"/>
+    <cs:fillRef idx="0"/>
+    <cs:effectRef idx="0"/>
+    <cs:fontRef idx="minor">
+      <a:schemeClr val="tx1"/>
+    </cs:fontRef>
+    <cs:spPr>
+      <a:ln w="9525" cap="flat">
+        <a:solidFill>
+          <a:srgbClr val="D9D9D9"/>
+        </a:solidFill>
+        <a:round/>
+      </a:ln>
+    </cs:spPr>
+  </cs:seriesLine>
+  <cs:title>
+    <cs:lnRef idx="0"/>
+    <cs:fillRef idx="0"/>
+    <cs:effectRef idx="0"/>
+    <cs:fontRef idx="minor">
+      <a:schemeClr val="tx1">
+        <a:lumMod val="65000"/>
+        <a:lumOff val="35000"/>
+      </a:schemeClr>
+    </cs:fontRef>
+    <cs:defRPr sz="1400"/>
+  </cs:title>
+  <cs:trendline>
+    <cs:lnRef idx="0">
+      <cs:styleClr val="auto"/>
+    </cs:lnRef>
+    <cs:fillRef idx="0"/>
+    <cs:effectRef idx="0"/>
+    <cs:fontRef idx="minor">
+      <a:schemeClr val="tx1"/>
+    </cs:fontRef>
+    <cs:spPr>
+      <a:ln w="19050" cap="rnd">
+        <a:solidFill>
+          <a:schemeClr val="phClr"/>
+        </a:solidFill>
+        <a:prstDash val="sysDash"/>
+      </a:ln>
+    </cs:spPr>
+  </cs:trendline>
+  <cs:trendlineLabel>
+    <cs:lnRef idx="0"/>
+    <cs:fillRef idx="0"/>
+    <cs:effectRef idx="0"/>
+    <cs:fontRef idx="minor">
+      <a:schemeClr val="tx1">
+        <a:lumMod val="65000"/>
+        <a:lumOff val="35000"/>
+      </a:schemeClr>
+    </cs:fontRef>
+    <cs:defRPr sz="900"/>
+  </cs:trendlineLabel>
+  <cs:upBar>
+    <cs:lnRef idx="0"/>
+    <cs:fillRef idx="0"/>
+    <cs:effectRef idx="0"/>
+    <cs:fontRef idx="minor">
+      <a:schemeClr val="dk1"/>
+    </cs:fontRef>
+    <cs:spPr>
+      <a:solidFill>
+        <a:schemeClr val="lt1"/>
+      </a:solidFill>
+      <a:ln w="9525">
+        <a:solidFill>
+          <a:schemeClr val="tx1">
+            <a:lumMod val="15000"/>
+            <a:lumOff val="85000"/>
+          </a:schemeClr>
+        </a:solidFill>
+      </a:ln>
+    </cs:spPr>
+  </cs:upBar>
+  <cs:valueAxis>
+    <cs:lnRef idx="0"/>
+    <cs:fillRef idx="0"/>
+    <cs:effectRef idx="0"/>
+    <cs:fontRef idx="minor">
+      <a:schemeClr val="tx1">
+        <a:lumMod val="65000"/>
+        <a:lumOff val="35000"/>
+      </a:schemeClr>
+    </cs:fontRef>
+    <cs:defRPr sz="900"/>
+  </cs:valueAxis>
+  <cs:wall>
+    <cs:lnRef idx="0"/>
+    <cs:fillRef idx="0"/>
+    <cs:effectRef idx="0"/>
+    <cs:fontRef idx="minor">
+      <a:schemeClr val="tx1"/>
+    </cs:fontRef>
+  </cs:wall>
+</cs:chartStyle>
 </file>
 
 <file path=ppt/ink/ink1.xml><?xml version="1.0" encoding="utf-8"?>
@@ -444,7 +1064,7 @@
           <a:p>
             <a:fld id="{86A64A56-4393-4CB6-85C6-C90BB7A8548C}" type="datetimeFigureOut">
               <a:rPr lang="en-US" smtClean="0"/>
-              <a:t>9/28/2026</a:t>
+              <a:t>10/5/2026</a:t>
             </a:fld>
             <a:endParaRPr lang="en-US"/>
           </a:p>
@@ -858,7 +1478,7 @@
           <a:p>
             <a:fld id="{60541A7F-F981-4501-AAE0-06F6CB326412}" type="datetime1">
               <a:rPr lang="en-US" smtClean="0"/>
-              <a:t>9/28/2026</a:t>
+              <a:t>10/5/2026</a:t>
             </a:fld>
             <a:endParaRPr lang="en-US"/>
           </a:p>
@@ -1056,7 +1676,7 @@
           <a:p>
             <a:fld id="{F853943D-1B76-47AC-8196-C4B25463BF47}" type="datetime1">
               <a:rPr lang="en-US" smtClean="0"/>
-              <a:t>9/28/2026</a:t>
+              <a:t>10/5/2026</a:t>
             </a:fld>
             <a:endParaRPr lang="en-US"/>
           </a:p>
@@ -1264,7 +1884,7 @@
           <a:p>
             <a:fld id="{2E188C43-274A-49F7-9E8E-741661AA3B8D}" type="datetime1">
               <a:rPr lang="en-US" smtClean="0"/>
-              <a:t>9/28/2026</a:t>
+              <a:t>10/5/2026</a:t>
             </a:fld>
             <a:endParaRPr lang="en-US"/>
           </a:p>
@@ -1328,6 +1948,280 @@
     <p:extLst>
       <p:ext uri="{BB962C8B-B14F-4D97-AF65-F5344CB8AC3E}">
         <p14:creationId xmlns:p14="http://schemas.microsoft.com/office/powerpoint/2010/main" val="1772351598"/>
+      </p:ext>
+    </p:extLst>
+  </p:cSld>
+  <p:clrMapOvr>
+    <a:masterClrMapping/>
+  </p:clrMapOvr>
+</p:sldLayout>
+</file>
+
+<file path=ppt/slideLayouts/slideLayout12.xml><?xml version="1.0" encoding="utf-8"?>
+<p:sldLayout xmlns:a="http://schemas.openxmlformats.org/drawingml/2006/main" xmlns:r="http://schemas.openxmlformats.org/officeDocument/2006/relationships" xmlns:p="http://schemas.openxmlformats.org/presentationml/2006/main" type="titleOnly">
+  <p:cSld name="Layout A">
+    <p:spTree>
+      <p:nvGrpSpPr>
+        <p:cNvPr id="1" name=""/>
+        <p:cNvGrpSpPr/>
+        <p:nvPr/>
+      </p:nvGrpSpPr>
+      <p:grpSpPr>
+        <a:xfrm>
+          <a:off x="0" y="0"/>
+          <a:ext cx="0" cy="0"/>
+          <a:chOff x="0" y="0"/>
+          <a:chExt cx="0" cy="0"/>
+        </a:xfrm>
+      </p:grpSpPr>
+      <p:sp>
+        <p:nvSpPr>
+          <p:cNvPr id="2" name="Title 1">
+            <a:extLst>
+              <a:ext uri="{FF2B5EF4-FFF2-40B4-BE49-F238E27FC236}">
+                <a16:creationId xmlns:a16="http://schemas.microsoft.com/office/drawing/2014/main" id="{6030150B-B92B-63DC-988E-EA6EF944F7F9}"/>
+              </a:ext>
+            </a:extLst>
+          </p:cNvPr>
+          <p:cNvSpPr>
+            <a:spLocks noGrp="1"/>
+          </p:cNvSpPr>
+          <p:nvPr>
+            <p:ph type="title"/>
+          </p:nvPr>
+        </p:nvSpPr>
+        <p:spPr/>
+        <p:txBody>
+          <a:bodyPr/>
+          <a:lstStyle/>
+          <a:p>
+            <a:r>
+              <a:rPr lang="en-US"/>
+              <a:t>Click to edit Master title style</a:t>
+            </a:r>
+          </a:p>
+        </p:txBody>
+      </p:sp>
+      <p:sp>
+        <p:nvSpPr>
+          <p:cNvPr id="5" name="Slide Number Placeholder 4">
+            <a:extLst>
+              <a:ext uri="{FF2B5EF4-FFF2-40B4-BE49-F238E27FC236}">
+                <a16:creationId xmlns:a16="http://schemas.microsoft.com/office/drawing/2014/main" id="{D3038B06-BF74-5654-F5F0-B5DB822985E1}"/>
+              </a:ext>
+            </a:extLst>
+          </p:cNvPr>
+          <p:cNvSpPr>
+            <a:spLocks noGrp="1"/>
+          </p:cNvSpPr>
+          <p:nvPr>
+            <p:ph type="sldNum" sz="quarter" idx="12"/>
+          </p:nvPr>
+        </p:nvSpPr>
+        <p:spPr/>
+        <p:txBody>
+          <a:bodyPr/>
+          <a:lstStyle/>
+          <a:p>
+            <a:fld id="{C6DDDF4F-F028-4B81-B3D4-6037FCFC1593}" type="slidenum">
+              <a:rPr lang="en-US" smtClean="0"/>
+              <a:t>‹#›</a:t>
+            </a:fld>
+            <a:endParaRPr lang="en-US"/>
+          </a:p>
+        </p:txBody>
+      </p:sp>
+      <p:sp>
+        <p:nvSpPr>
+          <p:cNvPr id="6" name="Layout A graphic">
+            <a:extLst>
+              <a:ext uri="{FF2B5EF4-FFF2-40B4-BE49-F238E27FC236}">
+                <a16:creationId xmlns:a16="http://schemas.microsoft.com/office/drawing/2014/main" id="{A4D09DA9-197B-0F4A-06D7-DB10B6473EB7}"/>
+              </a:ext>
+            </a:extLst>
+          </p:cNvPr>
+          <p:cNvSpPr/>
+          <p:nvPr userDrawn="1"/>
+        </p:nvSpPr>
+        <p:spPr>
+          <a:xfrm>
+            <a:off x="381000" y="685800"/>
+            <a:ext cx="2794000" cy="381000"/>
+          </a:xfrm>
+          <a:prstGeom prst="rect">
+            <a:avLst/>
+          </a:prstGeom>
+        </p:spPr>
+        <p:style>
+          <a:lnRef idx="2">
+            <a:schemeClr val="accent1">
+              <a:shade val="15000"/>
+            </a:schemeClr>
+          </a:lnRef>
+          <a:fillRef idx="1">
+            <a:schemeClr val="accent1"/>
+          </a:fillRef>
+          <a:effectRef idx="0">
+            <a:schemeClr val="accent1"/>
+          </a:effectRef>
+          <a:fontRef idx="minor">
+            <a:schemeClr val="lt1"/>
+          </a:fontRef>
+        </p:style>
+        <p:txBody>
+          <a:bodyPr rtlCol="0" anchor="ctr"/>
+          <a:lstStyle/>
+          <a:p>
+            <a:pPr algn="ctr"/>
+            <a:r>
+              <a:rPr lang="ar-EG" sz="1400"/>
+              <a:t>رسم التخطيط أ</a:t>
+            </a:r>
+            <a:endParaRPr lang="en-US" sz="1400"/>
+          </a:p>
+        </p:txBody>
+      </p:sp>
+    </p:spTree>
+    <p:extLst>
+      <p:ext uri="{BB962C8B-B14F-4D97-AF65-F5344CB8AC3E}">
+        <p14:creationId xmlns:p14="http://schemas.microsoft.com/office/powerpoint/2010/main" val="828789351"/>
+      </p:ext>
+    </p:extLst>
+  </p:cSld>
+  <p:clrMapOvr>
+    <a:masterClrMapping/>
+  </p:clrMapOvr>
+</p:sldLayout>
+</file>
+
+<file path=ppt/slideLayouts/slideLayout13.xml><?xml version="1.0" encoding="utf-8"?>
+<p:sldLayout xmlns:a="http://schemas.openxmlformats.org/drawingml/2006/main" xmlns:r="http://schemas.openxmlformats.org/officeDocument/2006/relationships" xmlns:p="http://schemas.openxmlformats.org/presentationml/2006/main" showMasterSp="0" type="titleOnly">
+  <p:cSld name="Layout B">
+    <p:spTree>
+      <p:nvGrpSpPr>
+        <p:cNvPr id="1" name=""/>
+        <p:cNvGrpSpPr/>
+        <p:nvPr/>
+      </p:nvGrpSpPr>
+      <p:grpSpPr>
+        <a:xfrm>
+          <a:off x="0" y="0"/>
+          <a:ext cx="0" cy="0"/>
+          <a:chOff x="0" y="0"/>
+          <a:chExt cx="0" cy="0"/>
+        </a:xfrm>
+      </p:grpSpPr>
+      <p:sp>
+        <p:nvSpPr>
+          <p:cNvPr id="2" name="Title 1">
+            <a:extLst>
+              <a:ext uri="{FF2B5EF4-FFF2-40B4-BE49-F238E27FC236}">
+                <a16:creationId xmlns:a16="http://schemas.microsoft.com/office/drawing/2014/main" id="{AF3E6521-8CFB-4D01-74E8-723187B4154D}"/>
+              </a:ext>
+            </a:extLst>
+          </p:cNvPr>
+          <p:cNvSpPr>
+            <a:spLocks noGrp="1"/>
+          </p:cNvSpPr>
+          <p:nvPr>
+            <p:ph type="title"/>
+          </p:nvPr>
+        </p:nvSpPr>
+        <p:spPr/>
+        <p:txBody>
+          <a:bodyPr/>
+          <a:lstStyle/>
+          <a:p>
+            <a:r>
+              <a:rPr lang="en-US"/>
+              <a:t>Click to edit Master title style</a:t>
+            </a:r>
+          </a:p>
+        </p:txBody>
+      </p:sp>
+      <p:sp>
+        <p:nvSpPr>
+          <p:cNvPr id="5" name="Slide Number Placeholder 4">
+            <a:extLst>
+              <a:ext uri="{FF2B5EF4-FFF2-40B4-BE49-F238E27FC236}">
+                <a16:creationId xmlns:a16="http://schemas.microsoft.com/office/drawing/2014/main" id="{DCE47D3F-5AE9-4574-C420-CD850FC82765}"/>
+              </a:ext>
+            </a:extLst>
+          </p:cNvPr>
+          <p:cNvSpPr>
+            <a:spLocks noGrp="1"/>
+          </p:cNvSpPr>
+          <p:nvPr>
+            <p:ph type="sldNum" sz="quarter" idx="12"/>
+          </p:nvPr>
+        </p:nvSpPr>
+        <p:spPr/>
+        <p:txBody>
+          <a:bodyPr/>
+          <a:lstStyle/>
+          <a:p>
+            <a:fld id="{C6DDDF4F-F028-4B81-B3D4-6037FCFC1593}" type="slidenum">
+              <a:rPr lang="en-US" smtClean="0"/>
+              <a:t>‹#›</a:t>
+            </a:fld>
+            <a:endParaRPr lang="en-US"/>
+          </a:p>
+        </p:txBody>
+      </p:sp>
+      <p:sp>
+        <p:nvSpPr>
+          <p:cNvPr id="6" name="Layout B graphic">
+            <a:extLst>
+              <a:ext uri="{FF2B5EF4-FFF2-40B4-BE49-F238E27FC236}">
+                <a16:creationId xmlns:a16="http://schemas.microsoft.com/office/drawing/2014/main" id="{14A9AAB3-6159-DF59-074C-EAFE3016E7D8}"/>
+              </a:ext>
+            </a:extLst>
+          </p:cNvPr>
+          <p:cNvSpPr/>
+          <p:nvPr userDrawn="1"/>
+        </p:nvSpPr>
+        <p:spPr>
+          <a:xfrm>
+            <a:off x="381000" y="685800"/>
+            <a:ext cx="2794000" cy="381000"/>
+          </a:xfrm>
+          <a:prstGeom prst="rect">
+            <a:avLst/>
+          </a:prstGeom>
+        </p:spPr>
+        <p:style>
+          <a:lnRef idx="2">
+            <a:schemeClr val="accent1">
+              <a:shade val="15000"/>
+            </a:schemeClr>
+          </a:lnRef>
+          <a:fillRef idx="1">
+            <a:schemeClr val="accent1"/>
+          </a:fillRef>
+          <a:effectRef idx="0">
+            <a:schemeClr val="accent1"/>
+          </a:effectRef>
+          <a:fontRef idx="minor">
+            <a:schemeClr val="lt1"/>
+          </a:fontRef>
+        </p:style>
+        <p:txBody>
+          <a:bodyPr rtlCol="0" anchor="ctr"/>
+          <a:lstStyle/>
+          <a:p>
+            <a:pPr algn="ctr"/>
+            <a:r>
+              <a:rPr lang="ar-EG" sz="1400"/>
+              <a:t>رسم التخطيط ب</a:t>
+            </a:r>
+            <a:endParaRPr lang="en-US" sz="1400"/>
+          </a:p>
+        </p:txBody>
+      </p:sp>
+    </p:spTree>
+    <p:extLst>
+      <p:ext uri="{BB962C8B-B14F-4D97-AF65-F5344CB8AC3E}">
+        <p14:creationId xmlns:p14="http://schemas.microsoft.com/office/powerpoint/2010/main" val="2712827227"/>
       </p:ext>
     </p:extLst>
   </p:cSld>
@@ -1462,7 +2356,7 @@
           <a:p>
             <a:fld id="{AFE56759-6820-42B3-B9BE-972720AE0218}" type="datetime1">
               <a:rPr lang="en-US" smtClean="0"/>
-              <a:t>9/28/2026</a:t>
+              <a:t>10/5/2026</a:t>
             </a:fld>
             <a:endParaRPr lang="en-US"/>
           </a:p>
@@ -1737,7 +2631,7 @@
           <a:p>
             <a:fld id="{E60A5D86-3AF6-469E-9631-8585AF639EE9}" type="datetime1">
               <a:rPr lang="en-US" smtClean="0"/>
-              <a:t>9/28/2026</a:t>
+              <a:t>10/5/2026</a:t>
             </a:fld>
             <a:endParaRPr lang="en-US"/>
           </a:p>
@@ -2002,7 +2896,7 @@
           <a:p>
             <a:fld id="{7040F516-D53A-4B36-A577-E8486E25D0EC}" type="datetime1">
               <a:rPr lang="en-US" smtClean="0"/>
-              <a:t>9/28/2026</a:t>
+              <a:t>10/5/2026</a:t>
             </a:fld>
             <a:endParaRPr lang="en-US"/>
           </a:p>
@@ -2414,7 +3308,7 @@
           <a:p>
             <a:fld id="{3E6E30B0-F99E-4FCA-83EF-31E10F2B66B1}" type="datetime1">
               <a:rPr lang="en-US" smtClean="0"/>
-              <a:t>9/28/2026</a:t>
+              <a:t>10/5/2026</a:t>
             </a:fld>
             <a:endParaRPr lang="en-US"/>
           </a:p>
@@ -2555,7 +3449,7 @@
           <a:p>
             <a:fld id="{FF185E36-5297-403D-B499-FD865F8C5A4F}" type="datetime1">
               <a:rPr lang="en-US" smtClean="0"/>
-              <a:t>9/28/2026</a:t>
+              <a:t>10/5/2026</a:t>
             </a:fld>
             <a:endParaRPr lang="en-US"/>
           </a:p>
@@ -2668,7 +3562,7 @@
           <a:p>
             <a:fld id="{2CDF4417-72BA-4D8F-8104-BFB5B423E2DD}" type="datetime1">
               <a:rPr lang="en-US" smtClean="0"/>
-              <a:t>9/28/2026</a:t>
+              <a:t>10/5/2026</a:t>
             </a:fld>
             <a:endParaRPr lang="en-US"/>
           </a:p>
@@ -2979,7 +3873,7 @@
           <a:p>
             <a:fld id="{C30CC0FA-F1D1-458D-9491-18A8D18048F7}" type="datetime1">
               <a:rPr lang="en-US" smtClean="0"/>
-              <a:t>9/28/2026</a:t>
+              <a:t>10/5/2026</a:t>
             </a:fld>
             <a:endParaRPr lang="en-US"/>
           </a:p>
@@ -3267,7 +4161,7 @@
           <a:p>
             <a:fld id="{66BF3E84-4616-4F9E-891F-D3C933FF2937}" type="datetime1">
               <a:rPr lang="en-US" smtClean="0"/>
-              <a:t>9/28/2026</a:t>
+              <a:t>10/5/2026</a:t>
             </a:fld>
             <a:endParaRPr lang="en-US"/>
           </a:p>
@@ -3508,7 +4402,7 @@
           <a:p>
             <a:fld id="{350CAA63-4269-45C0-A8A2-D62AE2EC413F}" type="datetime1">
               <a:rPr lang="en-US" smtClean="0"/>
-              <a:t>9/28/2026</a:t>
+              <a:t>10/5/2026</a:t>
             </a:fld>
             <a:endParaRPr lang="en-US"/>
           </a:p>
@@ -3908,6 +4802,621 @@
 </p:sldMaster>
 </file>
 
+<file path=ppt/slideMasters/slideMaster2.xml><?xml version="1.0" encoding="utf-8"?>
+<p:sldMaster xmlns:a="http://schemas.openxmlformats.org/drawingml/2006/main" xmlns:r="http://schemas.openxmlformats.org/officeDocument/2006/relationships" xmlns:p="http://schemas.openxmlformats.org/presentationml/2006/main" preserve="1">
+  <p:cSld>
+    <p:bg>
+      <p:bgPr>
+        <a:blipFill>
+          <a:blip r:embed="rId4"/>
+          <a:stretch>
+            <a:fillRect/>
+          </a:stretch>
+        </a:blipFill>
+        <a:effectLst/>
+      </p:bgPr>
+    </p:bg>
+    <p:spTree>
+      <p:nvGrpSpPr>
+        <p:cNvPr id="1" name=""/>
+        <p:cNvGrpSpPr/>
+        <p:nvPr/>
+      </p:nvGrpSpPr>
+      <p:grpSpPr>
+        <a:xfrm>
+          <a:off x="0" y="0"/>
+          <a:ext cx="0" cy="0"/>
+          <a:chOff x="0" y="0"/>
+          <a:chExt cx="0" cy="0"/>
+        </a:xfrm>
+      </p:grpSpPr>
+      <p:sp>
+        <p:nvSpPr>
+          <p:cNvPr id="2" name="Title Placeholder 1">
+            <a:extLst>
+              <a:ext uri="{FF2B5EF4-FFF2-40B4-BE49-F238E27FC236}">
+                <a16:creationId xmlns:a16="http://schemas.microsoft.com/office/drawing/2014/main" id="{C3E90674-C2C1-EE23-B14D-9859AD21165F}"/>
+              </a:ext>
+            </a:extLst>
+          </p:cNvPr>
+          <p:cNvSpPr>
+            <a:spLocks noGrp="1"/>
+          </p:cNvSpPr>
+          <p:nvPr>
+            <p:ph type="title"/>
+          </p:nvPr>
+        </p:nvSpPr>
+        <p:spPr>
+          <a:xfrm>
+            <a:off x="838200" y="365125"/>
+            <a:ext cx="10515600" cy="1325563"/>
+          </a:xfrm>
+          <a:prstGeom prst="rect">
+            <a:avLst/>
+          </a:prstGeom>
+        </p:spPr>
+        <p:txBody>
+          <a:bodyPr vert="horz" lIns="91440" tIns="45720" rIns="91440" bIns="45720" rtlCol="0" anchor="ctr">
+            <a:normAutofit/>
+          </a:bodyPr>
+          <a:lstStyle/>
+          <a:p>
+            <a:r>
+              <a:rPr lang="en-US"/>
+              <a:t>Click to edit Master title style</a:t>
+            </a:r>
+          </a:p>
+        </p:txBody>
+      </p:sp>
+      <p:sp>
+        <p:nvSpPr>
+          <p:cNvPr id="3" name="Text Placeholder 2">
+            <a:extLst>
+              <a:ext uri="{FF2B5EF4-FFF2-40B4-BE49-F238E27FC236}">
+                <a16:creationId xmlns:a16="http://schemas.microsoft.com/office/drawing/2014/main" id="{A3195541-4A69-8667-EE84-A8518AC74033}"/>
+              </a:ext>
+            </a:extLst>
+          </p:cNvPr>
+          <p:cNvSpPr>
+            <a:spLocks noGrp="1"/>
+          </p:cNvSpPr>
+          <p:nvPr>
+            <p:ph type="body" idx="1"/>
+          </p:nvPr>
+        </p:nvSpPr>
+        <p:spPr>
+          <a:xfrm>
+            <a:off x="838200" y="1825625"/>
+            <a:ext cx="10515600" cy="4351338"/>
+          </a:xfrm>
+          <a:prstGeom prst="rect">
+            <a:avLst/>
+          </a:prstGeom>
+        </p:spPr>
+        <p:txBody>
+          <a:bodyPr vert="horz" lIns="91440" tIns="45720" rIns="91440" bIns="45720" rtlCol="0">
+            <a:normAutofit/>
+          </a:bodyPr>
+          <a:lstStyle/>
+          <a:p>
+            <a:pPr lvl="0"/>
+            <a:r>
+              <a:rPr lang="en-US"/>
+              <a:t>Click to edit Master text styles</a:t>
+            </a:r>
+          </a:p>
+          <a:p>
+            <a:pPr lvl="1"/>
+            <a:r>
+              <a:rPr lang="en-US"/>
+              <a:t>Second level</a:t>
+            </a:r>
+          </a:p>
+          <a:p>
+            <a:pPr lvl="2"/>
+            <a:r>
+              <a:rPr lang="en-US"/>
+              <a:t>Third level</a:t>
+            </a:r>
+          </a:p>
+          <a:p>
+            <a:pPr lvl="3"/>
+            <a:r>
+              <a:rPr lang="en-US"/>
+              <a:t>Fourth level</a:t>
+            </a:r>
+          </a:p>
+          <a:p>
+            <a:pPr lvl="4"/>
+            <a:r>
+              <a:rPr lang="en-US"/>
+              <a:t>Fifth level</a:t>
+            </a:r>
+          </a:p>
+        </p:txBody>
+      </p:sp>
+      <p:sp>
+        <p:nvSpPr>
+          <p:cNvPr id="4" name="Date Placeholder 3">
+            <a:extLst>
+              <a:ext uri="{FF2B5EF4-FFF2-40B4-BE49-F238E27FC236}">
+                <a16:creationId xmlns:a16="http://schemas.microsoft.com/office/drawing/2014/main" id="{4FF32A8D-7850-3170-169C-FACD9064E9A8}"/>
+              </a:ext>
+            </a:extLst>
+          </p:cNvPr>
+          <p:cNvSpPr>
+            <a:spLocks noGrp="1"/>
+          </p:cNvSpPr>
+          <p:nvPr>
+            <p:ph type="dt" sz="half" idx="2"/>
+          </p:nvPr>
+        </p:nvSpPr>
+        <p:spPr>
+          <a:xfrm>
+            <a:off x="838200" y="6356350"/>
+            <a:ext cx="2743200" cy="365125"/>
+          </a:xfrm>
+          <a:prstGeom prst="rect">
+            <a:avLst/>
+          </a:prstGeom>
+        </p:spPr>
+        <p:txBody>
+          <a:bodyPr vert="horz" lIns="91440" tIns="45720" rIns="91440" bIns="45720" rtlCol="0" anchor="ctr"/>
+          <a:lstStyle>
+            <a:lvl1pPr algn="l">
+              <a:defRPr sz="1200">
+                <a:solidFill>
+                  <a:schemeClr val="tx1">
+                    <a:tint val="82000"/>
+                  </a:schemeClr>
+                </a:solidFill>
+              </a:defRPr>
+            </a:lvl1pPr>
+          </a:lstStyle>
+          <a:p>
+            <a:fld id="{27E3A6A4-31A5-4BF1-8F46-4A08E4DED6B4}" type="datetimeFigureOut">
+              <a:rPr lang="en-US" smtClean="0"/>
+              <a:t>10/5/2026</a:t>
+            </a:fld>
+            <a:endParaRPr lang="en-US"/>
+          </a:p>
+        </p:txBody>
+      </p:sp>
+      <p:sp>
+        <p:nvSpPr>
+          <p:cNvPr id="5" name="Footer Placeholder 4">
+            <a:extLst>
+              <a:ext uri="{FF2B5EF4-FFF2-40B4-BE49-F238E27FC236}">
+                <a16:creationId xmlns:a16="http://schemas.microsoft.com/office/drawing/2014/main" id="{D2CD2B44-AE81-2D59-EF35-488D48E80B04}"/>
+              </a:ext>
+            </a:extLst>
+          </p:cNvPr>
+          <p:cNvSpPr>
+            <a:spLocks noGrp="1"/>
+          </p:cNvSpPr>
+          <p:nvPr>
+            <p:ph type="ftr" sz="quarter" idx="3"/>
+          </p:nvPr>
+        </p:nvSpPr>
+        <p:spPr>
+          <a:xfrm>
+            <a:off x="4038600" y="6356350"/>
+            <a:ext cx="4114800" cy="365125"/>
+          </a:xfrm>
+          <a:prstGeom prst="rect">
+            <a:avLst/>
+          </a:prstGeom>
+        </p:spPr>
+        <p:txBody>
+          <a:bodyPr vert="horz" lIns="91440" tIns="45720" rIns="91440" bIns="45720" rtlCol="0" anchor="ctr"/>
+          <a:lstStyle>
+            <a:lvl1pPr algn="ctr">
+              <a:defRPr sz="1200">
+                <a:solidFill>
+                  <a:schemeClr val="tx1">
+                    <a:tint val="82000"/>
+                  </a:schemeClr>
+                </a:solidFill>
+              </a:defRPr>
+            </a:lvl1pPr>
+          </a:lstStyle>
+          <a:p>
+            <a:endParaRPr lang="en-US"/>
+          </a:p>
+        </p:txBody>
+      </p:sp>
+      <p:sp>
+        <p:nvSpPr>
+          <p:cNvPr id="6" name="Slide Number Placeholder 5">
+            <a:extLst>
+              <a:ext uri="{FF2B5EF4-FFF2-40B4-BE49-F238E27FC236}">
+                <a16:creationId xmlns:a16="http://schemas.microsoft.com/office/drawing/2014/main" id="{954F755E-3A70-91ED-AC02-517E8BD9E114}"/>
+              </a:ext>
+            </a:extLst>
+          </p:cNvPr>
+          <p:cNvSpPr>
+            <a:spLocks noGrp="1"/>
+          </p:cNvSpPr>
+          <p:nvPr>
+            <p:ph type="sldNum" sz="quarter" idx="4"/>
+          </p:nvPr>
+        </p:nvSpPr>
+        <p:spPr>
+          <a:xfrm>
+            <a:off x="8610600" y="6356350"/>
+            <a:ext cx="2743200" cy="365125"/>
+          </a:xfrm>
+          <a:prstGeom prst="rect">
+            <a:avLst/>
+          </a:prstGeom>
+        </p:spPr>
+        <p:txBody>
+          <a:bodyPr vert="horz" lIns="91440" tIns="45720" rIns="91440" bIns="45720" rtlCol="0" anchor="ctr"/>
+          <a:lstStyle>
+            <a:lvl1pPr algn="r">
+              <a:defRPr sz="1200">
+                <a:solidFill>
+                  <a:schemeClr val="tx1">
+                    <a:tint val="82000"/>
+                  </a:schemeClr>
+                </a:solidFill>
+              </a:defRPr>
+            </a:lvl1pPr>
+          </a:lstStyle>
+          <a:p>
+            <a:fld id="{C6DDDF4F-F028-4B81-B3D4-6037FCFC1593}" type="slidenum">
+              <a:rPr lang="en-US" smtClean="0"/>
+              <a:t>‹#›</a:t>
+            </a:fld>
+            <a:endParaRPr lang="en-US"/>
+          </a:p>
+        </p:txBody>
+      </p:sp>
+      <p:sp>
+        <p:nvSpPr>
+          <p:cNvPr id="7" name="Master logo">
+            <a:extLst>
+              <a:ext uri="{FF2B5EF4-FFF2-40B4-BE49-F238E27FC236}">
+                <a16:creationId xmlns:a16="http://schemas.microsoft.com/office/drawing/2014/main" id="{670868CD-C909-BF29-7562-E0BC1DE02FDE}"/>
+              </a:ext>
+            </a:extLst>
+          </p:cNvPr>
+          <p:cNvSpPr/>
+          <p:nvPr userDrawn="1"/>
+        </p:nvSpPr>
+        <p:spPr>
+          <a:xfrm>
+            <a:off x="381000" y="177800"/>
+            <a:ext cx="2794000" cy="381000"/>
+          </a:xfrm>
+          <a:prstGeom prst="rect">
+            <a:avLst/>
+          </a:prstGeom>
+        </p:spPr>
+        <p:style>
+          <a:lnRef idx="2">
+            <a:schemeClr val="accent1">
+              <a:shade val="15000"/>
+            </a:schemeClr>
+          </a:lnRef>
+          <a:fillRef idx="1">
+            <a:schemeClr val="accent1"/>
+          </a:fillRef>
+          <a:effectRef idx="0">
+            <a:schemeClr val="accent1"/>
+          </a:effectRef>
+          <a:fontRef idx="minor">
+            <a:schemeClr val="lt1"/>
+          </a:fontRef>
+        </p:style>
+        <p:txBody>
+          <a:bodyPr rtlCol="0" anchor="ctr"/>
+          <a:lstStyle/>
+          <a:p>
+            <a:pPr algn="ctr"/>
+            <a:r>
+              <a:rPr lang="ar-EG" sz="1400"/>
+              <a:t>شعار الاستوديو</a:t>
+            </a:r>
+            <a:endParaRPr lang="en-US" sz="1400"/>
+          </a:p>
+        </p:txBody>
+      </p:sp>
+    </p:spTree>
+    <p:extLst>
+      <p:ext uri="{BB962C8B-B14F-4D97-AF65-F5344CB8AC3E}">
+        <p14:creationId xmlns:p14="http://schemas.microsoft.com/office/powerpoint/2010/main" val="2184331512"/>
+      </p:ext>
+    </p:extLst>
+  </p:cSld>
+  <p:clrMap bg1="lt1" tx1="dk1" bg2="lt2" tx2="dk2" accent1="accent1" accent2="accent2" accent3="accent3" accent4="accent4" accent5="accent5" accent6="accent6" hlink="hlink" folHlink="folHlink"/>
+  <p:sldLayoutIdLst>
+    <p:sldLayoutId id="2147483672" r:id="rId1"/>
+    <p:sldLayoutId id="2147483673" r:id="rId2"/>
+  </p:sldLayoutIdLst>
+  <p:txStyles>
+    <p:titleStyle>
+      <a:lvl1pPr algn="l" defTabSz="914400" rtl="0" eaLnBrk="1" latinLnBrk="0" hangingPunct="1">
+        <a:lnSpc>
+          <a:spcPct val="90000"/>
+        </a:lnSpc>
+        <a:spcBef>
+          <a:spcPct val="0"/>
+        </a:spcBef>
+        <a:buNone/>
+        <a:defRPr sz="4400" kern="1200">
+          <a:solidFill>
+            <a:schemeClr val="tx1"/>
+          </a:solidFill>
+          <a:latin typeface="+mj-lt"/>
+          <a:ea typeface="+mj-ea"/>
+          <a:cs typeface="+mj-cs"/>
+        </a:defRPr>
+      </a:lvl1pPr>
+    </p:titleStyle>
+    <p:bodyStyle>
+      <a:lvl1pPr marL="228600" indent="-228600" algn="l" defTabSz="914400" rtl="0" eaLnBrk="1" latinLnBrk="0" hangingPunct="1">
+        <a:lnSpc>
+          <a:spcPct val="90000"/>
+        </a:lnSpc>
+        <a:spcBef>
+          <a:spcPts val="1000"/>
+        </a:spcBef>
+        <a:buFont typeface="Arial" panose="020B0604020202020204" pitchFamily="34" charset="0"/>
+        <a:buChar char="•"/>
+        <a:defRPr sz="2800" kern="1200">
+          <a:solidFill>
+            <a:schemeClr val="tx1"/>
+          </a:solidFill>
+          <a:latin typeface="+mn-lt"/>
+          <a:ea typeface="+mn-ea"/>
+          <a:cs typeface="+mn-cs"/>
+        </a:defRPr>
+      </a:lvl1pPr>
+      <a:lvl2pPr marL="685800" indent="-228600" algn="l" defTabSz="914400" rtl="0" eaLnBrk="1" latinLnBrk="0" hangingPunct="1">
+        <a:lnSpc>
+          <a:spcPct val="90000"/>
+        </a:lnSpc>
+        <a:spcBef>
+          <a:spcPts val="500"/>
+        </a:spcBef>
+        <a:buFont typeface="Arial" panose="020B0604020202020204" pitchFamily="34" charset="0"/>
+        <a:buChar char="•"/>
+        <a:defRPr sz="2400" kern="1200">
+          <a:solidFill>
+            <a:schemeClr val="tx1"/>
+          </a:solidFill>
+          <a:latin typeface="+mn-lt"/>
+          <a:ea typeface="+mn-ea"/>
+          <a:cs typeface="+mn-cs"/>
+        </a:defRPr>
+      </a:lvl2pPr>
+      <a:lvl3pPr marL="1143000" indent="-228600" algn="l" defTabSz="914400" rtl="0" eaLnBrk="1" latinLnBrk="0" hangingPunct="1">
+        <a:lnSpc>
+          <a:spcPct val="90000"/>
+        </a:lnSpc>
+        <a:spcBef>
+          <a:spcPts val="500"/>
+        </a:spcBef>
+        <a:buFont typeface="Arial" panose="020B0604020202020204" pitchFamily="34" charset="0"/>
+        <a:buChar char="•"/>
+        <a:defRPr sz="2000" kern="1200">
+          <a:solidFill>
+            <a:schemeClr val="tx1"/>
+          </a:solidFill>
+          <a:latin typeface="+mn-lt"/>
+          <a:ea typeface="+mn-ea"/>
+          <a:cs typeface="+mn-cs"/>
+        </a:defRPr>
+      </a:lvl3pPr>
+      <a:lvl4pPr marL="1600200" indent="-228600" algn="l" defTabSz="914400" rtl="0" eaLnBrk="1" latinLnBrk="0" hangingPunct="1">
+        <a:lnSpc>
+          <a:spcPct val="90000"/>
+        </a:lnSpc>
+        <a:spcBef>
+          <a:spcPts val="500"/>
+        </a:spcBef>
+        <a:buFont typeface="Arial" panose="020B0604020202020204" pitchFamily="34" charset="0"/>
+        <a:buChar char="•"/>
+        <a:defRPr sz="1800" kern="1200">
+          <a:solidFill>
+            <a:schemeClr val="tx1"/>
+          </a:solidFill>
+          <a:latin typeface="+mn-lt"/>
+          <a:ea typeface="+mn-ea"/>
+          <a:cs typeface="+mn-cs"/>
+        </a:defRPr>
+      </a:lvl4pPr>
+      <a:lvl5pPr marL="2057400" indent="-228600" algn="l" defTabSz="914400" rtl="0" eaLnBrk="1" latinLnBrk="0" hangingPunct="1">
+        <a:lnSpc>
+          <a:spcPct val="90000"/>
+        </a:lnSpc>
+        <a:spcBef>
+          <a:spcPts val="500"/>
+        </a:spcBef>
+        <a:buFont typeface="Arial" panose="020B0604020202020204" pitchFamily="34" charset="0"/>
+        <a:buChar char="•"/>
+        <a:defRPr sz="1800" kern="1200">
+          <a:solidFill>
+            <a:schemeClr val="tx1"/>
+          </a:solidFill>
+          <a:latin typeface="+mn-lt"/>
+          <a:ea typeface="+mn-ea"/>
+          <a:cs typeface="+mn-cs"/>
+        </a:defRPr>
+      </a:lvl5pPr>
+      <a:lvl6pPr marL="2514600" indent="-228600" algn="l" defTabSz="914400" rtl="0" eaLnBrk="1" latinLnBrk="0" hangingPunct="1">
+        <a:lnSpc>
+          <a:spcPct val="90000"/>
+        </a:lnSpc>
+        <a:spcBef>
+          <a:spcPts val="500"/>
+        </a:spcBef>
+        <a:buFont typeface="Arial" panose="020B0604020202020204" pitchFamily="34" charset="0"/>
+        <a:buChar char="•"/>
+        <a:defRPr sz="1800" kern="1200">
+          <a:solidFill>
+            <a:schemeClr val="tx1"/>
+          </a:solidFill>
+          <a:latin typeface="+mn-lt"/>
+          <a:ea typeface="+mn-ea"/>
+          <a:cs typeface="+mn-cs"/>
+        </a:defRPr>
+      </a:lvl6pPr>
+      <a:lvl7pPr marL="2971800" indent="-228600" algn="l" defTabSz="914400" rtl="0" eaLnBrk="1" latinLnBrk="0" hangingPunct="1">
+        <a:lnSpc>
+          <a:spcPct val="90000"/>
+        </a:lnSpc>
+        <a:spcBef>
+          <a:spcPts val="500"/>
+        </a:spcBef>
+        <a:buFont typeface="Arial" panose="020B0604020202020204" pitchFamily="34" charset="0"/>
+        <a:buChar char="•"/>
+        <a:defRPr sz="1800" kern="1200">
+          <a:solidFill>
+            <a:schemeClr val="tx1"/>
+          </a:solidFill>
+          <a:latin typeface="+mn-lt"/>
+          <a:ea typeface="+mn-ea"/>
+          <a:cs typeface="+mn-cs"/>
+        </a:defRPr>
+      </a:lvl7pPr>
+      <a:lvl8pPr marL="3429000" indent="-228600" algn="l" defTabSz="914400" rtl="0" eaLnBrk="1" latinLnBrk="0" hangingPunct="1">
+        <a:lnSpc>
+          <a:spcPct val="90000"/>
+        </a:lnSpc>
+        <a:spcBef>
+          <a:spcPts val="500"/>
+        </a:spcBef>
+        <a:buFont typeface="Arial" panose="020B0604020202020204" pitchFamily="34" charset="0"/>
+        <a:buChar char="•"/>
+        <a:defRPr sz="1800" kern="1200">
+          <a:solidFill>
+            <a:schemeClr val="tx1"/>
+          </a:solidFill>
+          <a:latin typeface="+mn-lt"/>
+          <a:ea typeface="+mn-ea"/>
+          <a:cs typeface="+mn-cs"/>
+        </a:defRPr>
+      </a:lvl8pPr>
+      <a:lvl9pPr marL="3886200" indent="-228600" algn="l" defTabSz="914400" rtl="0" eaLnBrk="1" latinLnBrk="0" hangingPunct="1">
+        <a:lnSpc>
+          <a:spcPct val="90000"/>
+        </a:lnSpc>
+        <a:spcBef>
+          <a:spcPts val="500"/>
+        </a:spcBef>
+        <a:buFont typeface="Arial" panose="020B0604020202020204" pitchFamily="34" charset="0"/>
+        <a:buChar char="•"/>
+        <a:defRPr sz="1800" kern="1200">
+          <a:solidFill>
+            <a:schemeClr val="tx1"/>
+          </a:solidFill>
+          <a:latin typeface="+mn-lt"/>
+          <a:ea typeface="+mn-ea"/>
+          <a:cs typeface="+mn-cs"/>
+        </a:defRPr>
+      </a:lvl9pPr>
+    </p:bodyStyle>
+    <p:otherStyle>
+      <a:defPPr>
+        <a:defRPr lang="en-US"/>
+      </a:defPPr>
+      <a:lvl1pPr marL="0" algn="l" defTabSz="914400" rtl="0" eaLnBrk="1" latinLnBrk="0" hangingPunct="1">
+        <a:defRPr sz="1800" kern="1200">
+          <a:solidFill>
+            <a:schemeClr val="tx1"/>
+          </a:solidFill>
+          <a:latin typeface="+mn-lt"/>
+          <a:ea typeface="+mn-ea"/>
+          <a:cs typeface="+mn-cs"/>
+        </a:defRPr>
+      </a:lvl1pPr>
+      <a:lvl2pPr marL="457200" algn="l" defTabSz="914400" rtl="0" eaLnBrk="1" latinLnBrk="0" hangingPunct="1">
+        <a:defRPr sz="1800" kern="1200">
+          <a:solidFill>
+            <a:schemeClr val="tx1"/>
+          </a:solidFill>
+          <a:latin typeface="+mn-lt"/>
+          <a:ea typeface="+mn-ea"/>
+          <a:cs typeface="+mn-cs"/>
+        </a:defRPr>
+      </a:lvl2pPr>
+      <a:lvl3pPr marL="914400" algn="l" defTabSz="914400" rtl="0" eaLnBrk="1" latinLnBrk="0" hangingPunct="1">
+        <a:defRPr sz="1800" kern="1200">
+          <a:solidFill>
+            <a:schemeClr val="tx1"/>
+          </a:solidFill>
+          <a:latin typeface="+mn-lt"/>
+          <a:ea typeface="+mn-ea"/>
+          <a:cs typeface="+mn-cs"/>
+        </a:defRPr>
+      </a:lvl3pPr>
+      <a:lvl4pPr marL="1371600" algn="l" defTabSz="914400" rtl="0" eaLnBrk="1" latinLnBrk="0" hangingPunct="1">
+        <a:defRPr sz="1800" kern="1200">
+          <a:solidFill>
+            <a:schemeClr val="tx1"/>
+          </a:solidFill>
+          <a:latin typeface="+mn-lt"/>
+          <a:ea typeface="+mn-ea"/>
+          <a:cs typeface="+mn-cs"/>
+        </a:defRPr>
+      </a:lvl4pPr>
+      <a:lvl5pPr marL="1828800" algn="l" defTabSz="914400" rtl="0" eaLnBrk="1" latinLnBrk="0" hangingPunct="1">
+        <a:defRPr sz="1800" kern="1200">
+          <a:solidFill>
+            <a:schemeClr val="tx1"/>
+          </a:solidFill>
+          <a:latin typeface="+mn-lt"/>
+          <a:ea typeface="+mn-ea"/>
+          <a:cs typeface="+mn-cs"/>
+        </a:defRPr>
+      </a:lvl5pPr>
+      <a:lvl6pPr marL="2286000" algn="l" defTabSz="914400" rtl="0" eaLnBrk="1" latinLnBrk="0" hangingPunct="1">
+        <a:defRPr sz="1800" kern="1200">
+          <a:solidFill>
+            <a:schemeClr val="tx1"/>
+          </a:solidFill>
+          <a:latin typeface="+mn-lt"/>
+          <a:ea typeface="+mn-ea"/>
+          <a:cs typeface="+mn-cs"/>
+        </a:defRPr>
+      </a:lvl6pPr>
+      <a:lvl7pPr marL="2743200" algn="l" defTabSz="914400" rtl="0" eaLnBrk="1" latinLnBrk="0" hangingPunct="1">
+        <a:defRPr sz="1800" kern="1200">
+          <a:solidFill>
+            <a:schemeClr val="tx1"/>
+          </a:solidFill>
+          <a:latin typeface="+mn-lt"/>
+          <a:ea typeface="+mn-ea"/>
+          <a:cs typeface="+mn-cs"/>
+        </a:defRPr>
+      </a:lvl7pPr>
+      <a:lvl8pPr marL="3200400" algn="l" defTabSz="914400" rtl="0" eaLnBrk="1" latinLnBrk="0" hangingPunct="1">
+        <a:defRPr sz="1800" kern="1200">
+          <a:solidFill>
+            <a:schemeClr val="tx1"/>
+          </a:solidFill>
+          <a:latin typeface="+mn-lt"/>
+          <a:ea typeface="+mn-ea"/>
+          <a:cs typeface="+mn-cs"/>
+        </a:defRPr>
+      </a:lvl8pPr>
+      <a:lvl9pPr marL="3657600" algn="l" defTabSz="914400" rtl="0" eaLnBrk="1" latinLnBrk="0" hangingPunct="1">
+        <a:defRPr sz="1800" kern="1200">
+          <a:solidFill>
+            <a:schemeClr val="tx1"/>
+          </a:solidFill>
+          <a:latin typeface="+mn-lt"/>
+          <a:ea typeface="+mn-ea"/>
+          <a:cs typeface="+mn-cs"/>
+        </a:defRPr>
+      </a:lvl9pPr>
+    </p:otherStyle>
+  </p:txStyles>
+</p:sldMaster>
+</file>
+
 <file path=ppt/slides/slide1.xml><?xml version="1.0" encoding="utf-8"?>
 <p:sld xmlns:a="http://schemas.openxmlformats.org/drawingml/2006/main" xmlns:r="http://schemas.openxmlformats.org/officeDocument/2006/relationships" xmlns:p="http://schemas.openxmlformats.org/presentationml/2006/main">
   <p:cSld>
@@ -5185,6 +6694,986 @@
     <p:extLst>
       <p:ext uri="{BB962C8B-B14F-4D97-AF65-F5344CB8AC3E}">
         <p14:creationId xmlns:p14="http://schemas.microsoft.com/office/powerpoint/2010/main" val="596326689"/>
+      </p:ext>
+    </p:extLst>
+  </p:cSld>
+  <p:clrMapOvr>
+    <a:masterClrMapping/>
+  </p:clrMapOvr>
+</p:sld>
+</file>
+
+<file path=ppt/slides/slide13.xml><?xml version="1.0" encoding="utf-8"?>
+<p:sld xmlns:a="http://schemas.openxmlformats.org/drawingml/2006/main" xmlns:r="http://schemas.openxmlformats.org/officeDocument/2006/relationships" xmlns:p="http://schemas.openxmlformats.org/presentationml/2006/main">
+  <p:cSld>
+    <p:spTree>
+      <p:nvGrpSpPr>
+        <p:cNvPr id="1" name=""/>
+        <p:cNvGrpSpPr/>
+        <p:nvPr/>
+      </p:nvGrpSpPr>
+      <p:grpSpPr>
+        <a:xfrm>
+          <a:off x="0" y="0"/>
+          <a:ext cx="0" cy="0"/>
+          <a:chOff x="0" y="0"/>
+          <a:chExt cx="0" cy="0"/>
+        </a:xfrm>
+      </p:grpSpPr>
+      <p:sp>
+        <p:nvSpPr>
+          <p:cNvPr id="4" name="Slide Number Placeholder 3">
+            <a:extLst>
+              <a:ext uri="{FF2B5EF4-FFF2-40B4-BE49-F238E27FC236}">
+                <a16:creationId xmlns:a16="http://schemas.microsoft.com/office/drawing/2014/main" id="{7CF73C67-6A8A-5856-CE07-81FF7A124167}"/>
+              </a:ext>
+            </a:extLst>
+          </p:cNvPr>
+          <p:cNvSpPr>
+            <a:spLocks noGrp="1"/>
+          </p:cNvSpPr>
+          <p:nvPr>
+            <p:ph type="sldNum" sz="quarter" idx="12"/>
+          </p:nvPr>
+        </p:nvSpPr>
+        <p:spPr/>
+        <p:txBody>
+          <a:bodyPr/>
+          <a:lstStyle/>
+          <a:p>
+            <a:fld id="{DCB96425-C66E-449F-8335-3FF27AC80FA3}" type="slidenum">
+              <a:rPr lang="en-US" smtClean="0"/>
+              <a:t>13</a:t>
+            </a:fld>
+            <a:endParaRPr lang="en-US"/>
+          </a:p>
+        </p:txBody>
+      </p:sp>
+      <p:sp>
+        <p:nvSpPr>
+          <p:cNvPr id="5" name="Title">
+            <a:extLst>
+              <a:ext uri="{FF2B5EF4-FFF2-40B4-BE49-F238E27FC236}">
+                <a16:creationId xmlns:a16="http://schemas.microsoft.com/office/drawing/2014/main" id="{34958500-4107-66AD-9E57-FD96394F86E1}"/>
+              </a:ext>
+            </a:extLst>
+          </p:cNvPr>
+          <p:cNvSpPr txBox="1"/>
+          <p:nvPr/>
+        </p:nvSpPr>
+        <p:spPr>
+          <a:xfrm>
+            <a:off x="0" y="304800"/>
+            <a:ext cx="12192000" cy="523220"/>
+          </a:xfrm>
+          <a:prstGeom prst="rect">
+            <a:avLst/>
+          </a:prstGeom>
+          <a:noFill/>
+        </p:spPr>
+        <p:txBody>
+          <a:bodyPr vert="horz" rtlCol="0">
+            <a:spAutoFit/>
+          </a:bodyPr>
+          <a:lstStyle/>
+          <a:p>
+            <a:pPr algn="ctr" rtl="1"/>
+            <a:r>
+              <a:rPr lang="ar-EG" sz="2800"/>
+              <a:t>خلايا مدمجة</a:t>
+            </a:r>
+            <a:endParaRPr lang="en-US" sz="2800"/>
+          </a:p>
+        </p:txBody>
+      </p:sp>
+      <p:graphicFrame>
+        <p:nvGraphicFramePr>
+          <p:cNvPr id="2" name="Merged cells">
+            <a:extLst>
+              <a:ext uri="{FF2B5EF4-FFF2-40B4-BE49-F238E27FC236}">
+                <a16:creationId xmlns:a16="http://schemas.microsoft.com/office/drawing/2014/main" id="{AE1598A0-8E6D-5F0B-76FF-1530671F5E8F}"/>
+              </a:ext>
+            </a:extLst>
+          </p:cNvPr>
+          <p:cNvGraphicFramePr>
+            <a:graphicFrameLocks noGrp="1"/>
+          </p:cNvGraphicFramePr>
+          <p:nvPr>
+            <p:extLst>
+              <p:ext uri="{D42A27DB-BD31-4B8C-83A1-F6EECF244321}">
+                <p14:modId xmlns:p14="http://schemas.microsoft.com/office/powerpoint/2010/main" val="4144017258"/>
+              </p:ext>
+            </p:extLst>
+          </p:nvPr>
+        </p:nvGraphicFramePr>
+        <p:xfrm>
+          <a:off x="762000" y="1651000"/>
+          <a:ext cx="10668000" cy="3302000"/>
+        </p:xfrm>
+        <a:graphic>
+          <a:graphicData uri="http://schemas.openxmlformats.org/drawingml/2006/table">
+            <a:tbl>
+              <a:tblPr firstRow="1" bandRow="1">
+                <a:tableStyleId>{5C22544A-7EE6-4342-B048-85BDC9FD1C3A}</a:tableStyleId>
+              </a:tblPr>
+              <a:tblGrid>
+                <a:gridCol w="2667000">
+                  <a:extLst>
+                    <a:ext uri="{9D8B030D-6E8A-4147-A177-3AD203B41FA5}">
+                      <a16:colId xmlns:a16="http://schemas.microsoft.com/office/drawing/2014/main" val="1604742891"/>
+                    </a:ext>
+                  </a:extLst>
+                </a:gridCol>
+                <a:gridCol w="2667000">
+                  <a:extLst>
+                    <a:ext uri="{9D8B030D-6E8A-4147-A177-3AD203B41FA5}">
+                      <a16:colId xmlns:a16="http://schemas.microsoft.com/office/drawing/2014/main" val="3722589525"/>
+                    </a:ext>
+                  </a:extLst>
+                </a:gridCol>
+                <a:gridCol w="2667000">
+                  <a:extLst>
+                    <a:ext uri="{9D8B030D-6E8A-4147-A177-3AD203B41FA5}">
+                      <a16:colId xmlns:a16="http://schemas.microsoft.com/office/drawing/2014/main" val="1829845810"/>
+                    </a:ext>
+                  </a:extLst>
+                </a:gridCol>
+                <a:gridCol w="2667000">
+                  <a:extLst>
+                    <a:ext uri="{9D8B030D-6E8A-4147-A177-3AD203B41FA5}">
+                      <a16:colId xmlns:a16="http://schemas.microsoft.com/office/drawing/2014/main" val="3177147476"/>
+                    </a:ext>
+                  </a:extLst>
+                </a:gridCol>
+              </a:tblGrid>
+              <a:tr h="825500">
+                <a:tc gridSpan="2">
+                  <a:txBody>
+                    <a:bodyPr/>
+                    <a:lstStyle/>
+                    <a:p>
+                      <a:r>
+                        <a:rPr lang="ar-EG"/>
+                        <a:t>العنوان المدمج</a:t>
+                      </a:r>
+                      <a:endParaRPr lang="en-US"/>
+                    </a:p>
+                  </a:txBody>
+                  <a:tcPr/>
+                </a:tc>
+                <a:tc hMerge="1">
+                  <a:txBody>
+                    <a:bodyPr/>
+                    <a:lstStyle/>
+                    <a:p>
+                      <a:endParaRPr lang="en-US"/>
+                    </a:p>
+                  </a:txBody>
+                  <a:tcPr/>
+                </a:tc>
+                <a:tc>
+                  <a:txBody>
+                    <a:bodyPr/>
+                    <a:lstStyle/>
+                    <a:p>
+                      <a:r>
+                        <a:rPr lang="ar-EG"/>
+                        <a:t>الحالة</a:t>
+                      </a:r>
+                      <a:endParaRPr lang="en-US"/>
+                    </a:p>
+                  </a:txBody>
+                  <a:tcPr/>
+                </a:tc>
+                <a:tc>
+                  <a:txBody>
+                    <a:bodyPr/>
+                    <a:lstStyle/>
+                    <a:p>
+                      <a:r>
+                        <a:rPr lang="ar-EG"/>
+                        <a:t>المبلغ</a:t>
+                      </a:r>
+                      <a:endParaRPr lang="en-US"/>
+                    </a:p>
+                  </a:txBody>
+                  <a:tcPr/>
+                </a:tc>
+                <a:extLst>
+                  <a:ext uri="{0D108BD9-81ED-4DB2-BD59-A6C34878D82A}">
+                    <a16:rowId xmlns:a16="http://schemas.microsoft.com/office/drawing/2014/main" val="148934365"/>
+                  </a:ext>
+                </a:extLst>
+              </a:tr>
+              <a:tr h="825500">
+                <a:tc>
+                  <a:txBody>
+                    <a:bodyPr/>
+                    <a:lstStyle/>
+                    <a:p>
+                      <a:r>
+                        <a:rPr lang="ar-EG"/>
+                        <a:t>التصوير</a:t>
+                      </a:r>
+                      <a:endParaRPr lang="en-US"/>
+                    </a:p>
+                  </a:txBody>
+                  <a:tcPr/>
+                </a:tc>
+                <a:tc>
+                  <a:txBody>
+                    <a:bodyPr/>
+                    <a:lstStyle/>
+                    <a:p>
+                      <a:r>
+                        <a:rPr lang="en-US"/>
+                        <a:t>٣</a:t>
+                      </a:r>
+                    </a:p>
+                  </a:txBody>
+                  <a:tcPr/>
+                </a:tc>
+                <a:tc rowSpan="2">
+                  <a:txBody>
+                    <a:bodyPr/>
+                    <a:lstStyle/>
+                    <a:p>
+                      <a:r>
+                        <a:rPr lang="ar-EG"/>
+                        <a:t>جارٍ</a:t>
+                      </a:r>
+                      <a:endParaRPr lang="en-US"/>
+                    </a:p>
+                  </a:txBody>
+                  <a:tcPr/>
+                </a:tc>
+                <a:tc>
+                  <a:txBody>
+                    <a:bodyPr/>
+                    <a:lstStyle/>
+                    <a:p>
+                      <a:r>
+                        <a:rPr lang="en-US"/>
+                        <a:t>٤٠</a:t>
+                      </a:r>
+                    </a:p>
+                  </a:txBody>
+                  <a:tcPr/>
+                </a:tc>
+                <a:extLst>
+                  <a:ext uri="{0D108BD9-81ED-4DB2-BD59-A6C34878D82A}">
+                    <a16:rowId xmlns:a16="http://schemas.microsoft.com/office/drawing/2014/main" val="2271396686"/>
+                  </a:ext>
+                </a:extLst>
+              </a:tr>
+              <a:tr h="825500">
+                <a:tc>
+                  <a:txBody>
+                    <a:bodyPr/>
+                    <a:lstStyle/>
+                    <a:p>
+                      <a:r>
+                        <a:rPr lang="ar-EG"/>
+                        <a:t>المونتاج</a:t>
+                      </a:r>
+                      <a:endParaRPr lang="en-US"/>
+                    </a:p>
+                  </a:txBody>
+                  <a:tcPr/>
+                </a:tc>
+                <a:tc>
+                  <a:txBody>
+                    <a:bodyPr/>
+                    <a:lstStyle/>
+                    <a:p>
+                      <a:r>
+                        <a:rPr lang="en-US"/>
+                        <a:t>٢</a:t>
+                      </a:r>
+                    </a:p>
+                  </a:txBody>
+                  <a:tcPr/>
+                </a:tc>
+                <a:tc vMerge="1">
+                  <a:txBody>
+                    <a:bodyPr/>
+                    <a:lstStyle/>
+                    <a:p>
+                      <a:endParaRPr lang="en-US"/>
+                    </a:p>
+                  </a:txBody>
+                  <a:tcPr/>
+                </a:tc>
+                <a:tc>
+                  <a:txBody>
+                    <a:bodyPr/>
+                    <a:lstStyle/>
+                    <a:p>
+                      <a:r>
+                        <a:rPr lang="en-US"/>
+                        <a:t>٣٠</a:t>
+                      </a:r>
+                    </a:p>
+                  </a:txBody>
+                  <a:tcPr/>
+                </a:tc>
+                <a:extLst>
+                  <a:ext uri="{0D108BD9-81ED-4DB2-BD59-A6C34878D82A}">
+                    <a16:rowId xmlns:a16="http://schemas.microsoft.com/office/drawing/2014/main" val="1854552322"/>
+                  </a:ext>
+                </a:extLst>
+              </a:tr>
+              <a:tr h="825500">
+                <a:tc>
+                  <a:txBody>
+                    <a:bodyPr/>
+                    <a:lstStyle/>
+                    <a:p>
+                      <a:r>
+                        <a:rPr lang="ar-EG"/>
+                        <a:t>الصوت</a:t>
+                      </a:r>
+                      <a:endParaRPr lang="en-US"/>
+                    </a:p>
+                  </a:txBody>
+                  <a:tcPr/>
+                </a:tc>
+                <a:tc>
+                  <a:txBody>
+                    <a:bodyPr/>
+                    <a:lstStyle/>
+                    <a:p>
+                      <a:r>
+                        <a:rPr lang="en-US"/>
+                        <a:t>١</a:t>
+                      </a:r>
+                    </a:p>
+                  </a:txBody>
+                  <a:tcPr/>
+                </a:tc>
+                <a:tc>
+                  <a:txBody>
+                    <a:bodyPr/>
+                    <a:lstStyle/>
+                    <a:p>
+                      <a:r>
+                        <a:rPr lang="ar-EG"/>
+                        <a:t>تم</a:t>
+                      </a:r>
+                      <a:endParaRPr lang="en-US"/>
+                    </a:p>
+                  </a:txBody>
+                  <a:tcPr/>
+                </a:tc>
+                <a:tc>
+                  <a:txBody>
+                    <a:bodyPr/>
+                    <a:lstStyle/>
+                    <a:p>
+                      <a:r>
+                        <a:rPr lang="en-US"/>
+                        <a:t>٢٠</a:t>
+                      </a:r>
+                    </a:p>
+                  </a:txBody>
+                  <a:tcPr/>
+                </a:tc>
+                <a:extLst>
+                  <a:ext uri="{0D108BD9-81ED-4DB2-BD59-A6C34878D82A}">
+                    <a16:rowId xmlns:a16="http://schemas.microsoft.com/office/drawing/2014/main" val="219908762"/>
+                  </a:ext>
+                </a:extLst>
+              </a:tr>
+            </a:tbl>
+          </a:graphicData>
+        </a:graphic>
+      </p:graphicFrame>
+    </p:spTree>
+    <p:extLst>
+      <p:ext uri="{BB962C8B-B14F-4D97-AF65-F5344CB8AC3E}">
+        <p14:creationId xmlns:p14="http://schemas.microsoft.com/office/powerpoint/2010/main" val="379884370"/>
+      </p:ext>
+    </p:extLst>
+  </p:cSld>
+  <p:clrMapOvr>
+    <a:masterClrMapping/>
+  </p:clrMapOvr>
+</p:sld>
+</file>
+
+<file path=ppt/slides/slide14.xml><?xml version="1.0" encoding="utf-8"?>
+<p:sld xmlns:a="http://schemas.openxmlformats.org/drawingml/2006/main" xmlns:r="http://schemas.openxmlformats.org/officeDocument/2006/relationships" xmlns:p="http://schemas.openxmlformats.org/presentationml/2006/main">
+  <p:cSld>
+    <p:spTree>
+      <p:nvGrpSpPr>
+        <p:cNvPr id="1" name=""/>
+        <p:cNvGrpSpPr/>
+        <p:nvPr/>
+      </p:nvGrpSpPr>
+      <p:grpSpPr>
+        <a:xfrm>
+          <a:off x="0" y="0"/>
+          <a:ext cx="0" cy="0"/>
+          <a:chOff x="0" y="0"/>
+          <a:chExt cx="0" cy="0"/>
+        </a:xfrm>
+      </p:grpSpPr>
+      <p:sp>
+        <p:nvSpPr>
+          <p:cNvPr id="2" name="Title 1">
+            <a:extLst>
+              <a:ext uri="{FF2B5EF4-FFF2-40B4-BE49-F238E27FC236}">
+                <a16:creationId xmlns:a16="http://schemas.microsoft.com/office/drawing/2014/main" id="{82C31481-920F-16EE-8F2C-E3D3E438664F}"/>
+              </a:ext>
+            </a:extLst>
+          </p:cNvPr>
+          <p:cNvSpPr>
+            <a:spLocks noGrp="1"/>
+          </p:cNvSpPr>
+          <p:nvPr>
+            <p:ph type="title"/>
+          </p:nvPr>
+        </p:nvSpPr>
+        <p:spPr/>
+        <p:txBody>
+          <a:bodyPr/>
+          <a:lstStyle/>
+          <a:p>
+            <a:r>
+              <a:rPr lang="ar-EG"/>
+              <a:t>الشلال: الميزانية</a:t>
+            </a:r>
+            <a:endParaRPr lang="en-US"/>
+          </a:p>
+        </p:txBody>
+      </p:sp>
+      <p:sp>
+        <p:nvSpPr>
+          <p:cNvPr id="3" name="Content Placeholder 2">
+            <a:extLst>
+              <a:ext uri="{FF2B5EF4-FFF2-40B4-BE49-F238E27FC236}">
+                <a16:creationId xmlns:a16="http://schemas.microsoft.com/office/drawing/2014/main" id="{FAA40049-449A-0FE1-2FA9-5518F226F93B}"/>
+              </a:ext>
+            </a:extLst>
+          </p:cNvPr>
+          <p:cNvSpPr>
+            <a:spLocks noGrp="1"/>
+          </p:cNvSpPr>
+          <p:nvPr>
+            <p:ph idx="1"/>
+          </p:nvPr>
+        </p:nvSpPr>
+        <p:spPr/>
+        <p:txBody>
+          <a:bodyPr/>
+          <a:lstStyle/>
+          <a:p>
+            <a:endParaRPr lang="en-US"/>
+          </a:p>
+        </p:txBody>
+      </p:sp>
+      <p:sp>
+        <p:nvSpPr>
+          <p:cNvPr id="4" name="Slide Number Placeholder 3">
+            <a:extLst>
+              <a:ext uri="{FF2B5EF4-FFF2-40B4-BE49-F238E27FC236}">
+                <a16:creationId xmlns:a16="http://schemas.microsoft.com/office/drawing/2014/main" id="{BE6F8DE4-C774-EA08-E8C7-F6F1E63C14F2}"/>
+              </a:ext>
+            </a:extLst>
+          </p:cNvPr>
+          <p:cNvSpPr>
+            <a:spLocks noGrp="1"/>
+          </p:cNvSpPr>
+          <p:nvPr>
+            <p:ph type="sldNum" sz="quarter" idx="12"/>
+          </p:nvPr>
+        </p:nvSpPr>
+        <p:spPr/>
+        <p:txBody>
+          <a:bodyPr/>
+          <a:lstStyle/>
+          <a:p>
+            <a:fld id="{DCB96425-C66E-449F-8335-3FF27AC80FA3}" type="slidenum">
+              <a:rPr lang="en-US" smtClean="0"/>
+              <a:t>14</a:t>
+            </a:fld>
+            <a:endParaRPr lang="en-US"/>
+          </a:p>
+        </p:txBody>
+      </p:sp>
+      <mc:AlternateContent xmlns:mc="http://schemas.openxmlformats.org/markup-compatibility/2006" xmlns:cx1="http://schemas.microsoft.com/office/drawing/2015/9/8/chartex">
+        <mc:Choice Requires="cx1">
+          <p:graphicFrame>
+            <p:nvGraphicFramePr>
+              <p:cNvPr id="5" name="Waterfall">
+                <a:extLst>
+                  <a:ext uri="{FF2B5EF4-FFF2-40B4-BE49-F238E27FC236}">
+                    <a16:creationId xmlns:a16="http://schemas.microsoft.com/office/drawing/2014/main" id="{4D78685F-76BC-638B-33C2-757D774A6E75}"/>
+                  </a:ext>
+                </a:extLst>
+              </p:cNvPr>
+              <p:cNvGraphicFramePr/>
+              <p:nvPr>
+                <p:extLst>
+                  <p:ext uri="{D42A27DB-BD31-4B8C-83A1-F6EECF244321}">
+                    <p14:modId xmlns:p14="http://schemas.microsoft.com/office/powerpoint/2010/main" val="326830524"/>
+                  </p:ext>
+                </p:extLst>
+              </p:nvPr>
+            </p:nvGraphicFramePr>
+            <p:xfrm>
+              <a:off x="1016000" y="1651000"/>
+              <a:ext cx="10160000" cy="4318000"/>
+            </p:xfrm>
+            <a:graphic>
+              <a:graphicData uri="http://schemas.microsoft.com/office/drawing/2014/chartex">
+                <cx:chart xmlns:cx="http://schemas.microsoft.com/office/drawing/2014/chartex" xmlns:r="http://schemas.openxmlformats.org/officeDocument/2006/relationships" r:id="rId2"/>
+              </a:graphicData>
+            </a:graphic>
+          </p:graphicFrame>
+        </mc:Choice>
+        <mc:Fallback xmlns="">
+          <p:pic>
+            <p:nvPicPr>
+              <p:cNvPr id="5" name="Waterfall">
+                <a:extLst>
+                  <a:ext uri="{FF2B5EF4-FFF2-40B4-BE49-F238E27FC236}">
+                    <a16:creationId xmlns:a16="http://schemas.microsoft.com/office/drawing/2014/main" id="{4D78685F-76BC-638B-33C2-757D774A6E75}"/>
+                  </a:ext>
+                </a:extLst>
+              </p:cNvPr>
+              <p:cNvPicPr>
+                <a:picLocks noGrp="1" noRot="1" noChangeAspect="1" noMove="1" noResize="1" noEditPoints="1" noAdjustHandles="1" noChangeArrowheads="1" noChangeShapeType="1"/>
+              </p:cNvPicPr>
+              <p:nvPr/>
+            </p:nvPicPr>
+            <p:blipFill>
+              <a:blip r:embed="rId3"/>
+              <a:stretch>
+                <a:fillRect/>
+              </a:stretch>
+            </p:blipFill>
+            <p:spPr>
+              <a:xfrm>
+                <a:off x="1016000" y="1651000"/>
+                <a:ext cx="10160000" cy="4318000"/>
+              </a:xfrm>
+              <a:prstGeom prst="rect">
+                <a:avLst/>
+              </a:prstGeom>
+            </p:spPr>
+          </p:pic>
+        </mc:Fallback>
+      </mc:AlternateContent>
+    </p:spTree>
+    <p:extLst>
+      <p:ext uri="{BB962C8B-B14F-4D97-AF65-F5344CB8AC3E}">
+        <p14:creationId xmlns:p14="http://schemas.microsoft.com/office/powerpoint/2010/main" val="3749411348"/>
+      </p:ext>
+    </p:extLst>
+  </p:cSld>
+  <p:clrMapOvr>
+    <a:masterClrMapping/>
+  </p:clrMapOvr>
+</p:sld>
+</file>
+
+<file path=ppt/slides/slide15.xml><?xml version="1.0" encoding="utf-8"?>
+<p:sld xmlns:a="http://schemas.openxmlformats.org/drawingml/2006/main" xmlns:r="http://schemas.openxmlformats.org/officeDocument/2006/relationships" xmlns:p="http://schemas.openxmlformats.org/presentationml/2006/main">
+  <p:cSld>
+    <p:spTree>
+      <p:nvGrpSpPr>
+        <p:cNvPr id="1" name=""/>
+        <p:cNvGrpSpPr/>
+        <p:nvPr/>
+      </p:nvGrpSpPr>
+      <p:grpSpPr>
+        <a:xfrm>
+          <a:off x="0" y="0"/>
+          <a:ext cx="0" cy="0"/>
+          <a:chOff x="0" y="0"/>
+          <a:chExt cx="0" cy="0"/>
+        </a:xfrm>
+      </p:grpSpPr>
+      <p:sp>
+        <p:nvSpPr>
+          <p:cNvPr id="2" name="Title">
+            <a:extLst>
+              <a:ext uri="{FF2B5EF4-FFF2-40B4-BE49-F238E27FC236}">
+                <a16:creationId xmlns:a16="http://schemas.microsoft.com/office/drawing/2014/main" id="{772041BC-3873-0E2D-B108-BBFB268BFD3C}"/>
+              </a:ext>
+            </a:extLst>
+          </p:cNvPr>
+          <p:cNvSpPr>
+            <a:spLocks noGrp="1"/>
+          </p:cNvSpPr>
+          <p:nvPr>
+            <p:ph type="title"/>
+          </p:nvPr>
+        </p:nvSpPr>
+        <p:spPr/>
+        <p:txBody>
+          <a:bodyPr/>
+          <a:lstStyle/>
+          <a:p>
+            <a:r>
+              <a:rPr lang="ar-EG"/>
+              <a:t>شريحة على التخطيط أ</a:t>
+            </a:r>
+            <a:endParaRPr lang="en-US"/>
+          </a:p>
+        </p:txBody>
+      </p:sp>
+      <p:sp>
+        <p:nvSpPr>
+          <p:cNvPr id="3" name="Slide Number Placeholder 2">
+            <a:extLst>
+              <a:ext uri="{FF2B5EF4-FFF2-40B4-BE49-F238E27FC236}">
+                <a16:creationId xmlns:a16="http://schemas.microsoft.com/office/drawing/2014/main" id="{F48BB6BF-0F43-B3BB-9726-9E24AF4AF1F2}"/>
+              </a:ext>
+            </a:extLst>
+          </p:cNvPr>
+          <p:cNvSpPr>
+            <a:spLocks noGrp="1"/>
+          </p:cNvSpPr>
+          <p:nvPr>
+            <p:ph type="sldNum" sz="quarter" idx="12"/>
+          </p:nvPr>
+        </p:nvSpPr>
+        <p:spPr/>
+        <p:txBody>
+          <a:bodyPr/>
+          <a:lstStyle/>
+          <a:p>
+            <a:fld id="{C6DDDF4F-F028-4B81-B3D4-6037FCFC1593}" type="slidenum">
+              <a:rPr lang="en-US" smtClean="0"/>
+              <a:t>15</a:t>
+            </a:fld>
+            <a:endParaRPr lang="en-US"/>
+          </a:p>
+        </p:txBody>
+      </p:sp>
+      <p:sp>
+        <p:nvSpPr>
+          <p:cNvPr id="4" name="Accent box">
+            <a:extLst>
+              <a:ext uri="{FF2B5EF4-FFF2-40B4-BE49-F238E27FC236}">
+                <a16:creationId xmlns:a16="http://schemas.microsoft.com/office/drawing/2014/main" id="{8BC34ECF-89BB-4E09-C605-80FA1413755F}"/>
+              </a:ext>
+            </a:extLst>
+          </p:cNvPr>
+          <p:cNvSpPr/>
+          <p:nvPr/>
+        </p:nvSpPr>
+        <p:spPr>
+          <a:xfrm>
+            <a:off x="762000" y="3302000"/>
+            <a:ext cx="3048000" cy="762000"/>
+          </a:xfrm>
+          <a:prstGeom prst="rect">
+            <a:avLst/>
+          </a:prstGeom>
+          <a:solidFill>
+            <a:schemeClr val="accent1"/>
+          </a:solidFill>
+        </p:spPr>
+        <p:style>
+          <a:lnRef idx="2">
+            <a:schemeClr val="accent1">
+              <a:shade val="15000"/>
+            </a:schemeClr>
+          </a:lnRef>
+          <a:fillRef idx="1">
+            <a:schemeClr val="accent1"/>
+          </a:fillRef>
+          <a:effectRef idx="0">
+            <a:schemeClr val="accent1"/>
+          </a:effectRef>
+          <a:fontRef idx="minor">
+            <a:schemeClr val="lt1"/>
+          </a:fontRef>
+        </p:style>
+        <p:txBody>
+          <a:bodyPr rtlCol="0" anchor="ctr"/>
+          <a:lstStyle/>
+          <a:p>
+            <a:pPr algn="ctr"/>
+            <a:r>
+              <a:rPr lang="ar-EG"/>
+              <a:t>لون التمييز الأول</a:t>
+            </a:r>
+            <a:endParaRPr lang="en-US"/>
+          </a:p>
+        </p:txBody>
+      </p:sp>
+    </p:spTree>
+    <p:extLst>
+      <p:ext uri="{BB962C8B-B14F-4D97-AF65-F5344CB8AC3E}">
+        <p14:creationId xmlns:p14="http://schemas.microsoft.com/office/powerpoint/2010/main" val="4226322720"/>
+      </p:ext>
+    </p:extLst>
+  </p:cSld>
+  <p:clrMapOvr>
+    <a:masterClrMapping/>
+  </p:clrMapOvr>
+</p:sld>
+</file>
+
+<file path=ppt/slides/slide16.xml><?xml version="1.0" encoding="utf-8"?>
+<p:sld xmlns:a="http://schemas.openxmlformats.org/drawingml/2006/main" xmlns:r="http://schemas.openxmlformats.org/officeDocument/2006/relationships" xmlns:p="http://schemas.openxmlformats.org/presentationml/2006/main">
+  <p:cSld>
+    <p:spTree>
+      <p:nvGrpSpPr>
+        <p:cNvPr id="1" name=""/>
+        <p:cNvGrpSpPr/>
+        <p:nvPr/>
+      </p:nvGrpSpPr>
+      <p:grpSpPr>
+        <a:xfrm>
+          <a:off x="0" y="0"/>
+          <a:ext cx="0" cy="0"/>
+          <a:chOff x="0" y="0"/>
+          <a:chExt cx="0" cy="0"/>
+        </a:xfrm>
+      </p:grpSpPr>
+      <p:sp>
+        <p:nvSpPr>
+          <p:cNvPr id="2" name="Title">
+            <a:extLst>
+              <a:ext uri="{FF2B5EF4-FFF2-40B4-BE49-F238E27FC236}">
+                <a16:creationId xmlns:a16="http://schemas.microsoft.com/office/drawing/2014/main" id="{77C35447-3B69-8290-4B68-032CFFAFA8DF}"/>
+              </a:ext>
+            </a:extLst>
+          </p:cNvPr>
+          <p:cNvSpPr>
+            <a:spLocks noGrp="1"/>
+          </p:cNvSpPr>
+          <p:nvPr>
+            <p:ph type="title"/>
+          </p:nvPr>
+        </p:nvSpPr>
+        <p:spPr/>
+        <p:txBody>
+          <a:bodyPr/>
+          <a:lstStyle/>
+          <a:p>
+            <a:r>
+              <a:rPr lang="ar-EG"/>
+              <a:t>شريحة ثانية على التخطيط أ</a:t>
+            </a:r>
+            <a:endParaRPr lang="en-US"/>
+          </a:p>
+        </p:txBody>
+      </p:sp>
+      <p:sp>
+        <p:nvSpPr>
+          <p:cNvPr id="3" name="Slide Number Placeholder 2">
+            <a:extLst>
+              <a:ext uri="{FF2B5EF4-FFF2-40B4-BE49-F238E27FC236}">
+                <a16:creationId xmlns:a16="http://schemas.microsoft.com/office/drawing/2014/main" id="{296FE604-8505-A095-2591-7110126032D1}"/>
+              </a:ext>
+            </a:extLst>
+          </p:cNvPr>
+          <p:cNvSpPr>
+            <a:spLocks noGrp="1"/>
+          </p:cNvSpPr>
+          <p:nvPr>
+            <p:ph type="sldNum" sz="quarter" idx="12"/>
+          </p:nvPr>
+        </p:nvSpPr>
+        <p:spPr/>
+        <p:txBody>
+          <a:bodyPr/>
+          <a:lstStyle/>
+          <a:p>
+            <a:fld id="{C6DDDF4F-F028-4B81-B3D4-6037FCFC1593}" type="slidenum">
+              <a:rPr lang="en-US" smtClean="0"/>
+              <a:t>16</a:t>
+            </a:fld>
+            <a:endParaRPr lang="en-US"/>
+          </a:p>
+        </p:txBody>
+      </p:sp>
+    </p:spTree>
+    <p:extLst>
+      <p:ext uri="{BB962C8B-B14F-4D97-AF65-F5344CB8AC3E}">
+        <p14:creationId xmlns:p14="http://schemas.microsoft.com/office/powerpoint/2010/main" val="3806732660"/>
+      </p:ext>
+    </p:extLst>
+  </p:cSld>
+  <p:clrMapOvr>
+    <a:masterClrMapping/>
+  </p:clrMapOvr>
+</p:sld>
+</file>
+
+<file path=ppt/slides/slide17.xml><?xml version="1.0" encoding="utf-8"?>
+<p:sld xmlns:a="http://schemas.openxmlformats.org/drawingml/2006/main" xmlns:r="http://schemas.openxmlformats.org/officeDocument/2006/relationships" xmlns:p="http://schemas.openxmlformats.org/presentationml/2006/main">
+  <p:cSld>
+    <p:spTree>
+      <p:nvGrpSpPr>
+        <p:cNvPr id="1" name=""/>
+        <p:cNvGrpSpPr/>
+        <p:nvPr/>
+      </p:nvGrpSpPr>
+      <p:grpSpPr>
+        <a:xfrm>
+          <a:off x="0" y="0"/>
+          <a:ext cx="0" cy="0"/>
+          <a:chOff x="0" y="0"/>
+          <a:chExt cx="0" cy="0"/>
+        </a:xfrm>
+      </p:grpSpPr>
+      <p:sp>
+        <p:nvSpPr>
+          <p:cNvPr id="2" name="Title">
+            <a:extLst>
+              <a:ext uri="{FF2B5EF4-FFF2-40B4-BE49-F238E27FC236}">
+                <a16:creationId xmlns:a16="http://schemas.microsoft.com/office/drawing/2014/main" id="{DD9FEE69-9AF8-6C4A-C179-E6427D9F7617}"/>
+              </a:ext>
+            </a:extLst>
+          </p:cNvPr>
+          <p:cNvSpPr>
+            <a:spLocks noGrp="1"/>
+          </p:cNvSpPr>
+          <p:nvPr>
+            <p:ph type="title"/>
+          </p:nvPr>
+        </p:nvSpPr>
+        <p:spPr/>
+        <p:txBody>
+          <a:bodyPr/>
+          <a:lstStyle/>
+          <a:p>
+            <a:r>
+              <a:rPr lang="ar-EG"/>
+              <a:t>شريحة على التخطيط ب</a:t>
+            </a:r>
+            <a:endParaRPr lang="en-US"/>
+          </a:p>
+        </p:txBody>
+      </p:sp>
+      <p:sp>
+        <p:nvSpPr>
+          <p:cNvPr id="3" name="Slide Number Placeholder 2">
+            <a:extLst>
+              <a:ext uri="{FF2B5EF4-FFF2-40B4-BE49-F238E27FC236}">
+                <a16:creationId xmlns:a16="http://schemas.microsoft.com/office/drawing/2014/main" id="{AD523B5E-A794-A434-59B8-0DD5E355BA4B}"/>
+              </a:ext>
+            </a:extLst>
+          </p:cNvPr>
+          <p:cNvSpPr>
+            <a:spLocks noGrp="1"/>
+          </p:cNvSpPr>
+          <p:nvPr>
+            <p:ph type="sldNum" sz="quarter" idx="12"/>
+          </p:nvPr>
+        </p:nvSpPr>
+        <p:spPr/>
+        <p:txBody>
+          <a:bodyPr/>
+          <a:lstStyle/>
+          <a:p>
+            <a:fld id="{C6DDDF4F-F028-4B81-B3D4-6037FCFC1593}" type="slidenum">
+              <a:rPr lang="en-US" smtClean="0"/>
+              <a:t>17</a:t>
+            </a:fld>
+            <a:endParaRPr lang="en-US"/>
+          </a:p>
+        </p:txBody>
+      </p:sp>
+    </p:spTree>
+    <p:extLst>
+      <p:ext uri="{BB962C8B-B14F-4D97-AF65-F5344CB8AC3E}">
+        <p14:creationId xmlns:p14="http://schemas.microsoft.com/office/powerpoint/2010/main" val="2862519318"/>
+      </p:ext>
+    </p:extLst>
+  </p:cSld>
+  <p:clrMapOvr>
+    <a:masterClrMapping/>
+  </p:clrMapOvr>
+</p:sld>
+</file>
+
+<file path=ppt/slides/slide18.xml><?xml version="1.0" encoding="utf-8"?>
+<p:sld xmlns:a="http://schemas.openxmlformats.org/drawingml/2006/main" xmlns:r="http://schemas.openxmlformats.org/officeDocument/2006/relationships" xmlns:p="http://schemas.openxmlformats.org/presentationml/2006/main" showMasterSp="0">
+  <p:cSld>
+    <p:spTree>
+      <p:nvGrpSpPr>
+        <p:cNvPr id="1" name=""/>
+        <p:cNvGrpSpPr/>
+        <p:nvPr/>
+      </p:nvGrpSpPr>
+      <p:grpSpPr>
+        <a:xfrm>
+          <a:off x="0" y="0"/>
+          <a:ext cx="0" cy="0"/>
+          <a:chOff x="0" y="0"/>
+          <a:chExt cx="0" cy="0"/>
+        </a:xfrm>
+      </p:grpSpPr>
+      <p:sp>
+        <p:nvSpPr>
+          <p:cNvPr id="2" name="Title">
+            <a:extLst>
+              <a:ext uri="{FF2B5EF4-FFF2-40B4-BE49-F238E27FC236}">
+                <a16:creationId xmlns:a16="http://schemas.microsoft.com/office/drawing/2014/main" id="{C0F35A0F-1EFA-9FEF-8C2A-A2D60A0C99F1}"/>
+              </a:ext>
+            </a:extLst>
+          </p:cNvPr>
+          <p:cNvSpPr>
+            <a:spLocks noGrp="1"/>
+          </p:cNvSpPr>
+          <p:nvPr>
+            <p:ph type="title"/>
+          </p:nvPr>
+        </p:nvSpPr>
+        <p:spPr/>
+        <p:txBody>
+          <a:bodyPr/>
+          <a:lstStyle/>
+          <a:p>
+            <a:r>
+              <a:rPr lang="ar-EG"/>
+              <a:t>شريحة تخفي الرسومات</a:t>
+            </a:r>
+            <a:endParaRPr lang="en-US"/>
+          </a:p>
+        </p:txBody>
+      </p:sp>
+      <p:sp>
+        <p:nvSpPr>
+          <p:cNvPr id="3" name="Slide Number Placeholder 2">
+            <a:extLst>
+              <a:ext uri="{FF2B5EF4-FFF2-40B4-BE49-F238E27FC236}">
+                <a16:creationId xmlns:a16="http://schemas.microsoft.com/office/drawing/2014/main" id="{F4FEFA19-FBBF-5EC2-7ED6-E33233854321}"/>
+              </a:ext>
+            </a:extLst>
+          </p:cNvPr>
+          <p:cNvSpPr>
+            <a:spLocks noGrp="1"/>
+          </p:cNvSpPr>
+          <p:nvPr>
+            <p:ph type="sldNum" sz="quarter" idx="12"/>
+          </p:nvPr>
+        </p:nvSpPr>
+        <p:spPr/>
+        <p:txBody>
+          <a:bodyPr/>
+          <a:lstStyle/>
+          <a:p>
+            <a:fld id="{C6DDDF4F-F028-4B81-B3D4-6037FCFC1593}" type="slidenum">
+              <a:rPr lang="en-US" smtClean="0"/>
+              <a:t>18</a:t>
+            </a:fld>
+            <a:endParaRPr lang="en-US"/>
+          </a:p>
+        </p:txBody>
+      </p:sp>
+    </p:spTree>
+    <p:extLst>
+      <p:ext uri="{BB962C8B-B14F-4D97-AF65-F5344CB8AC3E}">
+        <p14:creationId xmlns:p14="http://schemas.microsoft.com/office/powerpoint/2010/main" val="3179111390"/>
       </p:ext>
     </p:extLst>
   </p:cSld>
@@ -10303,6 +12792,321 @@
 </file>
 
 <file path=ppt/theme/theme2.xml><?xml version="1.0" encoding="utf-8"?>
+<a:theme xmlns:a="http://schemas.openxmlformats.org/drawingml/2006/main" name="Second master">
+  <a:themeElements>
+    <a:clrScheme name="Office">
+      <a:dk1>
+        <a:sysClr val="windowText" lastClr="000000"/>
+      </a:dk1>
+      <a:lt1>
+        <a:sysClr val="window" lastClr="FFFFFF"/>
+      </a:lt1>
+      <a:dk2>
+        <a:srgbClr val="0E2841"/>
+      </a:dk2>
+      <a:lt2>
+        <a:srgbClr val="E8E8E8"/>
+      </a:lt2>
+      <a:accent1>
+        <a:srgbClr val="1E6B3C"/>
+      </a:accent1>
+      <a:accent2>
+        <a:srgbClr val="E97132"/>
+      </a:accent2>
+      <a:accent3>
+        <a:srgbClr val="196B24"/>
+      </a:accent3>
+      <a:accent4>
+        <a:srgbClr val="0F9ED5"/>
+      </a:accent4>
+      <a:accent5>
+        <a:srgbClr val="A02B93"/>
+      </a:accent5>
+      <a:accent6>
+        <a:srgbClr val="4EA72E"/>
+      </a:accent6>
+      <a:hlink>
+        <a:srgbClr val="467886"/>
+      </a:hlink>
+      <a:folHlink>
+        <a:srgbClr val="96607D"/>
+      </a:folHlink>
+    </a:clrScheme>
+    <a:fontScheme name="Office">
+      <a:majorFont>
+        <a:latin typeface="Aptos Display" panose="02110004020202020204"/>
+        <a:ea typeface=""/>
+        <a:cs typeface=""/>
+        <a:font script="Jpan" typeface="游ゴシック Light"/>
+        <a:font script="Hang" typeface="맑은 고딕"/>
+        <a:font script="Hans" typeface="等线 Light"/>
+        <a:font script="Hant" typeface="新細明體"/>
+        <a:font script="Arab" typeface="Times New Roman"/>
+        <a:font script="Hebr" typeface="Times New Roman"/>
+        <a:font script="Thai" typeface="Angsana New"/>
+        <a:font script="Ethi" typeface="Nyala"/>
+        <a:font script="Beng" typeface="Vrinda"/>
+        <a:font script="Gujr" typeface="Shruti"/>
+        <a:font script="Khmr" typeface="MoolBoran"/>
+        <a:font script="Knda" typeface="Tunga"/>
+        <a:font script="Guru" typeface="Raavi"/>
+        <a:font script="Cans" typeface="Euphemia"/>
+        <a:font script="Cher" typeface="Plantagenet Cherokee"/>
+        <a:font script="Yiii" typeface="Microsoft Yi Baiti"/>
+        <a:font script="Tibt" typeface="Microsoft Himalaya"/>
+        <a:font script="Thaa" typeface="MV Boli"/>
+        <a:font script="Deva" typeface="Mangal"/>
+        <a:font script="Telu" typeface="Gautami"/>
+        <a:font script="Taml" typeface="Latha"/>
+        <a:font script="Syrc" typeface="Estrangelo Edessa"/>
+        <a:font script="Orya" typeface="Kalinga"/>
+        <a:font script="Mlym" typeface="Kartika"/>
+        <a:font script="Laoo" typeface="DokChampa"/>
+        <a:font script="Sinh" typeface="Iskoola Pota"/>
+        <a:font script="Mong" typeface="Mongolian Baiti"/>
+        <a:font script="Viet" typeface="Times New Roman"/>
+        <a:font script="Uigh" typeface="Microsoft Uighur"/>
+        <a:font script="Geor" typeface="Sylfaen"/>
+        <a:font script="Armn" typeface="Arial"/>
+        <a:font script="Bugi" typeface="Leelawadee UI"/>
+        <a:font script="Bopo" typeface="Microsoft JhengHei"/>
+        <a:font script="Java" typeface="Javanese Text"/>
+        <a:font script="Lisu" typeface="Segoe UI"/>
+        <a:font script="Mymr" typeface="Myanmar Text"/>
+        <a:font script="Nkoo" typeface="Ebrima"/>
+        <a:font script="Olck" typeface="Nirmala UI"/>
+        <a:font script="Osma" typeface="Ebrima"/>
+        <a:font script="Phag" typeface="Phagspa"/>
+        <a:font script="Syrn" typeface="Estrangelo Edessa"/>
+        <a:font script="Syrj" typeface="Estrangelo Edessa"/>
+        <a:font script="Syre" typeface="Estrangelo Edessa"/>
+        <a:font script="Sora" typeface="Nirmala UI"/>
+        <a:font script="Tale" typeface="Microsoft Tai Le"/>
+        <a:font script="Talu" typeface="Microsoft New Tai Lue"/>
+        <a:font script="Tfng" typeface="Ebrima"/>
+      </a:majorFont>
+      <a:minorFont>
+        <a:latin typeface="Aptos" panose="02110004020202020204"/>
+        <a:ea typeface=""/>
+        <a:cs typeface=""/>
+        <a:font script="Jpan" typeface="游ゴシック"/>
+        <a:font script="Hang" typeface="맑은 고딕"/>
+        <a:font script="Hans" typeface="等线"/>
+        <a:font script="Hant" typeface="新細明體"/>
+        <a:font script="Arab" typeface="Arial"/>
+        <a:font script="Hebr" typeface="Arial"/>
+        <a:font script="Thai" typeface="Cordia New"/>
+        <a:font script="Ethi" typeface="Nyala"/>
+        <a:font script="Beng" typeface="Vrinda"/>
+        <a:font script="Gujr" typeface="Shruti"/>
+        <a:font script="Khmr" typeface="DaunPenh"/>
+        <a:font script="Knda" typeface="Tunga"/>
+        <a:font script="Guru" typeface="Raavi"/>
+        <a:font script="Cans" typeface="Euphemia"/>
+        <a:font script="Cher" typeface="Plantagenet Cherokee"/>
+        <a:font script="Yiii" typeface="Microsoft Yi Baiti"/>
+        <a:font script="Tibt" typeface="Microsoft Himalaya"/>
+        <a:font script="Thaa" typeface="MV Boli"/>
+        <a:font script="Deva" typeface="Mangal"/>
+        <a:font script="Telu" typeface="Gautami"/>
+        <a:font script="Taml" typeface="Latha"/>
+        <a:font script="Syrc" typeface="Estrangelo Edessa"/>
+        <a:font script="Orya" typeface="Kalinga"/>
+        <a:font script="Mlym" typeface="Kartika"/>
+        <a:font script="Laoo" typeface="DokChampa"/>
+        <a:font script="Sinh" typeface="Iskoola Pota"/>
+        <a:font script="Mong" typeface="Mongolian Baiti"/>
+        <a:font script="Viet" typeface="Arial"/>
+        <a:font script="Uigh" typeface="Microsoft Uighur"/>
+        <a:font script="Geor" typeface="Sylfaen"/>
+        <a:font script="Armn" typeface="Arial"/>
+        <a:font script="Bugi" typeface="Leelawadee UI"/>
+        <a:font script="Bopo" typeface="Microsoft JhengHei"/>
+        <a:font script="Java" typeface="Javanese Text"/>
+        <a:font script="Lisu" typeface="Segoe UI"/>
+        <a:font script="Mymr" typeface="Myanmar Text"/>
+        <a:font script="Nkoo" typeface="Ebrima"/>
+        <a:font script="Olck" typeface="Nirmala UI"/>
+        <a:font script="Osma" typeface="Ebrima"/>
+        <a:font script="Phag" typeface="Phagspa"/>
+        <a:font script="Syrn" typeface="Estrangelo Edessa"/>
+        <a:font script="Syrj" typeface="Estrangelo Edessa"/>
+        <a:font script="Syre" typeface="Estrangelo Edessa"/>
+        <a:font script="Sora" typeface="Nirmala UI"/>
+        <a:font script="Tale" typeface="Microsoft Tai Le"/>
+        <a:font script="Talu" typeface="Microsoft New Tai Lue"/>
+        <a:font script="Tfng" typeface="Ebrima"/>
+      </a:minorFont>
+    </a:fontScheme>
+    <a:fmtScheme name="Office">
+      <a:fillStyleLst>
+        <a:solidFill>
+          <a:schemeClr val="phClr"/>
+        </a:solidFill>
+        <a:gradFill rotWithShape="1">
+          <a:gsLst>
+            <a:gs pos="0">
+              <a:schemeClr val="phClr">
+                <a:lumMod val="110000"/>
+                <a:satMod val="105000"/>
+                <a:tint val="67000"/>
+              </a:schemeClr>
+            </a:gs>
+            <a:gs pos="50000">
+              <a:schemeClr val="phClr">
+                <a:lumMod val="105000"/>
+                <a:satMod val="103000"/>
+                <a:tint val="73000"/>
+              </a:schemeClr>
+            </a:gs>
+            <a:gs pos="100000">
+              <a:schemeClr val="phClr">
+                <a:lumMod val="105000"/>
+                <a:satMod val="109000"/>
+                <a:tint val="81000"/>
+              </a:schemeClr>
+            </a:gs>
+          </a:gsLst>
+          <a:lin ang="5400000" scaled="0"/>
+        </a:gradFill>
+        <a:gradFill rotWithShape="1">
+          <a:gsLst>
+            <a:gs pos="0">
+              <a:schemeClr val="phClr">
+                <a:satMod val="103000"/>
+                <a:lumMod val="102000"/>
+                <a:tint val="94000"/>
+              </a:schemeClr>
+            </a:gs>
+            <a:gs pos="50000">
+              <a:schemeClr val="phClr">
+                <a:satMod val="110000"/>
+                <a:lumMod val="100000"/>
+                <a:shade val="100000"/>
+              </a:schemeClr>
+            </a:gs>
+            <a:gs pos="100000">
+              <a:schemeClr val="phClr">
+                <a:lumMod val="99000"/>
+                <a:satMod val="120000"/>
+                <a:shade val="78000"/>
+              </a:schemeClr>
+            </a:gs>
+          </a:gsLst>
+          <a:lin ang="5400000" scaled="0"/>
+        </a:gradFill>
+      </a:fillStyleLst>
+      <a:lnStyleLst>
+        <a:ln w="12700" cap="flat" cmpd="sng" algn="ctr">
+          <a:solidFill>
+            <a:schemeClr val="phClr"/>
+          </a:solidFill>
+          <a:prstDash val="solid"/>
+          <a:miter lim="800000"/>
+        </a:ln>
+        <a:ln w="19050" cap="flat" cmpd="sng" algn="ctr">
+          <a:solidFill>
+            <a:schemeClr val="phClr"/>
+          </a:solidFill>
+          <a:prstDash val="solid"/>
+          <a:miter lim="800000"/>
+        </a:ln>
+        <a:ln w="25400" cap="flat" cmpd="sng" algn="ctr">
+          <a:solidFill>
+            <a:schemeClr val="phClr"/>
+          </a:solidFill>
+          <a:prstDash val="solid"/>
+          <a:miter lim="800000"/>
+        </a:ln>
+      </a:lnStyleLst>
+      <a:effectStyleLst>
+        <a:effectStyle>
+          <a:effectLst/>
+        </a:effectStyle>
+        <a:effectStyle>
+          <a:effectLst/>
+        </a:effectStyle>
+        <a:effectStyle>
+          <a:effectLst>
+            <a:outerShdw blurRad="57150" dist="19050" dir="5400000" algn="ctr" rotWithShape="0">
+              <a:srgbClr val="000000">
+                <a:alpha val="63000"/>
+              </a:srgbClr>
+            </a:outerShdw>
+          </a:effectLst>
+        </a:effectStyle>
+      </a:effectStyleLst>
+      <a:bgFillStyleLst>
+        <a:solidFill>
+          <a:schemeClr val="phClr"/>
+        </a:solidFill>
+        <a:solidFill>
+          <a:schemeClr val="phClr">
+            <a:tint val="95000"/>
+            <a:satMod val="170000"/>
+          </a:schemeClr>
+        </a:solidFill>
+        <a:gradFill rotWithShape="1">
+          <a:gsLst>
+            <a:gs pos="0">
+              <a:schemeClr val="phClr">
+                <a:tint val="93000"/>
+                <a:satMod val="150000"/>
+                <a:shade val="98000"/>
+                <a:lumMod val="102000"/>
+              </a:schemeClr>
+            </a:gs>
+            <a:gs pos="50000">
+              <a:schemeClr val="phClr">
+                <a:tint val="98000"/>
+                <a:satMod val="130000"/>
+                <a:shade val="90000"/>
+                <a:lumMod val="103000"/>
+              </a:schemeClr>
+            </a:gs>
+            <a:gs pos="100000">
+              <a:schemeClr val="phClr">
+                <a:shade val="63000"/>
+                <a:satMod val="120000"/>
+              </a:schemeClr>
+            </a:gs>
+          </a:gsLst>
+          <a:lin ang="5400000" scaled="0"/>
+        </a:gradFill>
+      </a:bgFillStyleLst>
+    </a:fmtScheme>
+  </a:themeElements>
+  <a:objectDefaults>
+    <a:lnDef>
+      <a:spPr/>
+      <a:bodyPr/>
+      <a:lstStyle/>
+      <a:style>
+        <a:lnRef idx="2">
+          <a:schemeClr val="accent1"/>
+        </a:lnRef>
+        <a:fillRef idx="0">
+          <a:schemeClr val="accent1"/>
+        </a:fillRef>
+        <a:effectRef idx="1">
+          <a:schemeClr val="accent1"/>
+        </a:effectRef>
+        <a:fontRef idx="minor">
+          <a:schemeClr val="tx1"/>
+        </a:fontRef>
+      </a:style>
+    </a:lnDef>
+  </a:objectDefaults>
+  <a:extraClrSchemeLst/>
+  <a:extLst>
+    <a:ext uri="{05A4C25C-085E-4340-85A3-A5531E510DB2}">
+      <thm15:themeFamily xmlns:thm15="http://schemas.microsoft.com/office/thememl/2012/main" name="Office Theme" id="{2E142A2C-CD16-42D6-873A-C26D2A0506FA}" vid="{1BDDFF52-6CD6-40A5-AB3C-68EB2F1E4D0A}"/>
+    </a:ext>
+  </a:extLst>
+</a:theme>
+</file>
+
+<file path=ppt/theme/theme3.xml><?xml version="1.0" encoding="utf-8"?>
 <a:theme xmlns:a="http://schemas.openxmlformats.org/drawingml/2006/main" name="Office Theme">
   <a:themeElements>
     <a:clrScheme name="Office">

</xml_diff>

<commit_message>
Rendering refinements, developer workflows and baseline documentation
Squash 7 consecutive development commits, retaining the original ending snapshot.

- Improve Office rendering with shared drawing effects, SVG pictures and XLSX conditional formats
- XLSX viewer: fit to the file's sizes, selection past the data, range and reference highlights
- Refactor viewer interaction and error handling; enhance content rendering capabilities
- Validate IFS value-range shapes, prove the deferred coverage, and consolidate the visual harness
- Isolate renderer typography and paint resources, consolidate shared CSS
- Consolidate roadmap and fidelity gaps into architecture
- Preserve engineering decisions in topic notes and establish a development changelog
</commit_message>
<xml_diff>
--- a/fixtures/pptx-coverage.pptx
+++ b/fixtures/pptx-coverage.pptx
@@ -6,7 +6,7 @@
     <p:sldMasterId id="2147483660" r:id="rId2"/>
   </p:sldMasterIdLst>
   <p:notesMasterIdLst>
-    <p:notesMasterId r:id="rId21"/>
+    <p:notesMasterId r:id="rId23"/>
   </p:notesMasterIdLst>
   <p:sldIdLst>
     <p:sldId id="256" r:id="rId3"/>
@@ -27,6 +27,8 @@
     <p:sldId id="271" r:id="rId18"/>
     <p:sldId id="272" r:id="rId19"/>
     <p:sldId id="273" r:id="rId20"/>
+    <p:sldId id="274" r:id="rId21"/>
+    <p:sldId id="275" r:id="rId22"/>
   </p:sldIdLst>
   <p:sldSz cx="12192000" cy="6858000"/>
   <p:notesSz cx="6858000" cy="9144000"/>
@@ -1064,7 +1066,7 @@
           <a:p>
             <a:fld id="{86A64A56-4393-4CB6-85C6-C90BB7A8548C}" type="datetimeFigureOut">
               <a:rPr lang="en-US" smtClean="0"/>
-              <a:t>10/5/2026</a:t>
+              <a:t>10/10/2026</a:t>
             </a:fld>
             <a:endParaRPr lang="en-US"/>
           </a:p>
@@ -1478,7 +1480,7 @@
           <a:p>
             <a:fld id="{60541A7F-F981-4501-AAE0-06F6CB326412}" type="datetime1">
               <a:rPr lang="en-US" smtClean="0"/>
-              <a:t>10/5/2026</a:t>
+              <a:t>10/10/2026</a:t>
             </a:fld>
             <a:endParaRPr lang="en-US"/>
           </a:p>
@@ -1676,7 +1678,7 @@
           <a:p>
             <a:fld id="{F853943D-1B76-47AC-8196-C4B25463BF47}" type="datetime1">
               <a:rPr lang="en-US" smtClean="0"/>
-              <a:t>10/5/2026</a:t>
+              <a:t>10/10/2026</a:t>
             </a:fld>
             <a:endParaRPr lang="en-US"/>
           </a:p>
@@ -1884,7 +1886,7 @@
           <a:p>
             <a:fld id="{2E188C43-274A-49F7-9E8E-741661AA3B8D}" type="datetime1">
               <a:rPr lang="en-US" smtClean="0"/>
-              <a:t>10/5/2026</a:t>
+              <a:t>10/10/2026</a:t>
             </a:fld>
             <a:endParaRPr lang="en-US"/>
           </a:p>
@@ -2231,6 +2233,119 @@
 </p:sldLayout>
 </file>
 
+<file path=ppt/slideLayouts/slideLayout14.xml><?xml version="1.0" encoding="utf-8"?>
+<p:sldLayout xmlns:a="http://schemas.openxmlformats.org/drawingml/2006/main" xmlns:r="http://schemas.openxmlformats.org/officeDocument/2006/relationships" xmlns:p="http://schemas.openxmlformats.org/presentationml/2006/main" type="blank" preserve="1">
+  <p:cSld name="Blank">
+    <p:spTree>
+      <p:nvGrpSpPr>
+        <p:cNvPr id="1" name=""/>
+        <p:cNvGrpSpPr/>
+        <p:nvPr/>
+      </p:nvGrpSpPr>
+      <p:grpSpPr>
+        <a:xfrm>
+          <a:off x="0" y="0"/>
+          <a:ext cx="0" cy="0"/>
+          <a:chOff x="0" y="0"/>
+          <a:chExt cx="0" cy="0"/>
+        </a:xfrm>
+      </p:grpSpPr>
+      <p:sp>
+        <p:nvSpPr>
+          <p:cNvPr id="2" name="Date Placeholder 1">
+            <a:extLst>
+              <a:ext uri="{FF2B5EF4-FFF2-40B4-BE49-F238E27FC236}">
+                <a16:creationId xmlns:a16="http://schemas.microsoft.com/office/drawing/2014/main" id="{EFA39068-ABE7-C387-6E59-4270E7B0EBC7}"/>
+              </a:ext>
+            </a:extLst>
+          </p:cNvPr>
+          <p:cNvSpPr>
+            <a:spLocks noGrp="1"/>
+          </p:cNvSpPr>
+          <p:nvPr>
+            <p:ph type="dt" sz="half" idx="10"/>
+          </p:nvPr>
+        </p:nvSpPr>
+        <p:spPr/>
+        <p:txBody>
+          <a:bodyPr/>
+          <a:lstStyle/>
+          <a:p>
+            <a:fld id="{27E3A6A4-31A5-4BF1-8F46-4A08E4DED6B4}" type="datetimeFigureOut">
+              <a:rPr lang="en-US" smtClean="0"/>
+              <a:t>10/10/2026</a:t>
+            </a:fld>
+            <a:endParaRPr lang="en-US"/>
+          </a:p>
+        </p:txBody>
+      </p:sp>
+      <p:sp>
+        <p:nvSpPr>
+          <p:cNvPr id="3" name="Footer Placeholder 2">
+            <a:extLst>
+              <a:ext uri="{FF2B5EF4-FFF2-40B4-BE49-F238E27FC236}">
+                <a16:creationId xmlns:a16="http://schemas.microsoft.com/office/drawing/2014/main" id="{D22EF6E9-DE26-C468-BF42-27D0C6A41FDD}"/>
+              </a:ext>
+            </a:extLst>
+          </p:cNvPr>
+          <p:cNvSpPr>
+            <a:spLocks noGrp="1"/>
+          </p:cNvSpPr>
+          <p:nvPr>
+            <p:ph type="ftr" sz="quarter" idx="11"/>
+          </p:nvPr>
+        </p:nvSpPr>
+        <p:spPr/>
+        <p:txBody>
+          <a:bodyPr/>
+          <a:lstStyle/>
+          <a:p>
+            <a:endParaRPr lang="en-US"/>
+          </a:p>
+        </p:txBody>
+      </p:sp>
+      <p:sp>
+        <p:nvSpPr>
+          <p:cNvPr id="4" name="Slide Number Placeholder 3">
+            <a:extLst>
+              <a:ext uri="{FF2B5EF4-FFF2-40B4-BE49-F238E27FC236}">
+                <a16:creationId xmlns:a16="http://schemas.microsoft.com/office/drawing/2014/main" id="{192DB7DC-03BE-00C3-9609-8DB7362D1F8F}"/>
+              </a:ext>
+            </a:extLst>
+          </p:cNvPr>
+          <p:cNvSpPr>
+            <a:spLocks noGrp="1"/>
+          </p:cNvSpPr>
+          <p:nvPr>
+            <p:ph type="sldNum" sz="quarter" idx="12"/>
+          </p:nvPr>
+        </p:nvSpPr>
+        <p:spPr/>
+        <p:txBody>
+          <a:bodyPr/>
+          <a:lstStyle/>
+          <a:p>
+            <a:fld id="{C6DDDF4F-F028-4B81-B3D4-6037FCFC1593}" type="slidenum">
+              <a:rPr lang="en-US" smtClean="0"/>
+              <a:t>‹#›</a:t>
+            </a:fld>
+            <a:endParaRPr lang="en-US"/>
+          </a:p>
+        </p:txBody>
+      </p:sp>
+    </p:spTree>
+    <p:extLst>
+      <p:ext uri="{BB962C8B-B14F-4D97-AF65-F5344CB8AC3E}">
+        <p14:creationId xmlns:p14="http://schemas.microsoft.com/office/powerpoint/2010/main" val="4289214459"/>
+      </p:ext>
+    </p:extLst>
+  </p:cSld>
+  <p:clrMapOvr>
+    <a:masterClrMapping/>
+  </p:clrMapOvr>
+</p:sldLayout>
+</file>
+
 <file path=ppt/slideLayouts/slideLayout2.xml><?xml version="1.0" encoding="utf-8"?>
 <p:sldLayout xmlns:a="http://schemas.openxmlformats.org/drawingml/2006/main" xmlns:r="http://schemas.openxmlformats.org/officeDocument/2006/relationships" xmlns:p="http://schemas.openxmlformats.org/presentationml/2006/main" type="obj" preserve="1">
   <p:cSld name="Title and Content">
@@ -2356,7 +2471,7 @@
           <a:p>
             <a:fld id="{AFE56759-6820-42B3-B9BE-972720AE0218}" type="datetime1">
               <a:rPr lang="en-US" smtClean="0"/>
-              <a:t>10/5/2026</a:t>
+              <a:t>10/10/2026</a:t>
             </a:fld>
             <a:endParaRPr lang="en-US"/>
           </a:p>
@@ -2631,7 +2746,7 @@
           <a:p>
             <a:fld id="{E60A5D86-3AF6-469E-9631-8585AF639EE9}" type="datetime1">
               <a:rPr lang="en-US" smtClean="0"/>
-              <a:t>10/5/2026</a:t>
+              <a:t>10/10/2026</a:t>
             </a:fld>
             <a:endParaRPr lang="en-US"/>
           </a:p>
@@ -2896,7 +3011,7 @@
           <a:p>
             <a:fld id="{7040F516-D53A-4B36-A577-E8486E25D0EC}" type="datetime1">
               <a:rPr lang="en-US" smtClean="0"/>
-              <a:t>10/5/2026</a:t>
+              <a:t>10/10/2026</a:t>
             </a:fld>
             <a:endParaRPr lang="en-US"/>
           </a:p>
@@ -3308,7 +3423,7 @@
           <a:p>
             <a:fld id="{3E6E30B0-F99E-4FCA-83EF-31E10F2B66B1}" type="datetime1">
               <a:rPr lang="en-US" smtClean="0"/>
-              <a:t>10/5/2026</a:t>
+              <a:t>10/10/2026</a:t>
             </a:fld>
             <a:endParaRPr lang="en-US"/>
           </a:p>
@@ -3449,7 +3564,7 @@
           <a:p>
             <a:fld id="{FF185E36-5297-403D-B499-FD865F8C5A4F}" type="datetime1">
               <a:rPr lang="en-US" smtClean="0"/>
-              <a:t>10/5/2026</a:t>
+              <a:t>10/10/2026</a:t>
             </a:fld>
             <a:endParaRPr lang="en-US"/>
           </a:p>
@@ -3562,7 +3677,7 @@
           <a:p>
             <a:fld id="{2CDF4417-72BA-4D8F-8104-BFB5B423E2DD}" type="datetime1">
               <a:rPr lang="en-US" smtClean="0"/>
-              <a:t>10/5/2026</a:t>
+              <a:t>10/10/2026</a:t>
             </a:fld>
             <a:endParaRPr lang="en-US"/>
           </a:p>
@@ -3873,7 +3988,7 @@
           <a:p>
             <a:fld id="{C30CC0FA-F1D1-458D-9491-18A8D18048F7}" type="datetime1">
               <a:rPr lang="en-US" smtClean="0"/>
-              <a:t>10/5/2026</a:t>
+              <a:t>10/10/2026</a:t>
             </a:fld>
             <a:endParaRPr lang="en-US"/>
           </a:p>
@@ -4161,7 +4276,7 @@
           <a:p>
             <a:fld id="{66BF3E84-4616-4F9E-891F-D3C933FF2937}" type="datetime1">
               <a:rPr lang="en-US" smtClean="0"/>
-              <a:t>10/5/2026</a:t>
+              <a:t>10/10/2026</a:t>
             </a:fld>
             <a:endParaRPr lang="en-US"/>
           </a:p>
@@ -4402,7 +4517,7 @@
           <a:p>
             <a:fld id="{350CAA63-4269-45C0-A8A2-D62AE2EC413F}" type="datetime1">
               <a:rPr lang="en-US" smtClean="0"/>
-              <a:t>10/5/2026</a:t>
+              <a:t>10/10/2026</a:t>
             </a:fld>
             <a:endParaRPr lang="en-US"/>
           </a:p>
@@ -4808,7 +4923,7 @@
     <p:bg>
       <p:bgPr>
         <a:blipFill>
-          <a:blip r:embed="rId4"/>
+          <a:blip r:embed="rId5"/>
           <a:stretch>
             <a:fillRect/>
           </a:stretch>
@@ -4976,7 +5091,7 @@
           <a:p>
             <a:fld id="{27E3A6A4-31A5-4BF1-8F46-4A08E4DED6B4}" type="datetimeFigureOut">
               <a:rPr lang="en-US" smtClean="0"/>
-              <a:t>10/5/2026</a:t>
+              <a:t>10/10/2026</a:t>
             </a:fld>
             <a:endParaRPr lang="en-US"/>
           </a:p>
@@ -5133,6 +5248,7 @@
   <p:sldLayoutIdLst>
     <p:sldLayoutId id="2147483672" r:id="rId1"/>
     <p:sldLayoutId id="2147483673" r:id="rId2"/>
+    <p:sldLayoutId id="2147483674" r:id="rId3"/>
   </p:sldLayoutIdLst>
   <p:txStyles>
     <p:titleStyle>
@@ -7674,6 +7790,1421 @@
     <p:extLst>
       <p:ext uri="{BB962C8B-B14F-4D97-AF65-F5344CB8AC3E}">
         <p14:creationId xmlns:p14="http://schemas.microsoft.com/office/powerpoint/2010/main" val="3179111390"/>
+      </p:ext>
+    </p:extLst>
+  </p:cSld>
+  <p:clrMapOvr>
+    <a:masterClrMapping/>
+  </p:clrMapOvr>
+</p:sld>
+</file>
+
+<file path=ppt/slides/slide19.xml><?xml version="1.0" encoding="utf-8"?>
+<p:sld xmlns:a="http://schemas.openxmlformats.org/drawingml/2006/main" xmlns:r="http://schemas.openxmlformats.org/officeDocument/2006/relationships" xmlns:p="http://schemas.openxmlformats.org/presentationml/2006/main" showMasterSp="0">
+  <p:cSld>
+    <p:bg>
+      <p:bgPr>
+        <a:solidFill>
+          <a:srgbClr val="FFFFFF"/>
+        </a:solidFill>
+        <a:effectLst/>
+      </p:bgPr>
+    </p:bg>
+    <p:spTree>
+      <p:nvGrpSpPr>
+        <p:cNvPr id="1" name=""/>
+        <p:cNvGrpSpPr/>
+        <p:nvPr/>
+      </p:nvGrpSpPr>
+      <p:grpSpPr>
+        <a:xfrm>
+          <a:off x="0" y="0"/>
+          <a:ext cx="0" cy="0"/>
+          <a:chOff x="0" y="0"/>
+          <a:chExt cx="0" cy="0"/>
+        </a:xfrm>
+      </p:grpSpPr>
+      <p:sp>
+        <p:nvSpPr>
+          <p:cNvPr id="2" name="TextBox 1">
+            <a:extLst>
+              <a:ext uri="{FF2B5EF4-FFF2-40B4-BE49-F238E27FC236}">
+                <a16:creationId xmlns:a16="http://schemas.microsoft.com/office/drawing/2014/main" id="{A51325DE-31BC-CD28-7041-318E0FA652C7}"/>
+              </a:ext>
+            </a:extLst>
+          </p:cNvPr>
+          <p:cNvSpPr txBox="1"/>
+          <p:nvPr/>
+        </p:nvSpPr>
+        <p:spPr>
+          <a:xfrm>
+            <a:off x="381000" y="152400"/>
+            <a:ext cx="8255000" cy="461665"/>
+          </a:xfrm>
+          <a:prstGeom prst="rect">
+            <a:avLst/>
+          </a:prstGeom>
+          <a:noFill/>
+        </p:spPr>
+        <p:txBody>
+          <a:bodyPr vert="horz" rtlCol="0">
+            <a:spAutoFit/>
+          </a:bodyPr>
+          <a:lstStyle/>
+          <a:p>
+            <a:r>
+              <a:rPr lang="en-US" sz="2400">
+                <a:latin typeface="Arial" panose="020B0604020202020204" pitchFamily="34" charset="0"/>
+              </a:rPr>
+              <a:t>Group appearance / </a:t>
+            </a:r>
+            <a:r>
+              <a:rPr lang="ar-EG" sz="2400">
+                <a:latin typeface="Arial" panose="020B0604020202020204" pitchFamily="34" charset="0"/>
+              </a:rPr>
+              <a:t>مظهر المجموعة</a:t>
+            </a:r>
+            <a:endParaRPr lang="en-US" sz="2400">
+              <a:latin typeface="Arial" panose="020B0604020202020204" pitchFamily="34" charset="0"/>
+            </a:endParaRPr>
+          </a:p>
+        </p:txBody>
+      </p:sp>
+      <p:grpSp>
+        <p:nvGrpSpPr>
+          <p:cNvPr id="5" name="Group fill inheritance">
+            <a:extLst>
+              <a:ext uri="{FF2B5EF4-FFF2-40B4-BE49-F238E27FC236}">
+                <a16:creationId xmlns:a16="http://schemas.microsoft.com/office/drawing/2014/main" id="{38DDD7A7-3A69-EA61-42F6-D2CEC9BDD659}"/>
+              </a:ext>
+            </a:extLst>
+          </p:cNvPr>
+          <p:cNvGrpSpPr/>
+          <p:nvPr/>
+        </p:nvGrpSpPr>
+        <p:grpSpPr>
+          <a:xfrm>
+            <a:off x="508000" y="1016000"/>
+            <a:ext cx="1778000" cy="1206500"/>
+            <a:chOff x="508000" y="1016000"/>
+            <a:chExt cx="1778000" cy="1206500"/>
+          </a:xfrm>
+          <a:solidFill>
+            <a:srgbClr val="156082"/>
+          </a:solidFill>
+        </p:grpSpPr>
+        <p:sp>
+          <p:nvSpPr>
+            <p:cNvPr id="3" name="Group fill inheritance A">
+              <a:extLst>
+                <a:ext uri="{FF2B5EF4-FFF2-40B4-BE49-F238E27FC236}">
+                  <a16:creationId xmlns:a16="http://schemas.microsoft.com/office/drawing/2014/main" id="{139E4F8A-9FD1-0A0C-2D9E-369CA61C8841}"/>
+                </a:ext>
+              </a:extLst>
+            </p:cNvPr>
+            <p:cNvSpPr/>
+            <p:nvPr/>
+          </p:nvSpPr>
+          <p:spPr>
+            <a:xfrm>
+              <a:off x="508000" y="1016000"/>
+              <a:ext cx="1079500" cy="825500"/>
+            </a:xfrm>
+            <a:prstGeom prst="rect">
+              <a:avLst/>
+            </a:prstGeom>
+            <a:grpFill/>
+            <a:ln w="19050" cap="flat" cmpd="sng" algn="ctr">
+              <a:noFill/>
+              <a:prstDash val="solid"/>
+              <a:miter lim="800000"/>
+            </a:ln>
+            <a:effectLst/>
+            <a:extLst>
+              <a:ext uri="{91240B29-F687-4F45-9708-019B960494DF}">
+                <a14:hiddenLine xmlns:a14="http://schemas.microsoft.com/office/drawing/2010/main" w="19050" cap="flat" cmpd="sng" algn="ctr">
+                  <a:solidFill>
+                    <a:schemeClr val="accent1">
+                      <a:shade val="15000"/>
+                    </a:schemeClr>
+                  </a:solidFill>
+                  <a:prstDash val="solid"/>
+                  <a:miter lim="800000"/>
+                </a14:hiddenLine>
+              </a:ext>
+            </a:extLst>
+          </p:spPr>
+          <p:style>
+            <a:lnRef idx="2">
+              <a:schemeClr val="accent1">
+                <a:shade val="15000"/>
+              </a:schemeClr>
+            </a:lnRef>
+            <a:fillRef idx="1">
+              <a:schemeClr val="accent1"/>
+            </a:fillRef>
+            <a:effectRef idx="0">
+              <a:schemeClr val="accent1"/>
+            </a:effectRef>
+            <a:fontRef idx="minor">
+              <a:schemeClr val="lt1"/>
+            </a:fontRef>
+          </p:style>
+          <p:txBody>
+            <a:bodyPr rtlCol="0" anchor="ctr"/>
+            <a:lstStyle/>
+            <a:p>
+              <a:pPr algn="ctr"/>
+              <a:r>
+                <a:rPr lang="ar-EG" sz="1400">
+                  <a:latin typeface="Arial" panose="020B0604020202020204" pitchFamily="34" charset="0"/>
+                </a:rPr>
+                <a:t>مجموعة</a:t>
+              </a:r>
+              <a:endParaRPr lang="en-US" sz="1400">
+                <a:latin typeface="Arial" panose="020B0604020202020204" pitchFamily="34" charset="0"/>
+              </a:endParaRPr>
+            </a:p>
+          </p:txBody>
+        </p:sp>
+        <p:sp>
+          <p:nvSpPr>
+            <p:cNvPr id="4" name="Group fill inheritance B">
+              <a:extLst>
+                <a:ext uri="{FF2B5EF4-FFF2-40B4-BE49-F238E27FC236}">
+                  <a16:creationId xmlns:a16="http://schemas.microsoft.com/office/drawing/2014/main" id="{8FD1249E-015A-915D-C5C8-E8FCFD9465C1}"/>
+                </a:ext>
+              </a:extLst>
+            </p:cNvPr>
+            <p:cNvSpPr/>
+            <p:nvPr/>
+          </p:nvSpPr>
+          <p:spPr>
+            <a:xfrm>
+              <a:off x="1206500" y="1397000"/>
+              <a:ext cx="1079500" cy="825500"/>
+            </a:xfrm>
+            <a:prstGeom prst="ellipse">
+              <a:avLst/>
+            </a:prstGeom>
+            <a:solidFill>
+              <a:srgbClr val="BE2832"/>
+            </a:solidFill>
+            <a:ln w="19050" cap="flat" cmpd="sng" algn="ctr">
+              <a:noFill/>
+              <a:prstDash val="solid"/>
+              <a:miter lim="800000"/>
+            </a:ln>
+            <a:effectLst/>
+            <a:extLst>
+              <a:ext uri="{91240B29-F687-4F45-9708-019B960494DF}">
+                <a14:hiddenLine xmlns:a14="http://schemas.microsoft.com/office/drawing/2010/main" w="19050" cap="flat" cmpd="sng" algn="ctr">
+                  <a:solidFill>
+                    <a:schemeClr val="accent1">
+                      <a:shade val="15000"/>
+                    </a:schemeClr>
+                  </a:solidFill>
+                  <a:prstDash val="solid"/>
+                  <a:miter lim="800000"/>
+                </a14:hiddenLine>
+              </a:ext>
+            </a:extLst>
+          </p:spPr>
+          <p:style>
+            <a:lnRef idx="2">
+              <a:schemeClr val="accent1">
+                <a:shade val="15000"/>
+              </a:schemeClr>
+            </a:lnRef>
+            <a:fillRef idx="1">
+              <a:schemeClr val="accent1"/>
+            </a:fillRef>
+            <a:effectRef idx="0">
+              <a:schemeClr val="accent1"/>
+            </a:effectRef>
+            <a:fontRef idx="minor">
+              <a:schemeClr val="lt1"/>
+            </a:fontRef>
+          </p:style>
+          <p:txBody>
+            <a:bodyPr rtlCol="0" anchor="ctr"/>
+            <a:lstStyle/>
+            <a:p>
+              <a:pPr algn="ctr"/>
+              <a:r>
+                <a:rPr lang="en-US" sz="1400">
+                  <a:grpFill/>
+                  <a:latin typeface="Arial" panose="020B0604020202020204" pitchFamily="34" charset="0"/>
+                </a:rPr>
+                <a:t>Group</a:t>
+              </a:r>
+            </a:p>
+          </p:txBody>
+        </p:sp>
+      </p:grpSp>
+      <p:grpSp>
+        <p:nvGrpSpPr>
+          <p:cNvPr id="8" name="Group outer shadow">
+            <a:extLst>
+              <a:ext uri="{FF2B5EF4-FFF2-40B4-BE49-F238E27FC236}">
+                <a16:creationId xmlns:a16="http://schemas.microsoft.com/office/drawing/2014/main" id="{716FA7A4-2873-D167-E06F-32FA59F25836}"/>
+              </a:ext>
+            </a:extLst>
+          </p:cNvPr>
+          <p:cNvGrpSpPr/>
+          <p:nvPr/>
+        </p:nvGrpSpPr>
+        <p:grpSpPr>
+          <a:xfrm>
+            <a:off x="3175000" y="1016000"/>
+            <a:ext cx="1778000" cy="1206500"/>
+            <a:chOff x="3175000" y="1016000"/>
+            <a:chExt cx="1778000" cy="1206500"/>
+          </a:xfrm>
+          <a:solidFill>
+            <a:srgbClr val="156082"/>
+          </a:solidFill>
+          <a:effectLst>
+            <a:outerShdw blurRad="50800" dist="127000" dir="2212190" rotWithShape="0">
+              <a:srgbClr val="000000">
+                <a:alpha val="60000"/>
+              </a:srgbClr>
+            </a:outerShdw>
+          </a:effectLst>
+        </p:grpSpPr>
+        <p:sp>
+          <p:nvSpPr>
+            <p:cNvPr id="6" name="Group outer shadow A">
+              <a:extLst>
+                <a:ext uri="{FF2B5EF4-FFF2-40B4-BE49-F238E27FC236}">
+                  <a16:creationId xmlns:a16="http://schemas.microsoft.com/office/drawing/2014/main" id="{4F2422EA-71E0-0AA3-ADA7-63DB5549016C}"/>
+                </a:ext>
+              </a:extLst>
+            </p:cNvPr>
+            <p:cNvSpPr/>
+            <p:nvPr/>
+          </p:nvSpPr>
+          <p:spPr>
+            <a:xfrm>
+              <a:off x="3175000" y="1016000"/>
+              <a:ext cx="1079500" cy="825500"/>
+            </a:xfrm>
+            <a:prstGeom prst="rect">
+              <a:avLst/>
+            </a:prstGeom>
+            <a:grpFill/>
+            <a:ln w="19050" cap="flat" cmpd="sng" algn="ctr">
+              <a:noFill/>
+              <a:prstDash val="solid"/>
+              <a:miter lim="800000"/>
+            </a:ln>
+            <a:effectLst/>
+            <a:extLst>
+              <a:ext uri="{91240B29-F687-4F45-9708-019B960494DF}">
+                <a14:hiddenLine xmlns:a14="http://schemas.microsoft.com/office/drawing/2010/main" w="19050" cap="flat" cmpd="sng" algn="ctr">
+                  <a:solidFill>
+                    <a:schemeClr val="accent1">
+                      <a:shade val="15000"/>
+                    </a:schemeClr>
+                  </a:solidFill>
+                  <a:prstDash val="solid"/>
+                  <a:miter lim="800000"/>
+                </a14:hiddenLine>
+              </a:ext>
+            </a:extLst>
+          </p:spPr>
+          <p:style>
+            <a:lnRef idx="2">
+              <a:schemeClr val="accent1">
+                <a:shade val="15000"/>
+              </a:schemeClr>
+            </a:lnRef>
+            <a:fillRef idx="1">
+              <a:schemeClr val="accent1"/>
+            </a:fillRef>
+            <a:effectRef idx="0">
+              <a:schemeClr val="accent1"/>
+            </a:effectRef>
+            <a:fontRef idx="minor">
+              <a:schemeClr val="lt1"/>
+            </a:fontRef>
+          </p:style>
+          <p:txBody>
+            <a:bodyPr rtlCol="0" anchor="ctr"/>
+            <a:lstStyle/>
+            <a:p>
+              <a:pPr algn="ctr"/>
+              <a:r>
+                <a:rPr lang="ar-EG" sz="1400">
+                  <a:latin typeface="Arial" panose="020B0604020202020204" pitchFamily="34" charset="0"/>
+                </a:rPr>
+                <a:t>مجموعة</a:t>
+              </a:r>
+              <a:endParaRPr lang="en-US" sz="1400">
+                <a:latin typeface="Arial" panose="020B0604020202020204" pitchFamily="34" charset="0"/>
+              </a:endParaRPr>
+            </a:p>
+          </p:txBody>
+        </p:sp>
+        <p:sp>
+          <p:nvSpPr>
+            <p:cNvPr id="7" name="Group outer shadow B">
+              <a:extLst>
+                <a:ext uri="{FF2B5EF4-FFF2-40B4-BE49-F238E27FC236}">
+                  <a16:creationId xmlns:a16="http://schemas.microsoft.com/office/drawing/2014/main" id="{FF08A866-8821-264E-7B4B-E8D75A74B1C4}"/>
+                </a:ext>
+              </a:extLst>
+            </p:cNvPr>
+            <p:cNvSpPr/>
+            <p:nvPr/>
+          </p:nvSpPr>
+          <p:spPr>
+            <a:xfrm>
+              <a:off x="3873500" y="1397000"/>
+              <a:ext cx="1079500" cy="825500"/>
+            </a:xfrm>
+            <a:prstGeom prst="ellipse">
+              <a:avLst/>
+            </a:prstGeom>
+            <a:grpFill/>
+            <a:ln w="19050" cap="flat" cmpd="sng" algn="ctr">
+              <a:noFill/>
+              <a:prstDash val="solid"/>
+              <a:miter lim="800000"/>
+            </a:ln>
+            <a:effectLst/>
+            <a:extLst>
+              <a:ext uri="{91240B29-F687-4F45-9708-019B960494DF}">
+                <a14:hiddenLine xmlns:a14="http://schemas.microsoft.com/office/drawing/2010/main" w="19050" cap="flat" cmpd="sng" algn="ctr">
+                  <a:solidFill>
+                    <a:schemeClr val="accent1">
+                      <a:shade val="15000"/>
+                    </a:schemeClr>
+                  </a:solidFill>
+                  <a:prstDash val="solid"/>
+                  <a:miter lim="800000"/>
+                </a14:hiddenLine>
+              </a:ext>
+            </a:extLst>
+          </p:spPr>
+          <p:style>
+            <a:lnRef idx="2">
+              <a:schemeClr val="accent1">
+                <a:shade val="15000"/>
+              </a:schemeClr>
+            </a:lnRef>
+            <a:fillRef idx="1">
+              <a:schemeClr val="accent1"/>
+            </a:fillRef>
+            <a:effectRef idx="0">
+              <a:schemeClr val="accent1"/>
+            </a:effectRef>
+            <a:fontRef idx="minor">
+              <a:schemeClr val="lt1"/>
+            </a:fontRef>
+          </p:style>
+          <p:txBody>
+            <a:bodyPr rtlCol="0" anchor="ctr"/>
+            <a:lstStyle/>
+            <a:p>
+              <a:pPr algn="ctr"/>
+              <a:r>
+                <a:rPr lang="en-US" sz="1400">
+                  <a:latin typeface="Arial" panose="020B0604020202020204" pitchFamily="34" charset="0"/>
+                </a:rPr>
+                <a:t>Group</a:t>
+              </a:r>
+            </a:p>
+          </p:txBody>
+        </p:sp>
+      </p:grpSp>
+      <p:grpSp>
+        <p:nvGrpSpPr>
+          <p:cNvPr id="11" name="Group glow">
+            <a:extLst>
+              <a:ext uri="{FF2B5EF4-FFF2-40B4-BE49-F238E27FC236}">
+                <a16:creationId xmlns:a16="http://schemas.microsoft.com/office/drawing/2014/main" id="{14ACDAAA-C45A-6378-85D1-64EC3A7FED03}"/>
+              </a:ext>
+            </a:extLst>
+          </p:cNvPr>
+          <p:cNvGrpSpPr/>
+          <p:nvPr/>
+        </p:nvGrpSpPr>
+        <p:grpSpPr>
+          <a:xfrm>
+            <a:off x="5842000" y="1016000"/>
+            <a:ext cx="1778000" cy="1206500"/>
+            <a:chOff x="5842000" y="1016000"/>
+            <a:chExt cx="1778000" cy="1206500"/>
+          </a:xfrm>
+          <a:solidFill>
+            <a:srgbClr val="156082"/>
+          </a:solidFill>
+          <a:effectLst>
+            <a:glow rad="101600">
+              <a:srgbClr val="DC780A">
+                <a:alpha val="80000"/>
+              </a:srgbClr>
+            </a:glow>
+          </a:effectLst>
+        </p:grpSpPr>
+        <p:sp>
+          <p:nvSpPr>
+            <p:cNvPr id="9" name="Group glow A">
+              <a:extLst>
+                <a:ext uri="{FF2B5EF4-FFF2-40B4-BE49-F238E27FC236}">
+                  <a16:creationId xmlns:a16="http://schemas.microsoft.com/office/drawing/2014/main" id="{68E5F410-40E5-A402-82EA-E01AE357E203}"/>
+                </a:ext>
+              </a:extLst>
+            </p:cNvPr>
+            <p:cNvSpPr/>
+            <p:nvPr/>
+          </p:nvSpPr>
+          <p:spPr>
+            <a:xfrm>
+              <a:off x="5842000" y="1016000"/>
+              <a:ext cx="1079500" cy="825500"/>
+            </a:xfrm>
+            <a:prstGeom prst="rect">
+              <a:avLst/>
+            </a:prstGeom>
+            <a:grpFill/>
+            <a:ln w="19050" cap="flat" cmpd="sng" algn="ctr">
+              <a:noFill/>
+              <a:prstDash val="solid"/>
+              <a:miter lim="800000"/>
+            </a:ln>
+            <a:effectLst/>
+            <a:extLst>
+              <a:ext uri="{91240B29-F687-4F45-9708-019B960494DF}">
+                <a14:hiddenLine xmlns:a14="http://schemas.microsoft.com/office/drawing/2010/main" w="19050" cap="flat" cmpd="sng" algn="ctr">
+                  <a:solidFill>
+                    <a:schemeClr val="accent1">
+                      <a:shade val="15000"/>
+                    </a:schemeClr>
+                  </a:solidFill>
+                  <a:prstDash val="solid"/>
+                  <a:miter lim="800000"/>
+                </a14:hiddenLine>
+              </a:ext>
+            </a:extLst>
+          </p:spPr>
+          <p:style>
+            <a:lnRef idx="2">
+              <a:schemeClr val="accent1">
+                <a:shade val="15000"/>
+              </a:schemeClr>
+            </a:lnRef>
+            <a:fillRef idx="1">
+              <a:schemeClr val="accent1"/>
+            </a:fillRef>
+            <a:effectRef idx="0">
+              <a:schemeClr val="accent1"/>
+            </a:effectRef>
+            <a:fontRef idx="minor">
+              <a:schemeClr val="lt1"/>
+            </a:fontRef>
+          </p:style>
+          <p:txBody>
+            <a:bodyPr rtlCol="0" anchor="ctr"/>
+            <a:lstStyle/>
+            <a:p>
+              <a:pPr algn="ctr"/>
+              <a:r>
+                <a:rPr lang="ar-EG" sz="1400">
+                  <a:latin typeface="Arial" panose="020B0604020202020204" pitchFamily="34" charset="0"/>
+                </a:rPr>
+                <a:t>مجموعة</a:t>
+              </a:r>
+              <a:endParaRPr lang="en-US" sz="1400">
+                <a:latin typeface="Arial" panose="020B0604020202020204" pitchFamily="34" charset="0"/>
+              </a:endParaRPr>
+            </a:p>
+          </p:txBody>
+        </p:sp>
+        <p:sp>
+          <p:nvSpPr>
+            <p:cNvPr id="10" name="Group glow B">
+              <a:extLst>
+                <a:ext uri="{FF2B5EF4-FFF2-40B4-BE49-F238E27FC236}">
+                  <a16:creationId xmlns:a16="http://schemas.microsoft.com/office/drawing/2014/main" id="{E93FBC87-0054-980B-A551-2553F7E75297}"/>
+                </a:ext>
+              </a:extLst>
+            </p:cNvPr>
+            <p:cNvSpPr/>
+            <p:nvPr/>
+          </p:nvSpPr>
+          <p:spPr>
+            <a:xfrm>
+              <a:off x="6540500" y="1397000"/>
+              <a:ext cx="1079500" cy="825500"/>
+            </a:xfrm>
+            <a:prstGeom prst="ellipse">
+              <a:avLst/>
+            </a:prstGeom>
+            <a:grpFill/>
+            <a:ln w="19050" cap="flat" cmpd="sng" algn="ctr">
+              <a:noFill/>
+              <a:prstDash val="solid"/>
+              <a:miter lim="800000"/>
+            </a:ln>
+            <a:effectLst/>
+            <a:extLst>
+              <a:ext uri="{91240B29-F687-4F45-9708-019B960494DF}">
+                <a14:hiddenLine xmlns:a14="http://schemas.microsoft.com/office/drawing/2010/main" w="19050" cap="flat" cmpd="sng" algn="ctr">
+                  <a:solidFill>
+                    <a:schemeClr val="accent1">
+                      <a:shade val="15000"/>
+                    </a:schemeClr>
+                  </a:solidFill>
+                  <a:prstDash val="solid"/>
+                  <a:miter lim="800000"/>
+                </a14:hiddenLine>
+              </a:ext>
+            </a:extLst>
+          </p:spPr>
+          <p:style>
+            <a:lnRef idx="2">
+              <a:schemeClr val="accent1">
+                <a:shade val="15000"/>
+              </a:schemeClr>
+            </a:lnRef>
+            <a:fillRef idx="1">
+              <a:schemeClr val="accent1"/>
+            </a:fillRef>
+            <a:effectRef idx="0">
+              <a:schemeClr val="accent1"/>
+            </a:effectRef>
+            <a:fontRef idx="minor">
+              <a:schemeClr val="lt1"/>
+            </a:fontRef>
+          </p:style>
+          <p:txBody>
+            <a:bodyPr rtlCol="0" anchor="ctr"/>
+            <a:lstStyle/>
+            <a:p>
+              <a:pPr algn="ctr"/>
+              <a:r>
+                <a:rPr lang="en-US" sz="1400">
+                  <a:latin typeface="Arial" panose="020B0604020202020204" pitchFamily="34" charset="0"/>
+                </a:rPr>
+                <a:t>Group</a:t>
+              </a:r>
+            </a:p>
+          </p:txBody>
+        </p:sp>
+      </p:grpSp>
+      <p:grpSp>
+        <p:nvGrpSpPr>
+          <p:cNvPr id="16" name="Group nested outer">
+            <a:extLst>
+              <a:ext uri="{FF2B5EF4-FFF2-40B4-BE49-F238E27FC236}">
+                <a16:creationId xmlns:a16="http://schemas.microsoft.com/office/drawing/2014/main" id="{32905409-6067-0D74-436D-7056991DFB56}"/>
+              </a:ext>
+            </a:extLst>
+          </p:cNvPr>
+          <p:cNvGrpSpPr/>
+          <p:nvPr/>
+        </p:nvGrpSpPr>
+        <p:grpSpPr>
+          <a:xfrm>
+            <a:off x="508000" y="3175000"/>
+            <a:ext cx="2032000" cy="1206500"/>
+            <a:chOff x="508000" y="3175000"/>
+            <a:chExt cx="2032000" cy="1206500"/>
+          </a:xfrm>
+          <a:gradFill flip="none" rotWithShape="1">
+            <a:gsLst>
+              <a:gs pos="0">
+                <a:srgbClr val="156082"/>
+              </a:gs>
+              <a:gs pos="100000">
+                <a:srgbClr val="FFFFFF"/>
+              </a:gs>
+            </a:gsLst>
+            <a:lin ang="5400000" scaled="1"/>
+            <a:tileRect/>
+          </a:gradFill>
+        </p:grpSpPr>
+        <p:grpSp>
+          <p:nvGrpSpPr>
+            <p:cNvPr id="14" name="Group nested fill">
+              <a:extLst>
+                <a:ext uri="{FF2B5EF4-FFF2-40B4-BE49-F238E27FC236}">
+                  <a16:creationId xmlns:a16="http://schemas.microsoft.com/office/drawing/2014/main" id="{C2BE28D3-4140-3BCD-C30F-2E781C3F4EE4}"/>
+                </a:ext>
+              </a:extLst>
+            </p:cNvPr>
+            <p:cNvGrpSpPr/>
+            <p:nvPr/>
+          </p:nvGrpSpPr>
+          <p:grpSpPr>
+            <a:xfrm>
+              <a:off x="508000" y="3175000"/>
+              <a:ext cx="1778000" cy="1206500"/>
+              <a:chOff x="508000" y="3175000"/>
+              <a:chExt cx="1778000" cy="1206500"/>
+            </a:xfrm>
+            <a:grpFill/>
+          </p:grpSpPr>
+          <p:sp>
+            <p:nvSpPr>
+              <p:cNvPr id="12" name="Group nested fill A">
+                <a:extLst>
+                  <a:ext uri="{FF2B5EF4-FFF2-40B4-BE49-F238E27FC236}">
+                    <a16:creationId xmlns:a16="http://schemas.microsoft.com/office/drawing/2014/main" id="{F0C0CEB5-5AA8-1723-150E-ADC9A2A43DCD}"/>
+                  </a:ext>
+                </a:extLst>
+              </p:cNvPr>
+              <p:cNvSpPr/>
+              <p:nvPr/>
+            </p:nvSpPr>
+            <p:spPr>
+              <a:xfrm>
+                <a:off x="508000" y="3175000"/>
+                <a:ext cx="1079500" cy="825500"/>
+              </a:xfrm>
+              <a:prstGeom prst="rect">
+                <a:avLst/>
+              </a:prstGeom>
+              <a:grpFill/>
+              <a:ln w="19050" cap="flat" cmpd="sng" algn="ctr">
+                <a:noFill/>
+                <a:prstDash val="solid"/>
+                <a:miter lim="800000"/>
+              </a:ln>
+              <a:effectLst/>
+              <a:extLst>
+                <a:ext uri="{91240B29-F687-4F45-9708-019B960494DF}">
+                  <a14:hiddenLine xmlns:a14="http://schemas.microsoft.com/office/drawing/2010/main" w="19050" cap="flat" cmpd="sng" algn="ctr">
+                    <a:solidFill>
+                      <a:schemeClr val="accent1">
+                        <a:shade val="15000"/>
+                      </a:schemeClr>
+                    </a:solidFill>
+                    <a:prstDash val="solid"/>
+                    <a:miter lim="800000"/>
+                  </a14:hiddenLine>
+                </a:ext>
+              </a:extLst>
+            </p:spPr>
+            <p:style>
+              <a:lnRef idx="2">
+                <a:schemeClr val="accent1">
+                  <a:shade val="15000"/>
+                </a:schemeClr>
+              </a:lnRef>
+              <a:fillRef idx="1">
+                <a:schemeClr val="accent1"/>
+              </a:fillRef>
+              <a:effectRef idx="0">
+                <a:schemeClr val="accent1"/>
+              </a:effectRef>
+              <a:fontRef idx="minor">
+                <a:schemeClr val="lt1"/>
+              </a:fontRef>
+            </p:style>
+            <p:txBody>
+              <a:bodyPr rtlCol="0" anchor="ctr"/>
+              <a:lstStyle/>
+              <a:p>
+                <a:pPr algn="ctr"/>
+                <a:r>
+                  <a:rPr lang="ar-EG" sz="1400">
+                    <a:latin typeface="Arial" panose="020B0604020202020204" pitchFamily="34" charset="0"/>
+                  </a:rPr>
+                  <a:t>مجموعة</a:t>
+                </a:r>
+                <a:endParaRPr lang="en-US" sz="1400">
+                  <a:latin typeface="Arial" panose="020B0604020202020204" pitchFamily="34" charset="0"/>
+                </a:endParaRPr>
+              </a:p>
+            </p:txBody>
+          </p:sp>
+          <p:sp>
+            <p:nvSpPr>
+              <p:cNvPr id="13" name="Group nested fill B">
+                <a:extLst>
+                  <a:ext uri="{FF2B5EF4-FFF2-40B4-BE49-F238E27FC236}">
+                    <a16:creationId xmlns:a16="http://schemas.microsoft.com/office/drawing/2014/main" id="{CD178A9C-908C-0D7C-E0A4-343600C92807}"/>
+                  </a:ext>
+                </a:extLst>
+              </p:cNvPr>
+              <p:cNvSpPr/>
+              <p:nvPr/>
+            </p:nvSpPr>
+            <p:spPr>
+              <a:xfrm>
+                <a:off x="1206500" y="3556000"/>
+                <a:ext cx="1079500" cy="825500"/>
+              </a:xfrm>
+              <a:prstGeom prst="ellipse">
+                <a:avLst/>
+              </a:prstGeom>
+              <a:grpFill/>
+              <a:ln w="19050" cap="flat" cmpd="sng" algn="ctr">
+                <a:noFill/>
+                <a:prstDash val="solid"/>
+                <a:miter lim="800000"/>
+              </a:ln>
+              <a:effectLst/>
+              <a:extLst>
+                <a:ext uri="{91240B29-F687-4F45-9708-019B960494DF}">
+                  <a14:hiddenLine xmlns:a14="http://schemas.microsoft.com/office/drawing/2010/main" w="19050" cap="flat" cmpd="sng" algn="ctr">
+                    <a:solidFill>
+                      <a:schemeClr val="accent1">
+                        <a:shade val="15000"/>
+                      </a:schemeClr>
+                    </a:solidFill>
+                    <a:prstDash val="solid"/>
+                    <a:miter lim="800000"/>
+                  </a14:hiddenLine>
+                </a:ext>
+              </a:extLst>
+            </p:spPr>
+            <p:style>
+              <a:lnRef idx="2">
+                <a:schemeClr val="accent1">
+                  <a:shade val="15000"/>
+                </a:schemeClr>
+              </a:lnRef>
+              <a:fillRef idx="1">
+                <a:schemeClr val="accent1"/>
+              </a:fillRef>
+              <a:effectRef idx="0">
+                <a:schemeClr val="accent1"/>
+              </a:effectRef>
+              <a:fontRef idx="minor">
+                <a:schemeClr val="lt1"/>
+              </a:fontRef>
+            </p:style>
+            <p:txBody>
+              <a:bodyPr rtlCol="0" anchor="ctr"/>
+              <a:lstStyle/>
+              <a:p>
+                <a:pPr algn="ctr"/>
+                <a:r>
+                  <a:rPr lang="en-US" sz="1400">
+                    <a:latin typeface="Arial" panose="020B0604020202020204" pitchFamily="34" charset="0"/>
+                  </a:rPr>
+                  <a:t>Group</a:t>
+                </a:r>
+              </a:p>
+            </p:txBody>
+          </p:sp>
+        </p:grpSp>
+        <p:sp>
+          <p:nvSpPr>
+            <p:cNvPr id="15" name="Nested fill transparent">
+              <a:extLst>
+                <a:ext uri="{FF2B5EF4-FFF2-40B4-BE49-F238E27FC236}">
+                  <a16:creationId xmlns:a16="http://schemas.microsoft.com/office/drawing/2014/main" id="{F925ED96-93C2-D385-238A-F02A7AC57BAD}"/>
+                </a:ext>
+              </a:extLst>
+            </p:cNvPr>
+            <p:cNvSpPr/>
+            <p:nvPr/>
+          </p:nvSpPr>
+          <p:spPr>
+            <a:xfrm>
+              <a:off x="2159000" y="3937000"/>
+              <a:ext cx="381000" cy="381000"/>
+            </a:xfrm>
+            <a:prstGeom prst="rect">
+              <a:avLst/>
+            </a:prstGeom>
+            <a:noFill/>
+            <a:ln w="19050" cap="flat" cmpd="sng" algn="ctr">
+              <a:noFill/>
+              <a:prstDash val="solid"/>
+              <a:miter lim="800000"/>
+            </a:ln>
+            <a:effectLst/>
+            <a:extLst>
+              <a:ext uri="{909E8E84-426E-40DD-AFC4-6F175D3DCCD1}">
+                <a14:hiddenFill xmlns:a14="http://schemas.microsoft.com/office/drawing/2010/main">
+                  <a:gradFill flip="none" rotWithShape="1">
+                    <a:gsLst>
+                      <a:gs pos="0">
+                        <a:schemeClr val="accent1"/>
+                      </a:gs>
+                      <a:gs pos="100000">
+                        <a:schemeClr val="accent1"/>
+                      </a:gs>
+                    </a:gsLst>
+                    <a:lin ang="5400000" scaled="1"/>
+                    <a:tileRect/>
+                  </a:gradFill>
+                </a14:hiddenFill>
+              </a:ext>
+              <a:ext uri="{91240B29-F687-4F45-9708-019B960494DF}">
+                <a14:hiddenLine xmlns:a14="http://schemas.microsoft.com/office/drawing/2010/main" w="19050" cap="flat" cmpd="sng" algn="ctr">
+                  <a:solidFill>
+                    <a:schemeClr val="accent1">
+                      <a:shade val="15000"/>
+                    </a:schemeClr>
+                  </a:solidFill>
+                  <a:prstDash val="solid"/>
+                  <a:miter lim="800000"/>
+                </a14:hiddenLine>
+              </a:ext>
+            </a:extLst>
+          </p:spPr>
+          <p:style>
+            <a:lnRef idx="2">
+              <a:schemeClr val="accent1">
+                <a:shade val="15000"/>
+              </a:schemeClr>
+            </a:lnRef>
+            <a:fillRef idx="1">
+              <a:schemeClr val="accent1"/>
+            </a:fillRef>
+            <a:effectRef idx="0">
+              <a:schemeClr val="accent1"/>
+            </a:effectRef>
+            <a:fontRef idx="minor">
+              <a:schemeClr val="lt1"/>
+            </a:fontRef>
+          </p:style>
+          <p:txBody>
+            <a:bodyPr rtlCol="0" anchor="ctr"/>
+            <a:lstStyle/>
+            <a:p>
+              <a:pPr algn="ctr"/>
+              <a:endParaRPr lang="en-US"/>
+            </a:p>
+          </p:txBody>
+        </p:sp>
+      </p:grpSp>
+      <p:grpSp>
+        <p:nvGrpSpPr>
+          <p:cNvPr id="20" name="Group reflection">
+            <a:extLst>
+              <a:ext uri="{FF2B5EF4-FFF2-40B4-BE49-F238E27FC236}">
+                <a16:creationId xmlns:a16="http://schemas.microsoft.com/office/drawing/2014/main" id="{0E46BAF5-3A35-CF21-300E-B785971E21B8}"/>
+              </a:ext>
+            </a:extLst>
+          </p:cNvPr>
+          <p:cNvGrpSpPr/>
+          <p:nvPr/>
+        </p:nvGrpSpPr>
+        <p:grpSpPr>
+          <a:xfrm>
+            <a:off x="3175000" y="3175000"/>
+            <a:ext cx="1778000" cy="1206500"/>
+            <a:chOff x="3175000" y="3175000"/>
+            <a:chExt cx="1778000" cy="1206500"/>
+          </a:xfrm>
+          <a:solidFill>
+            <a:srgbClr val="156082"/>
+          </a:solidFill>
+          <a:effectLst>
+            <a:reflection blurRad="6350" stA="50000" endA="300" endPos="55000" dir="5400000" sy="-100000" algn="bl" rotWithShape="0"/>
+          </a:effectLst>
+        </p:grpSpPr>
+        <p:sp>
+          <p:nvSpPr>
+            <p:cNvPr id="18" name="Group reflection A">
+              <a:extLst>
+                <a:ext uri="{FF2B5EF4-FFF2-40B4-BE49-F238E27FC236}">
+                  <a16:creationId xmlns:a16="http://schemas.microsoft.com/office/drawing/2014/main" id="{61328323-7A62-A8C7-2BDF-7C8BC1E38CAA}"/>
+                </a:ext>
+              </a:extLst>
+            </p:cNvPr>
+            <p:cNvSpPr/>
+            <p:nvPr/>
+          </p:nvSpPr>
+          <p:spPr>
+            <a:xfrm>
+              <a:off x="3175000" y="3175000"/>
+              <a:ext cx="1079500" cy="825500"/>
+            </a:xfrm>
+            <a:prstGeom prst="rect">
+              <a:avLst/>
+            </a:prstGeom>
+            <a:grpFill/>
+            <a:ln w="19050" cap="flat" cmpd="sng" algn="ctr">
+              <a:noFill/>
+              <a:prstDash val="solid"/>
+              <a:miter lim="800000"/>
+            </a:ln>
+            <a:effectLst/>
+            <a:extLst>
+              <a:ext uri="{91240B29-F687-4F45-9708-019B960494DF}">
+                <a14:hiddenLine xmlns:a14="http://schemas.microsoft.com/office/drawing/2010/main" w="19050" cap="flat" cmpd="sng" algn="ctr">
+                  <a:solidFill>
+                    <a:schemeClr val="accent1">
+                      <a:shade val="15000"/>
+                    </a:schemeClr>
+                  </a:solidFill>
+                  <a:prstDash val="solid"/>
+                  <a:miter lim="800000"/>
+                </a14:hiddenLine>
+              </a:ext>
+            </a:extLst>
+          </p:spPr>
+          <p:style>
+            <a:lnRef idx="2">
+              <a:schemeClr val="accent1">
+                <a:shade val="15000"/>
+              </a:schemeClr>
+            </a:lnRef>
+            <a:fillRef idx="1">
+              <a:schemeClr val="accent1"/>
+            </a:fillRef>
+            <a:effectRef idx="0">
+              <a:schemeClr val="accent1"/>
+            </a:effectRef>
+            <a:fontRef idx="minor">
+              <a:schemeClr val="lt1"/>
+            </a:fontRef>
+          </p:style>
+          <p:txBody>
+            <a:bodyPr rtlCol="0" anchor="ctr"/>
+            <a:lstStyle/>
+            <a:p>
+              <a:pPr algn="ctr"/>
+              <a:r>
+                <a:rPr lang="ar-EG" sz="1400">
+                  <a:latin typeface="Arial" panose="020B0604020202020204" pitchFamily="34" charset="0"/>
+                </a:rPr>
+                <a:t>مجموعة</a:t>
+              </a:r>
+              <a:endParaRPr lang="en-US" sz="1400">
+                <a:latin typeface="Arial" panose="020B0604020202020204" pitchFamily="34" charset="0"/>
+              </a:endParaRPr>
+            </a:p>
+          </p:txBody>
+        </p:sp>
+        <p:sp>
+          <p:nvSpPr>
+            <p:cNvPr id="19" name="Group reflection B">
+              <a:extLst>
+                <a:ext uri="{FF2B5EF4-FFF2-40B4-BE49-F238E27FC236}">
+                  <a16:creationId xmlns:a16="http://schemas.microsoft.com/office/drawing/2014/main" id="{B0208CEF-F4E7-83F7-A846-D866B6958BE0}"/>
+                </a:ext>
+              </a:extLst>
+            </p:cNvPr>
+            <p:cNvSpPr/>
+            <p:nvPr/>
+          </p:nvSpPr>
+          <p:spPr>
+            <a:xfrm>
+              <a:off x="3873500" y="3556000"/>
+              <a:ext cx="1079500" cy="825500"/>
+            </a:xfrm>
+            <a:prstGeom prst="ellipse">
+              <a:avLst/>
+            </a:prstGeom>
+            <a:grpFill/>
+            <a:ln w="19050" cap="flat" cmpd="sng" algn="ctr">
+              <a:noFill/>
+              <a:prstDash val="solid"/>
+              <a:miter lim="800000"/>
+            </a:ln>
+            <a:effectLst/>
+            <a:extLst>
+              <a:ext uri="{91240B29-F687-4F45-9708-019B960494DF}">
+                <a14:hiddenLine xmlns:a14="http://schemas.microsoft.com/office/drawing/2010/main" w="19050" cap="flat" cmpd="sng" algn="ctr">
+                  <a:solidFill>
+                    <a:schemeClr val="accent1">
+                      <a:shade val="15000"/>
+                    </a:schemeClr>
+                  </a:solidFill>
+                  <a:prstDash val="solid"/>
+                  <a:miter lim="800000"/>
+                </a14:hiddenLine>
+              </a:ext>
+            </a:extLst>
+          </p:spPr>
+          <p:style>
+            <a:lnRef idx="2">
+              <a:schemeClr val="accent1">
+                <a:shade val="15000"/>
+              </a:schemeClr>
+            </a:lnRef>
+            <a:fillRef idx="1">
+              <a:schemeClr val="accent1"/>
+            </a:fillRef>
+            <a:effectRef idx="0">
+              <a:schemeClr val="accent1"/>
+            </a:effectRef>
+            <a:fontRef idx="minor">
+              <a:schemeClr val="lt1"/>
+            </a:fontRef>
+          </p:style>
+          <p:txBody>
+            <a:bodyPr rtlCol="0" anchor="ctr"/>
+            <a:lstStyle/>
+            <a:p>
+              <a:pPr algn="ctr"/>
+              <a:r>
+                <a:rPr lang="en-US" sz="1400">
+                  <a:latin typeface="Arial" panose="020B0604020202020204" pitchFamily="34" charset="0"/>
+                </a:rPr>
+                <a:t>Group</a:t>
+              </a:r>
+            </a:p>
+          </p:txBody>
+        </p:sp>
+      </p:grpSp>
+      <p:grpSp>
+        <p:nvGrpSpPr>
+          <p:cNvPr id="23" name="Group inner shadow">
+            <a:extLst>
+              <a:ext uri="{FF2B5EF4-FFF2-40B4-BE49-F238E27FC236}">
+                <a16:creationId xmlns:a16="http://schemas.microsoft.com/office/drawing/2014/main" id="{F4300882-FFB2-75D3-C39C-74B1666C36D0}"/>
+              </a:ext>
+            </a:extLst>
+          </p:cNvPr>
+          <p:cNvGrpSpPr/>
+          <p:nvPr/>
+        </p:nvGrpSpPr>
+        <p:grpSpPr>
+          <a:xfrm>
+            <a:off x="5842000" y="3175000"/>
+            <a:ext cx="1778000" cy="1206500"/>
+            <a:chOff x="5842000" y="3175000"/>
+            <a:chExt cx="1778000" cy="1206500"/>
+          </a:xfrm>
+          <a:solidFill>
+            <a:srgbClr val="156082"/>
+          </a:solidFill>
+        </p:grpSpPr>
+        <p:sp>
+          <p:nvSpPr>
+            <p:cNvPr id="21" name="Group inner shadow A">
+              <a:extLst>
+                <a:ext uri="{FF2B5EF4-FFF2-40B4-BE49-F238E27FC236}">
+                  <a16:creationId xmlns:a16="http://schemas.microsoft.com/office/drawing/2014/main" id="{5ACAC6CD-5ECD-C667-8E3C-785C208BE31F}"/>
+                </a:ext>
+              </a:extLst>
+            </p:cNvPr>
+            <p:cNvSpPr/>
+            <p:nvPr/>
+          </p:nvSpPr>
+          <p:spPr>
+            <a:xfrm>
+              <a:off x="5842000" y="3175000"/>
+              <a:ext cx="1079500" cy="825500"/>
+            </a:xfrm>
+            <a:prstGeom prst="rect">
+              <a:avLst/>
+            </a:prstGeom>
+            <a:grpFill/>
+            <a:ln w="19050" cap="flat" cmpd="sng" algn="ctr">
+              <a:noFill/>
+              <a:prstDash val="solid"/>
+              <a:miter lim="800000"/>
+            </a:ln>
+            <a:effectLst>
+              <a:innerShdw blurRad="38100" dist="63500" dir="2212194">
+                <a:srgbClr val="000000">
+                  <a:alpha val="70000"/>
+                </a:srgbClr>
+              </a:innerShdw>
+            </a:effectLst>
+            <a:extLst>
+              <a:ext uri="{91240B29-F687-4F45-9708-019B960494DF}">
+                <a14:hiddenLine xmlns:a14="http://schemas.microsoft.com/office/drawing/2010/main" w="19050" cap="flat" cmpd="sng" algn="ctr">
+                  <a:solidFill>
+                    <a:schemeClr val="accent1">
+                      <a:shade val="15000"/>
+                    </a:schemeClr>
+                  </a:solidFill>
+                  <a:prstDash val="solid"/>
+                  <a:miter lim="800000"/>
+                </a14:hiddenLine>
+              </a:ext>
+            </a:extLst>
+          </p:spPr>
+          <p:style>
+            <a:lnRef idx="2">
+              <a:schemeClr val="accent1">
+                <a:shade val="15000"/>
+              </a:schemeClr>
+            </a:lnRef>
+            <a:fillRef idx="1">
+              <a:schemeClr val="accent1"/>
+            </a:fillRef>
+            <a:effectRef idx="0">
+              <a:schemeClr val="accent1"/>
+            </a:effectRef>
+            <a:fontRef idx="minor">
+              <a:schemeClr val="lt1"/>
+            </a:fontRef>
+          </p:style>
+          <p:txBody>
+            <a:bodyPr rtlCol="0" anchor="ctr"/>
+            <a:lstStyle/>
+            <a:p>
+              <a:pPr algn="ctr"/>
+              <a:r>
+                <a:rPr lang="ar-EG" sz="1400">
+                  <a:latin typeface="Arial" panose="020B0604020202020204" pitchFamily="34" charset="0"/>
+                </a:rPr>
+                <a:t>مجموعة</a:t>
+              </a:r>
+              <a:endParaRPr lang="en-US" sz="1400">
+                <a:latin typeface="Arial" panose="020B0604020202020204" pitchFamily="34" charset="0"/>
+              </a:endParaRPr>
+            </a:p>
+          </p:txBody>
+        </p:sp>
+        <p:sp>
+          <p:nvSpPr>
+            <p:cNvPr id="22" name="Group inner shadow B">
+              <a:extLst>
+                <a:ext uri="{FF2B5EF4-FFF2-40B4-BE49-F238E27FC236}">
+                  <a16:creationId xmlns:a16="http://schemas.microsoft.com/office/drawing/2014/main" id="{0F10016D-B589-3356-3ADC-C113E482631B}"/>
+                </a:ext>
+              </a:extLst>
+            </p:cNvPr>
+            <p:cNvSpPr/>
+            <p:nvPr/>
+          </p:nvSpPr>
+          <p:spPr>
+            <a:xfrm>
+              <a:off x="6540500" y="3556000"/>
+              <a:ext cx="1079500" cy="825500"/>
+            </a:xfrm>
+            <a:prstGeom prst="ellipse">
+              <a:avLst/>
+            </a:prstGeom>
+            <a:grpFill/>
+            <a:ln w="19050" cap="flat" cmpd="sng" algn="ctr">
+              <a:noFill/>
+              <a:prstDash val="solid"/>
+              <a:miter lim="800000"/>
+            </a:ln>
+            <a:effectLst>
+              <a:innerShdw blurRad="38100" dist="63500" dir="2212194">
+                <a:srgbClr val="000000">
+                  <a:alpha val="70000"/>
+                </a:srgbClr>
+              </a:innerShdw>
+            </a:effectLst>
+            <a:extLst>
+              <a:ext uri="{91240B29-F687-4F45-9708-019B960494DF}">
+                <a14:hiddenLine xmlns:a14="http://schemas.microsoft.com/office/drawing/2010/main" w="19050" cap="flat" cmpd="sng" algn="ctr">
+                  <a:solidFill>
+                    <a:schemeClr val="accent1">
+                      <a:shade val="15000"/>
+                    </a:schemeClr>
+                  </a:solidFill>
+                  <a:prstDash val="solid"/>
+                  <a:miter lim="800000"/>
+                </a14:hiddenLine>
+              </a:ext>
+            </a:extLst>
+          </p:spPr>
+          <p:style>
+            <a:lnRef idx="2">
+              <a:schemeClr val="accent1">
+                <a:shade val="15000"/>
+              </a:schemeClr>
+            </a:lnRef>
+            <a:fillRef idx="1">
+              <a:schemeClr val="accent1"/>
+            </a:fillRef>
+            <a:effectRef idx="0">
+              <a:schemeClr val="accent1"/>
+            </a:effectRef>
+            <a:fontRef idx="minor">
+              <a:schemeClr val="lt1"/>
+            </a:fontRef>
+          </p:style>
+          <p:txBody>
+            <a:bodyPr rtlCol="0" anchor="ctr"/>
+            <a:lstStyle/>
+            <a:p>
+              <a:pPr algn="ctr"/>
+              <a:r>
+                <a:rPr lang="en-US" sz="1400">
+                  <a:latin typeface="Arial" panose="020B0604020202020204" pitchFamily="34" charset="0"/>
+                </a:rPr>
+                <a:t>Group</a:t>
+              </a:r>
+            </a:p>
+          </p:txBody>
+        </p:sp>
+      </p:grpSp>
+      <p:grpSp>
+        <p:nvGrpSpPr>
+          <p:cNvPr id="26" name="Group soft edge">
+            <a:extLst>
+              <a:ext uri="{FF2B5EF4-FFF2-40B4-BE49-F238E27FC236}">
+                <a16:creationId xmlns:a16="http://schemas.microsoft.com/office/drawing/2014/main" id="{9118D3F6-1CF1-1859-9BDC-4DDB0F281DE3}"/>
+              </a:ext>
+            </a:extLst>
+          </p:cNvPr>
+          <p:cNvGrpSpPr/>
+          <p:nvPr/>
+        </p:nvGrpSpPr>
+        <p:grpSpPr>
+          <a:xfrm>
+            <a:off x="508000" y="5334000"/>
+            <a:ext cx="1778000" cy="1206500"/>
+            <a:chOff x="508000" y="5334000"/>
+            <a:chExt cx="1778000" cy="1206500"/>
+          </a:xfrm>
+          <a:solidFill>
+            <a:srgbClr val="156082"/>
+          </a:solidFill>
+          <a:effectLst>
+            <a:softEdge rad="63500"/>
+          </a:effectLst>
+        </p:grpSpPr>
+        <p:sp>
+          <p:nvSpPr>
+            <p:cNvPr id="24" name="Group soft edge A">
+              <a:extLst>
+                <a:ext uri="{FF2B5EF4-FFF2-40B4-BE49-F238E27FC236}">
+                  <a16:creationId xmlns:a16="http://schemas.microsoft.com/office/drawing/2014/main" id="{43411E50-F9AF-C729-8D20-DE4C5788C1D6}"/>
+                </a:ext>
+              </a:extLst>
+            </p:cNvPr>
+            <p:cNvSpPr/>
+            <p:nvPr/>
+          </p:nvSpPr>
+          <p:spPr>
+            <a:xfrm>
+              <a:off x="508000" y="5334000"/>
+              <a:ext cx="1079500" cy="825500"/>
+            </a:xfrm>
+            <a:prstGeom prst="rect">
+              <a:avLst/>
+            </a:prstGeom>
+            <a:grpFill/>
+            <a:ln w="19050" cap="flat" cmpd="sng" algn="ctr">
+              <a:noFill/>
+              <a:prstDash val="solid"/>
+              <a:miter lim="800000"/>
+            </a:ln>
+            <a:effectLst/>
+            <a:extLst>
+              <a:ext uri="{91240B29-F687-4F45-9708-019B960494DF}">
+                <a14:hiddenLine xmlns:a14="http://schemas.microsoft.com/office/drawing/2010/main" w="19050" cap="flat" cmpd="sng" algn="ctr">
+                  <a:solidFill>
+                    <a:schemeClr val="accent1">
+                      <a:shade val="15000"/>
+                    </a:schemeClr>
+                  </a:solidFill>
+                  <a:prstDash val="solid"/>
+                  <a:miter lim="800000"/>
+                </a14:hiddenLine>
+              </a:ext>
+            </a:extLst>
+          </p:spPr>
+          <p:style>
+            <a:lnRef idx="2">
+              <a:schemeClr val="accent1">
+                <a:shade val="15000"/>
+              </a:schemeClr>
+            </a:lnRef>
+            <a:fillRef idx="1">
+              <a:schemeClr val="accent1"/>
+            </a:fillRef>
+            <a:effectRef idx="0">
+              <a:schemeClr val="accent1"/>
+            </a:effectRef>
+            <a:fontRef idx="minor">
+              <a:schemeClr val="lt1"/>
+            </a:fontRef>
+          </p:style>
+          <p:txBody>
+            <a:bodyPr rtlCol="0" anchor="ctr"/>
+            <a:lstStyle/>
+            <a:p>
+              <a:pPr algn="ctr"/>
+              <a:r>
+                <a:rPr lang="ar-EG" sz="1400">
+                  <a:latin typeface="Arial" panose="020B0604020202020204" pitchFamily="34" charset="0"/>
+                </a:rPr>
+                <a:t>مجموعة</a:t>
+              </a:r>
+              <a:endParaRPr lang="en-US" sz="1400">
+                <a:latin typeface="Arial" panose="020B0604020202020204" pitchFamily="34" charset="0"/>
+              </a:endParaRPr>
+            </a:p>
+          </p:txBody>
+        </p:sp>
+        <p:sp>
+          <p:nvSpPr>
+            <p:cNvPr id="25" name="Group soft edge B">
+              <a:extLst>
+                <a:ext uri="{FF2B5EF4-FFF2-40B4-BE49-F238E27FC236}">
+                  <a16:creationId xmlns:a16="http://schemas.microsoft.com/office/drawing/2014/main" id="{F37BED01-5FC3-C9B9-6EA7-3359166ADC8D}"/>
+                </a:ext>
+              </a:extLst>
+            </p:cNvPr>
+            <p:cNvSpPr/>
+            <p:nvPr/>
+          </p:nvSpPr>
+          <p:spPr>
+            <a:xfrm>
+              <a:off x="1206500" y="5715000"/>
+              <a:ext cx="1079500" cy="825500"/>
+            </a:xfrm>
+            <a:prstGeom prst="ellipse">
+              <a:avLst/>
+            </a:prstGeom>
+            <a:grpFill/>
+            <a:ln w="19050" cap="flat" cmpd="sng" algn="ctr">
+              <a:noFill/>
+              <a:prstDash val="solid"/>
+              <a:miter lim="800000"/>
+            </a:ln>
+            <a:effectLst/>
+            <a:extLst>
+              <a:ext uri="{91240B29-F687-4F45-9708-019B960494DF}">
+                <a14:hiddenLine xmlns:a14="http://schemas.microsoft.com/office/drawing/2010/main" w="19050" cap="flat" cmpd="sng" algn="ctr">
+                  <a:solidFill>
+                    <a:schemeClr val="accent1">
+                      <a:shade val="15000"/>
+                    </a:schemeClr>
+                  </a:solidFill>
+                  <a:prstDash val="solid"/>
+                  <a:miter lim="800000"/>
+                </a14:hiddenLine>
+              </a:ext>
+            </a:extLst>
+          </p:spPr>
+          <p:style>
+            <a:lnRef idx="2">
+              <a:schemeClr val="accent1">
+                <a:shade val="15000"/>
+              </a:schemeClr>
+            </a:lnRef>
+            <a:fillRef idx="1">
+              <a:schemeClr val="accent1"/>
+            </a:fillRef>
+            <a:effectRef idx="0">
+              <a:schemeClr val="accent1"/>
+            </a:effectRef>
+            <a:fontRef idx="minor">
+              <a:schemeClr val="lt1"/>
+            </a:fontRef>
+          </p:style>
+          <p:txBody>
+            <a:bodyPr rtlCol="0" anchor="ctr"/>
+            <a:lstStyle/>
+            <a:p>
+              <a:pPr algn="ctr"/>
+              <a:r>
+                <a:rPr lang="en-US" sz="1400">
+                  <a:latin typeface="Arial" panose="020B0604020202020204" pitchFamily="34" charset="0"/>
+                </a:rPr>
+                <a:t>Group</a:t>
+              </a:r>
+            </a:p>
+          </p:txBody>
+        </p:sp>
+      </p:grpSp>
+    </p:spTree>
+    <p:extLst>
+      <p:ext uri="{BB962C8B-B14F-4D97-AF65-F5344CB8AC3E}">
+        <p14:creationId xmlns:p14="http://schemas.microsoft.com/office/powerpoint/2010/main" val="427893083"/>
       </p:ext>
     </p:extLst>
   </p:cSld>
@@ -8500,6 +10031,169 @@
     <p:extLst>
       <p:ext uri="{BB962C8B-B14F-4D97-AF65-F5344CB8AC3E}">
         <p14:creationId xmlns:p14="http://schemas.microsoft.com/office/powerpoint/2010/main" val="705791109"/>
+      </p:ext>
+    </p:extLst>
+  </p:cSld>
+  <p:clrMapOvr>
+    <a:masterClrMapping/>
+  </p:clrMapOvr>
+</p:sld>
+</file>
+
+<file path=ppt/slides/slide20.xml><?xml version="1.0" encoding="utf-8"?>
+<p:sld xmlns:a="http://schemas.openxmlformats.org/drawingml/2006/main" xmlns:r="http://schemas.openxmlformats.org/officeDocument/2006/relationships" xmlns:p="http://schemas.openxmlformats.org/presentationml/2006/main">
+  <p:cSld>
+    <p:spTree>
+      <p:nvGrpSpPr>
+        <p:cNvPr id="1" name=""/>
+        <p:cNvGrpSpPr/>
+        <p:nvPr/>
+      </p:nvGrpSpPr>
+      <p:grpSpPr>
+        <a:xfrm>
+          <a:off x="0" y="0"/>
+          <a:ext cx="0" cy="0"/>
+          <a:chOff x="0" y="0"/>
+          <a:chExt cx="0" cy="0"/>
+        </a:xfrm>
+      </p:grpSpPr>
+      <p:sp>
+        <p:nvSpPr>
+          <p:cNvPr id="2" name="Title 1">
+            <a:extLst>
+              <a:ext uri="{FF2B5EF4-FFF2-40B4-BE49-F238E27FC236}">
+                <a16:creationId xmlns:a16="http://schemas.microsoft.com/office/drawing/2014/main" id="{87F6A5B9-2CBF-C40A-343C-A6405B9AA487}"/>
+              </a:ext>
+            </a:extLst>
+          </p:cNvPr>
+          <p:cNvSpPr>
+            <a:spLocks noGrp="1"/>
+          </p:cNvSpPr>
+          <p:nvPr>
+            <p:ph type="title"/>
+          </p:nvPr>
+        </p:nvSpPr>
+        <p:spPr/>
+        <p:txBody>
+          <a:bodyPr/>
+          <a:lstStyle/>
+          <a:p>
+            <a:endParaRPr lang="en-US"/>
+          </a:p>
+        </p:txBody>
+      </p:sp>
+      <p:sp>
+        <p:nvSpPr>
+          <p:cNvPr id="3" name="Slide Number Placeholder 2">
+            <a:extLst>
+              <a:ext uri="{FF2B5EF4-FFF2-40B4-BE49-F238E27FC236}">
+                <a16:creationId xmlns:a16="http://schemas.microsoft.com/office/drawing/2014/main" id="{8FF23F6A-2D20-0D64-6BEC-4E5F28F5AB85}"/>
+              </a:ext>
+            </a:extLst>
+          </p:cNvPr>
+          <p:cNvSpPr>
+            <a:spLocks noGrp="1"/>
+          </p:cNvSpPr>
+          <p:nvPr>
+            <p:ph type="sldNum" sz="quarter" idx="12"/>
+          </p:nvPr>
+        </p:nvSpPr>
+        <p:spPr/>
+        <p:txBody>
+          <a:bodyPr/>
+          <a:lstStyle/>
+          <a:p>
+            <a:fld id="{DCB96425-C66E-449F-8335-3FF27AC80FA3}" type="slidenum">
+              <a:rPr lang="en-US" smtClean="0"/>
+              <a:t>20</a:t>
+            </a:fld>
+            <a:endParaRPr lang="en-US"/>
+          </a:p>
+        </p:txBody>
+      </p:sp>
+      <p:sp>
+        <p:nvSpPr>
+          <p:cNvPr id="4" name="SVG caption">
+            <a:extLst>
+              <a:ext uri="{FF2B5EF4-FFF2-40B4-BE49-F238E27FC236}">
+                <a16:creationId xmlns:a16="http://schemas.microsoft.com/office/drawing/2014/main" id="{B59402A2-3F65-0EF5-8AF8-527660F01782}"/>
+              </a:ext>
+            </a:extLst>
+          </p:cNvPr>
+          <p:cNvSpPr txBox="1"/>
+          <p:nvPr/>
+        </p:nvSpPr>
+        <p:spPr>
+          <a:xfrm>
+            <a:off x="457200" y="152400"/>
+            <a:ext cx="8128000" cy="400110"/>
+          </a:xfrm>
+          <a:prstGeom prst="rect">
+            <a:avLst/>
+          </a:prstGeom>
+          <a:noFill/>
+        </p:spPr>
+        <p:txBody>
+          <a:bodyPr vert="horz" rtlCol="0">
+            <a:spAutoFit/>
+          </a:bodyPr>
+          <a:lstStyle/>
+          <a:p>
+            <a:r>
+              <a:rPr lang="en-US" sz="2000"/>
+              <a:t>SVG picture / </a:t>
+            </a:r>
+            <a:r>
+              <a:rPr lang="ar-EG" sz="2000"/>
+              <a:t>صورة </a:t>
+            </a:r>
+            <a:r>
+              <a:rPr lang="en-US" sz="2000"/>
+              <a:t>SVG</a:t>
+            </a:r>
+          </a:p>
+        </p:txBody>
+      </p:sp>
+      <p:pic>
+        <p:nvPicPr>
+          <p:cNvPr id="6" name="SVG picture">
+            <a:extLst>
+              <a:ext uri="{FF2B5EF4-FFF2-40B4-BE49-F238E27FC236}">
+                <a16:creationId xmlns:a16="http://schemas.microsoft.com/office/drawing/2014/main" id="{F83CC0D4-B616-DDC3-CD7D-BD36882AC35C}"/>
+              </a:ext>
+            </a:extLst>
+          </p:cNvPr>
+          <p:cNvPicPr>
+            <a:picLocks/>
+          </p:cNvPicPr>
+          <p:nvPr/>
+        </p:nvPicPr>
+        <p:blipFill>
+          <a:blip>
+            <a:extLst>
+              <a:ext uri="{96DAC541-7B7A-43D3-8B79-37D633B846F1}">
+                <asvg:svgBlip xmlns:asvg="http://schemas.microsoft.com/office/drawing/2016/SVG/main" r:embed="rId2"/>
+              </a:ext>
+            </a:extLst>
+          </a:blip>
+          <a:stretch>
+            <a:fillRect/>
+          </a:stretch>
+        </p:blipFill>
+        <p:spPr>
+          <a:xfrm>
+            <a:off x="914400" y="914400"/>
+            <a:ext cx="3657600" cy="2743200"/>
+          </a:xfrm>
+          <a:prstGeom prst="rect">
+            <a:avLst/>
+          </a:prstGeom>
+        </p:spPr>
+      </p:pic>
+    </p:spTree>
+    <p:extLst>
+      <p:ext uri="{BB962C8B-B14F-4D97-AF65-F5344CB8AC3E}">
+        <p14:creationId xmlns:p14="http://schemas.microsoft.com/office/powerpoint/2010/main" val="2051564055"/>
       </p:ext>
     </p:extLst>
   </p:cSld>

</xml_diff>